<commit_message>
Show full 2027 product lineup on Rock 2 slide
Co-Authored-By: Claude Opus 5.5 <noreply@anthropic.com>
Claude-Session: https://claude.ai/code/session_01TQevHxB1x7vFaQYb7c58XF
</commit_message>
<xml_diff>
--- a/OA_Q2_Sales_Rock_Recap_Refined.pptx
+++ b/OA_Q2_Sales_Rock_Recap_Refined.pptx
@@ -114,13 +114,13 @@
   <p:extLst>
     <p:ext uri="{521415D9-36F7-43E2-AB2F-B90AF26B5E84}">
       <p14:sectionLst xmlns:p14="http://schemas.microsoft.com/office/powerpoint/2010/main">
-        <p14:section name="Overview" id="{c01d04a1-a123-9b83-c0cc-0d94bd407a0a}">
+        <p14:section name="Overview" id="{70c46522-9495-e618-28cf-c8dac2f4bced}">
           <p14:sldIdLst>
             <p14:sldId id="256"/>
             <p14:sldId id="257"/>
           </p14:sldIdLst>
         </p14:section>
-        <p14:section name="Rocks" id="{ad4f39d8-b608-dfcd-3d9e-5341bba5c85c}">
+        <p14:section name="Rocks" id="{df6766dc-6615-ba26-e8d1-3084741bae69}">
           <p14:sldIdLst>
             <p14:sldId id="258"/>
             <p14:sldId id="259"/>
@@ -128,7 +128,7 @@
             <p14:sldId id="261"/>
           </p14:sldIdLst>
         </p14:section>
-        <p14:section name="Next quarter" id="{d1398325-f8f1-ca77-4c79-bd7266221972}">
+        <p14:section name="Next quarter" id="{e168d3e7-d88e-b6b6-510e-35fa3c6698d3}">
           <p14:sldIdLst>
             <p14:sldId id="262"/>
             <p14:sldId id="263"/>
@@ -626,7 +626,7 @@
           <a:p>
             <a:r>
               <a:rPr lang="en-US" dirty="0"/>
-              <a:t>Four numbers tell the story. 12 sales in September from the new flexible products. One previously lost client won back through reactivation. Three products market-ready, hitting the target of 3. And we now know the three reasons leads say no.</a:t>
+              <a:t>Four numbers tell the story. 12 sales in September from the new flexible products. One previously lost client won back through reactivation. We now have 10 ways to buy, up from one core VA offer: the 8-step 2027 product ladder plus OAX100 and the Fractional Partners. And we now know the three reasons leads say no.</a:t>
             </a:r>
             <a:endParaRPr lang="en-US" dirty="0"/>
           </a:p>
@@ -890,7 +890,7 @@
           <a:p>
             <a:r>
               <a:rPr lang="en-US" dirty="0"/>
-              <a:t>Ms Linh set the product vision: the 2027 product ladder, OAX100 and Fractional Marketing Partners. Sales built the pitch and led calls with flexible options instead of one fixed package. Prospects who used to walk away because one package did not fit now find one that does, which gives us new entry points and upgrade paths.</a:t>
+              <a:t>Ms Linh set the product vision: the 2027 product ladder of 8 products from Plan to Scale, plus OAX100 (upcoming) and the Fractional Partners for Marketing and AI. That is 10 ways to buy, up from one core VA offer. Every client starts with the $500 Freedom Plan, which is credited in full toward whichever product they choose next. Sales built the pitch and led calls with flexible options instead of one fixed package. Prospects who used to walk away because one package did not fit now find one that does, which gives us new entry points and upgrade paths.</a:t>
             </a:r>
             <a:endParaRPr lang="en-US" dirty="0"/>
           </a:p>
@@ -2730,7 +2730,7 @@
                   <a:schemeClr val="accent1"/>
                 </a:solidFill>
               </a:rPr>
-              <a:t>3</a:t>
+              <a:t>10</a:t>
             </a:r>
             <a:endParaRPr lang="en-US" sz="4400" dirty="0"/>
           </a:p>
@@ -2766,7 +2766,7 @@
                   <a:schemeClr val="tx1"/>
                 </a:solidFill>
               </a:rPr>
-              <a:t>Products ready to sell</a:t>
+              <a:t>Ways to buy</a:t>
             </a:r>
             <a:endParaRPr lang="en-US" sz="1200" dirty="0"/>
           </a:p>
@@ -2802,7 +2802,7 @@
                   <a:schemeClr val="accent3"/>
                 </a:solidFill>
               </a:rPr>
-              <a:t>Target was 3: hit</a:t>
+              <a:t>Up from 1 core VA offer</a:t>
             </a:r>
             <a:endParaRPr lang="en-US" sz="1000" dirty="0"/>
           </a:p>
@@ -3741,7 +3741,7 @@
                   <a:schemeClr val="tx1"/>
                 </a:solidFill>
               </a:rPr>
-              <a:t>3 new products live. 12 sales in September</a:t>
+              <a:t>10 ways to buy across the client journey. 12 sales in Sept</a:t>
             </a:r>
             <a:endParaRPr lang="en-US" sz="1100" dirty="0"/>
           </a:p>
@@ -4998,11 +4998,11 @@
         <p:spPr>
           <a:xfrm>
             <a:off x="457200" y="1371600"/>
-            <a:ext cx="2743200" cy="2148840"/>
+            <a:ext cx="2103120" cy="2240280"/>
           </a:xfrm>
           <a:prstGeom prst="roundRect">
             <a:avLst>
-              <a:gd name="adj" fmla="val 3404"/>
+              <a:gd name="adj" fmla="val 3478"/>
             </a:avLst>
           </a:prstGeom>
           <a:solidFill>
@@ -5019,8 +5019,8 @@
         </p:nvSpPr>
         <p:spPr>
           <a:xfrm>
-            <a:off x="685800" y="1463040"/>
-            <a:ext cx="2286000" cy="1097280"/>
+            <a:off x="658368" y="1463040"/>
+            <a:ext cx="1737360" cy="914400"/>
           </a:xfrm>
           <a:prstGeom prst="rect">
             <a:avLst/>
@@ -5036,14 +5036,14 @@
               <a:buNone/>
             </a:pPr>
             <a:r>
-              <a:rPr lang="en-US" sz="7200" b="1" dirty="0">
+              <a:rPr lang="en-US" sz="6000" b="1" dirty="0">
                 <a:solidFill>
                   <a:schemeClr val="bg1"/>
                 </a:solidFill>
               </a:rPr>
               <a:t>12</a:t>
             </a:r>
-            <a:endParaRPr lang="en-US" sz="7200" dirty="0"/>
+            <a:endParaRPr lang="en-US" sz="6000" dirty="0"/>
           </a:p>
         </p:txBody>
       </p:sp>
@@ -5055,8 +5055,8 @@
         </p:nvSpPr>
         <p:spPr>
           <a:xfrm>
-            <a:off x="685800" y="2560320"/>
-            <a:ext cx="2331720" cy="777240"/>
+            <a:off x="658368" y="2377440"/>
+            <a:ext cx="1737360" cy="457200"/>
           </a:xfrm>
           <a:prstGeom prst="rect">
             <a:avLst/>
@@ -5077,7 +5077,7 @@
                   <a:schemeClr val="bg1"/>
                 </a:solidFill>
               </a:rPr>
-              <a:t>sales in September from the new flexible products</a:t>
+              <a:t>sales in September</a:t>
             </a:r>
             <a:endParaRPr lang="en-US" sz="1300" dirty="0"/>
           </a:p>
@@ -5091,8 +5091,44 @@
         </p:nvSpPr>
         <p:spPr>
           <a:xfrm>
-            <a:off x="3520440" y="1371600"/>
-            <a:ext cx="2743200" cy="228600"/>
+            <a:off x="658368" y="2834640"/>
+            <a:ext cx="1737360" cy="640080"/>
+          </a:xfrm>
+          <a:prstGeom prst="rect">
+            <a:avLst/>
+          </a:prstGeom>
+          <a:noFill/>
+          <a:ln/>
+        </p:spPr>
+        <p:txBody>
+          <a:bodyPr wrap="square" lIns="0" tIns="0" rIns="0" bIns="0" rtlCol="0" anchor="t"/>
+          <a:lstStyle/>
+          <a:p>
+            <a:pPr indent="0" marL="0">
+              <a:buNone/>
+            </a:pPr>
+            <a:r>
+              <a:rPr lang="en-US" sz="1100" i="1" dirty="0">
+                <a:solidFill>
+                  <a:schemeClr val="bg1"/>
+                </a:solidFill>
+              </a:rPr>
+              <a:t>“Not quite right for us” became “yes”</a:t>
+            </a:r>
+            <a:endParaRPr lang="en-US" sz="1100" dirty="0"/>
+          </a:p>
+        </p:txBody>
+      </p:sp>
+      <p:sp>
+        <p:nvSpPr>
+          <p:cNvPr id="9" name="Text 6"/>
+          <p:cNvSpPr txBox="1"/>
+          <p:nvPr/>
+        </p:nvSpPr>
+        <p:spPr>
+          <a:xfrm>
+            <a:off x="2788920" y="1325880"/>
+            <a:ext cx="5897880" cy="228600"/>
           </a:xfrm>
           <a:prstGeom prst="rect">
             <a:avLst/>
@@ -5113,7 +5149,7 @@
                   <a:schemeClr val="accent5"/>
                 </a:solidFill>
               </a:rPr>
-              <a:t>WHAT CHANGED</a:t>
+              <a:t>10 WAYS TO BUY, ONE CLIENT JOURNEY</a:t>
             </a:r>
             <a:endParaRPr lang="en-US" sz="1000" dirty="0"/>
           </a:p>
@@ -5121,68 +5157,212 @@
       </p:sp>
       <p:sp>
         <p:nvSpPr>
-          <p:cNvPr id="9" name="Text 6"/>
-          <p:cNvSpPr txBox="1"/>
-          <p:nvPr/>
-        </p:nvSpPr>
-        <p:spPr>
-          <a:xfrm>
-            <a:off x="3520440" y="1645920"/>
-            <a:ext cx="5120640" cy="685800"/>
-          </a:xfrm>
-          <a:prstGeom prst="rect">
-            <a:avLst/>
-          </a:prstGeom>
-          <a:noFill/>
-          <a:ln/>
-        </p:spPr>
-        <p:txBody>
-          <a:bodyPr wrap="square" lIns="0" tIns="0" rIns="0" bIns="0" rtlCol="0" anchor="t"/>
-          <a:lstStyle/>
-          <a:p>
-            <a:pPr indent="0" marL="0">
-              <a:buNone/>
-            </a:pPr>
-            <a:r>
-              <a:rPr lang="en-US" sz="1600" b="1" dirty="0">
-                <a:solidFill>
-                  <a:schemeClr val="accent3"/>
-                </a:solidFill>
-              </a:rPr>
-              <a:t>“Not quite right for us”</a:t>
-            </a:r>
-            <a:endParaRPr lang="en-US" sz="1600" dirty="0"/>
-          </a:p>
-          <a:p>
-            <a:pPr indent="0" marL="0">
-              <a:buNone/>
-            </a:pPr>
-            <a:r>
-              <a:rPr lang="en-US" sz="1600" b="1" dirty="0">
-                <a:solidFill>
-                  <a:schemeClr val="tx1"/>
-                </a:solidFill>
-              </a:rPr>
-              <a:t>became “Yes”</a:t>
-            </a:r>
-            <a:endParaRPr lang="en-US" sz="1600" dirty="0"/>
-          </a:p>
-        </p:txBody>
-      </p:sp>
-      <p:sp>
-        <p:nvSpPr>
-          <p:cNvPr id="10" name="product 1"/>
+          <p:cNvPr id="10" name="stage PLAN"/>
           <p:cNvSpPr/>
           <p:nvPr/>
         </p:nvSpPr>
         <p:spPr>
           <a:xfrm>
-            <a:off x="3520440" y="2514600"/>
-            <a:ext cx="1600200" cy="1005840"/>
+            <a:off x="2788920" y="1600200"/>
+            <a:ext cx="1106424" cy="274320"/>
           </a:xfrm>
           <a:prstGeom prst="roundRect">
             <a:avLst>
-              <a:gd name="adj" fmla="val 7273"/>
+              <a:gd name="adj" fmla="val 50000"/>
+            </a:avLst>
+          </a:prstGeom>
+          <a:solidFill>
+            <a:schemeClr val="accent5"/>
+          </a:solidFill>
+          <a:ln/>
+        </p:spPr>
+      </p:sp>
+      <p:sp>
+        <p:nvSpPr>
+          <p:cNvPr id="11" name="Text 8"/>
+          <p:cNvSpPr txBox="1"/>
+          <p:nvPr/>
+        </p:nvSpPr>
+        <p:spPr>
+          <a:xfrm>
+            <a:off x="2788920" y="1600200"/>
+            <a:ext cx="1106424" cy="274320"/>
+          </a:xfrm>
+          <a:prstGeom prst="rect">
+            <a:avLst/>
+          </a:prstGeom>
+          <a:noFill/>
+          <a:ln/>
+        </p:spPr>
+        <p:txBody>
+          <a:bodyPr wrap="square" lIns="0" tIns="0" rIns="0" bIns="0" rtlCol="0" anchor="ctr"/>
+          <a:lstStyle/>
+          <a:p>
+            <a:pPr algn="ctr" indent="0" marL="0">
+              <a:buNone/>
+            </a:pPr>
+            <a:r>
+              <a:rPr lang="en-US" sz="900" b="1" spc="100" kern="0" dirty="0">
+                <a:solidFill>
+                  <a:schemeClr val="bg1"/>
+                </a:solidFill>
+              </a:rPr>
+              <a:t>PLAN</a:t>
+            </a:r>
+            <a:endParaRPr lang="en-US" sz="900" dirty="0"/>
+          </a:p>
+        </p:txBody>
+      </p:sp>
+      <p:sp>
+        <p:nvSpPr>
+          <p:cNvPr id="12" name="product Freedom Plan"/>
+          <p:cNvSpPr/>
+          <p:nvPr/>
+        </p:nvSpPr>
+        <p:spPr>
+          <a:xfrm>
+            <a:off x="2788920" y="1947672"/>
+            <a:ext cx="1106424" cy="493776"/>
+          </a:xfrm>
+          <a:prstGeom prst="roundRect">
+            <a:avLst>
+              <a:gd name="adj" fmla="val 14815"/>
+            </a:avLst>
+          </a:prstGeom>
+          <a:solidFill>
+            <a:schemeClr val="accent1"/>
+          </a:solidFill>
+          <a:ln/>
+        </p:spPr>
+      </p:sp>
+      <p:sp>
+        <p:nvSpPr>
+          <p:cNvPr id="13" name="Text 10"/>
+          <p:cNvSpPr txBox="1"/>
+          <p:nvPr/>
+        </p:nvSpPr>
+        <p:spPr>
+          <a:xfrm>
+            <a:off x="2862072" y="1947672"/>
+            <a:ext cx="996696" cy="493776"/>
+          </a:xfrm>
+          <a:prstGeom prst="rect">
+            <a:avLst/>
+          </a:prstGeom>
+          <a:noFill/>
+          <a:ln/>
+        </p:spPr>
+        <p:txBody>
+          <a:bodyPr wrap="square" lIns="0" tIns="0" rIns="0" bIns="0" rtlCol="0" anchor="ctr"/>
+          <a:lstStyle/>
+          <a:p>
+            <a:pPr indent="0" marL="0">
+              <a:lnSpc>
+                <a:spcPct val="95000"/>
+              </a:lnSpc>
+              <a:buNone/>
+            </a:pPr>
+            <a:r>
+              <a:rPr lang="en-US" sz="1000" b="1" dirty="0">
+                <a:solidFill>
+                  <a:schemeClr val="bg1"/>
+                </a:solidFill>
+              </a:rPr>
+              <a:t>Freedom Plan</a:t>
+            </a:r>
+            <a:endParaRPr lang="en-US" sz="1000" dirty="0"/>
+          </a:p>
+          <a:p>
+            <a:pPr indent="0" marL="0">
+              <a:lnSpc>
+                <a:spcPct val="95000"/>
+              </a:lnSpc>
+              <a:buNone/>
+            </a:pPr>
+            <a:r>
+              <a:rPr lang="en-US" sz="900" b="1" dirty="0">
+                <a:solidFill>
+                  <a:schemeClr val="bg1"/>
+                </a:solidFill>
+              </a:rPr>
+              <a:t>Start here: $500</a:t>
+            </a:r>
+            <a:endParaRPr lang="en-US" sz="1000" dirty="0"/>
+          </a:p>
+        </p:txBody>
+      </p:sp>
+      <p:sp>
+        <p:nvSpPr>
+          <p:cNvPr id="14" name="stage HIRE"/>
+          <p:cNvSpPr/>
+          <p:nvPr/>
+        </p:nvSpPr>
+        <p:spPr>
+          <a:xfrm>
+            <a:off x="3986784" y="1600200"/>
+            <a:ext cx="1106424" cy="274320"/>
+          </a:xfrm>
+          <a:prstGeom prst="roundRect">
+            <a:avLst>
+              <a:gd name="adj" fmla="val 50000"/>
+            </a:avLst>
+          </a:prstGeom>
+          <a:solidFill>
+            <a:schemeClr val="accent5"/>
+          </a:solidFill>
+          <a:ln/>
+        </p:spPr>
+      </p:sp>
+      <p:sp>
+        <p:nvSpPr>
+          <p:cNvPr id="15" name="Text 12"/>
+          <p:cNvSpPr txBox="1"/>
+          <p:nvPr/>
+        </p:nvSpPr>
+        <p:spPr>
+          <a:xfrm>
+            <a:off x="3986784" y="1600200"/>
+            <a:ext cx="1106424" cy="274320"/>
+          </a:xfrm>
+          <a:prstGeom prst="rect">
+            <a:avLst/>
+          </a:prstGeom>
+          <a:noFill/>
+          <a:ln/>
+        </p:spPr>
+        <p:txBody>
+          <a:bodyPr wrap="square" lIns="0" tIns="0" rIns="0" bIns="0" rtlCol="0" anchor="ctr"/>
+          <a:lstStyle/>
+          <a:p>
+            <a:pPr algn="ctr" indent="0" marL="0">
+              <a:buNone/>
+            </a:pPr>
+            <a:r>
+              <a:rPr lang="en-US" sz="900" b="1" spc="100" kern="0" dirty="0">
+                <a:solidFill>
+                  <a:schemeClr val="bg1"/>
+                </a:solidFill>
+              </a:rPr>
+              <a:t>HIRE</a:t>
+            </a:r>
+            <a:endParaRPr lang="en-US" sz="900" dirty="0"/>
+          </a:p>
+        </p:txBody>
+      </p:sp>
+      <p:sp>
+        <p:nvSpPr>
+          <p:cNvPr id="16" name="product Angel Match"/>
+          <p:cNvSpPr/>
+          <p:nvPr/>
+        </p:nvSpPr>
+        <p:spPr>
+          <a:xfrm>
+            <a:off x="3986784" y="1947672"/>
+            <a:ext cx="1106424" cy="493776"/>
+          </a:xfrm>
+          <a:prstGeom prst="roundRect">
+            <a:avLst>
+              <a:gd name="adj" fmla="val 14815"/>
             </a:avLst>
           </a:prstGeom>
           <a:solidFill>
@@ -5193,17 +5373,58 @@
       </p:sp>
       <p:sp>
         <p:nvSpPr>
-          <p:cNvPr id="11" name="product tick 1 circle"/>
+          <p:cNvPr id="17" name="Text 14"/>
+          <p:cNvSpPr txBox="1"/>
+          <p:nvPr/>
+        </p:nvSpPr>
+        <p:spPr>
+          <a:xfrm>
+            <a:off x="4059936" y="1947672"/>
+            <a:ext cx="996696" cy="493776"/>
+          </a:xfrm>
+          <a:prstGeom prst="rect">
+            <a:avLst/>
+          </a:prstGeom>
+          <a:noFill/>
+          <a:ln/>
+        </p:spPr>
+        <p:txBody>
+          <a:bodyPr wrap="square" lIns="0" tIns="0" rIns="0" bIns="0" rtlCol="0" anchor="ctr"/>
+          <a:lstStyle/>
+          <a:p>
+            <a:pPr indent="0" marL="0">
+              <a:lnSpc>
+                <a:spcPct val="95000"/>
+              </a:lnSpc>
+              <a:buNone/>
+            </a:pPr>
+            <a:r>
+              <a:rPr lang="en-US" sz="1000" b="1" dirty="0">
+                <a:solidFill>
+                  <a:schemeClr val="tx1"/>
+                </a:solidFill>
+              </a:rPr>
+              <a:t>Angel Match</a:t>
+            </a:r>
+            <a:endParaRPr lang="en-US" sz="1000" dirty="0"/>
+          </a:p>
+        </p:txBody>
+      </p:sp>
+      <p:sp>
+        <p:nvSpPr>
+          <p:cNvPr id="18" name="stage MANAGE"/>
           <p:cNvSpPr/>
           <p:nvPr/>
         </p:nvSpPr>
         <p:spPr>
           <a:xfrm>
-            <a:off x="3657600" y="2651760"/>
-            <a:ext cx="310896" cy="310896"/>
-          </a:xfrm>
-          <a:prstGeom prst="ellipse">
-            <a:avLst/>
+            <a:off x="5184648" y="1600200"/>
+            <a:ext cx="1106424" cy="274320"/>
+          </a:xfrm>
+          <a:prstGeom prst="roundRect">
+            <a:avLst>
+              <a:gd name="adj" fmla="val 50000"/>
+            </a:avLst>
           </a:prstGeom>
           <a:solidFill>
             <a:schemeClr val="accent5"/>
@@ -5211,9 +5432,749 @@
           <a:ln/>
         </p:spPr>
       </p:sp>
+      <p:sp>
+        <p:nvSpPr>
+          <p:cNvPr id="19" name="Text 16"/>
+          <p:cNvSpPr txBox="1"/>
+          <p:nvPr/>
+        </p:nvSpPr>
+        <p:spPr>
+          <a:xfrm>
+            <a:off x="5184648" y="1600200"/>
+            <a:ext cx="1106424" cy="274320"/>
+          </a:xfrm>
+          <a:prstGeom prst="rect">
+            <a:avLst/>
+          </a:prstGeom>
+          <a:noFill/>
+          <a:ln/>
+        </p:spPr>
+        <p:txBody>
+          <a:bodyPr wrap="square" lIns="0" tIns="0" rIns="0" bIns="0" rtlCol="0" anchor="ctr"/>
+          <a:lstStyle/>
+          <a:p>
+            <a:pPr algn="ctr" indent="0" marL="0">
+              <a:buNone/>
+            </a:pPr>
+            <a:r>
+              <a:rPr lang="en-US" sz="900" b="1" spc="100" kern="0" dirty="0">
+                <a:solidFill>
+                  <a:schemeClr val="bg1"/>
+                </a:solidFill>
+              </a:rPr>
+              <a:t>MANAGE</a:t>
+            </a:r>
+            <a:endParaRPr lang="en-US" sz="900" dirty="0"/>
+          </a:p>
+        </p:txBody>
+      </p:sp>
+      <p:sp>
+        <p:nvSpPr>
+          <p:cNvPr id="20" name="product Angel Essentials"/>
+          <p:cNvSpPr/>
+          <p:nvPr/>
+        </p:nvSpPr>
+        <p:spPr>
+          <a:xfrm>
+            <a:off x="5184648" y="1947672"/>
+            <a:ext cx="1106424" cy="493776"/>
+          </a:xfrm>
+          <a:prstGeom prst="roundRect">
+            <a:avLst>
+              <a:gd name="adj" fmla="val 14815"/>
+            </a:avLst>
+          </a:prstGeom>
+          <a:solidFill>
+            <a:schemeClr val="bg2"/>
+          </a:solidFill>
+          <a:ln/>
+        </p:spPr>
+      </p:sp>
+      <p:sp>
+        <p:nvSpPr>
+          <p:cNvPr id="21" name="Text 18"/>
+          <p:cNvSpPr txBox="1"/>
+          <p:nvPr/>
+        </p:nvSpPr>
+        <p:spPr>
+          <a:xfrm>
+            <a:off x="5257800" y="1947672"/>
+            <a:ext cx="996696" cy="493776"/>
+          </a:xfrm>
+          <a:prstGeom prst="rect">
+            <a:avLst/>
+          </a:prstGeom>
+          <a:noFill/>
+          <a:ln/>
+        </p:spPr>
+        <p:txBody>
+          <a:bodyPr wrap="square" lIns="0" tIns="0" rIns="0" bIns="0" rtlCol="0" anchor="ctr"/>
+          <a:lstStyle/>
+          <a:p>
+            <a:pPr indent="0" marL="0">
+              <a:lnSpc>
+                <a:spcPct val="95000"/>
+              </a:lnSpc>
+              <a:buNone/>
+            </a:pPr>
+            <a:r>
+              <a:rPr lang="en-US" sz="1000" b="1" dirty="0">
+                <a:solidFill>
+                  <a:schemeClr val="tx1"/>
+                </a:solidFill>
+              </a:rPr>
+              <a:t>Angel Essentials</a:t>
+            </a:r>
+            <a:endParaRPr lang="en-US" sz="1000" dirty="0"/>
+          </a:p>
+          <a:p>
+            <a:pPr indent="0" marL="0">
+              <a:lnSpc>
+                <a:spcPct val="95000"/>
+              </a:lnSpc>
+              <a:buNone/>
+            </a:pPr>
+            <a:r>
+              <a:rPr lang="en-US" sz="900" b="1" dirty="0">
+                <a:solidFill>
+                  <a:schemeClr val="accent5"/>
+                </a:solidFill>
+              </a:rPr>
+              <a:t>Pilot</a:t>
+            </a:r>
+            <a:endParaRPr lang="en-US" sz="1000" dirty="0"/>
+          </a:p>
+        </p:txBody>
+      </p:sp>
+      <p:sp>
+        <p:nvSpPr>
+          <p:cNvPr id="22" name="product Angel Managed"/>
+          <p:cNvSpPr/>
+          <p:nvPr/>
+        </p:nvSpPr>
+        <p:spPr>
+          <a:xfrm>
+            <a:off x="5184648" y="2514600"/>
+            <a:ext cx="1106424" cy="493776"/>
+          </a:xfrm>
+          <a:prstGeom prst="roundRect">
+            <a:avLst>
+              <a:gd name="adj" fmla="val 14815"/>
+            </a:avLst>
+          </a:prstGeom>
+          <a:solidFill>
+            <a:schemeClr val="bg2"/>
+          </a:solidFill>
+          <a:ln/>
+        </p:spPr>
+      </p:sp>
+      <p:sp>
+        <p:nvSpPr>
+          <p:cNvPr id="23" name="Text 20"/>
+          <p:cNvSpPr txBox="1"/>
+          <p:nvPr/>
+        </p:nvSpPr>
+        <p:spPr>
+          <a:xfrm>
+            <a:off x="5257800" y="2514600"/>
+            <a:ext cx="996696" cy="493776"/>
+          </a:xfrm>
+          <a:prstGeom prst="rect">
+            <a:avLst/>
+          </a:prstGeom>
+          <a:noFill/>
+          <a:ln/>
+        </p:spPr>
+        <p:txBody>
+          <a:bodyPr wrap="square" lIns="0" tIns="0" rIns="0" bIns="0" rtlCol="0" anchor="ctr"/>
+          <a:lstStyle/>
+          <a:p>
+            <a:pPr indent="0" marL="0">
+              <a:lnSpc>
+                <a:spcPct val="95000"/>
+              </a:lnSpc>
+              <a:buNone/>
+            </a:pPr>
+            <a:r>
+              <a:rPr lang="en-US" sz="1000" b="1" dirty="0">
+                <a:solidFill>
+                  <a:schemeClr val="tx1"/>
+                </a:solidFill>
+              </a:rPr>
+              <a:t>Angel Managed</a:t>
+            </a:r>
+            <a:endParaRPr lang="en-US" sz="1000" dirty="0"/>
+          </a:p>
+          <a:p>
+            <a:pPr indent="0" marL="0">
+              <a:lnSpc>
+                <a:spcPct val="95000"/>
+              </a:lnSpc>
+              <a:buNone/>
+            </a:pPr>
+            <a:r>
+              <a:rPr lang="en-US" sz="900" b="1" dirty="0">
+                <a:solidFill>
+                  <a:schemeClr val="accent5"/>
+                </a:solidFill>
+              </a:rPr>
+              <a:t>Flagship</a:t>
+            </a:r>
+            <a:endParaRPr lang="en-US" sz="1000" dirty="0"/>
+          </a:p>
+        </p:txBody>
+      </p:sp>
+      <p:sp>
+        <p:nvSpPr>
+          <p:cNvPr id="24" name="stage OPTIMISE"/>
+          <p:cNvSpPr/>
+          <p:nvPr/>
+        </p:nvSpPr>
+        <p:spPr>
+          <a:xfrm>
+            <a:off x="6382512" y="1600200"/>
+            <a:ext cx="1106424" cy="274320"/>
+          </a:xfrm>
+          <a:prstGeom prst="roundRect">
+            <a:avLst>
+              <a:gd name="adj" fmla="val 50000"/>
+            </a:avLst>
+          </a:prstGeom>
+          <a:solidFill>
+            <a:schemeClr val="accent5"/>
+          </a:solidFill>
+          <a:ln/>
+        </p:spPr>
+      </p:sp>
+      <p:sp>
+        <p:nvSpPr>
+          <p:cNvPr id="25" name="Text 22"/>
+          <p:cNvSpPr txBox="1"/>
+          <p:nvPr/>
+        </p:nvSpPr>
+        <p:spPr>
+          <a:xfrm>
+            <a:off x="6382512" y="1600200"/>
+            <a:ext cx="1106424" cy="274320"/>
+          </a:xfrm>
+          <a:prstGeom prst="rect">
+            <a:avLst/>
+          </a:prstGeom>
+          <a:noFill/>
+          <a:ln/>
+        </p:spPr>
+        <p:txBody>
+          <a:bodyPr wrap="square" lIns="0" tIns="0" rIns="0" bIns="0" rtlCol="0" anchor="ctr"/>
+          <a:lstStyle/>
+          <a:p>
+            <a:pPr algn="ctr" indent="0" marL="0">
+              <a:buNone/>
+            </a:pPr>
+            <a:r>
+              <a:rPr lang="en-US" sz="900" b="1" spc="100" kern="0" dirty="0">
+                <a:solidFill>
+                  <a:schemeClr val="bg1"/>
+                </a:solidFill>
+              </a:rPr>
+              <a:t>OPTIMISE</a:t>
+            </a:r>
+            <a:endParaRPr lang="en-US" sz="900" dirty="0"/>
+          </a:p>
+        </p:txBody>
+      </p:sp>
+      <p:sp>
+        <p:nvSpPr>
+          <p:cNvPr id="26" name="product Angel Accelerate"/>
+          <p:cNvSpPr/>
+          <p:nvPr/>
+        </p:nvSpPr>
+        <p:spPr>
+          <a:xfrm>
+            <a:off x="6382512" y="1947672"/>
+            <a:ext cx="1106424" cy="493776"/>
+          </a:xfrm>
+          <a:prstGeom prst="roundRect">
+            <a:avLst>
+              <a:gd name="adj" fmla="val 14815"/>
+            </a:avLst>
+          </a:prstGeom>
+          <a:solidFill>
+            <a:schemeClr val="bg2"/>
+          </a:solidFill>
+          <a:ln/>
+        </p:spPr>
+      </p:sp>
+      <p:sp>
+        <p:nvSpPr>
+          <p:cNvPr id="27" name="Text 24"/>
+          <p:cNvSpPr txBox="1"/>
+          <p:nvPr/>
+        </p:nvSpPr>
+        <p:spPr>
+          <a:xfrm>
+            <a:off x="6455664" y="1947672"/>
+            <a:ext cx="996696" cy="493776"/>
+          </a:xfrm>
+          <a:prstGeom prst="rect">
+            <a:avLst/>
+          </a:prstGeom>
+          <a:noFill/>
+          <a:ln/>
+        </p:spPr>
+        <p:txBody>
+          <a:bodyPr wrap="square" lIns="0" tIns="0" rIns="0" bIns="0" rtlCol="0" anchor="ctr"/>
+          <a:lstStyle/>
+          <a:p>
+            <a:pPr indent="0" marL="0">
+              <a:lnSpc>
+                <a:spcPct val="95000"/>
+              </a:lnSpc>
+              <a:buNone/>
+            </a:pPr>
+            <a:r>
+              <a:rPr lang="en-US" sz="1000" b="1" dirty="0">
+                <a:solidFill>
+                  <a:schemeClr val="tx1"/>
+                </a:solidFill>
+              </a:rPr>
+              <a:t>Angel Accelerate</a:t>
+            </a:r>
+            <a:endParaRPr lang="en-US" sz="1000" dirty="0"/>
+          </a:p>
+        </p:txBody>
+      </p:sp>
+      <p:sp>
+        <p:nvSpPr>
+          <p:cNvPr id="28" name="product Angel Growth"/>
+          <p:cNvSpPr/>
+          <p:nvPr/>
+        </p:nvSpPr>
+        <p:spPr>
+          <a:xfrm>
+            <a:off x="6382512" y="2514600"/>
+            <a:ext cx="1106424" cy="493776"/>
+          </a:xfrm>
+          <a:prstGeom prst="roundRect">
+            <a:avLst>
+              <a:gd name="adj" fmla="val 14815"/>
+            </a:avLst>
+          </a:prstGeom>
+          <a:solidFill>
+            <a:schemeClr val="bg2"/>
+          </a:solidFill>
+          <a:ln/>
+        </p:spPr>
+      </p:sp>
+      <p:sp>
+        <p:nvSpPr>
+          <p:cNvPr id="29" name="Text 26"/>
+          <p:cNvSpPr txBox="1"/>
+          <p:nvPr/>
+        </p:nvSpPr>
+        <p:spPr>
+          <a:xfrm>
+            <a:off x="6455664" y="2514600"/>
+            <a:ext cx="996696" cy="493776"/>
+          </a:xfrm>
+          <a:prstGeom prst="rect">
+            <a:avLst/>
+          </a:prstGeom>
+          <a:noFill/>
+          <a:ln/>
+        </p:spPr>
+        <p:txBody>
+          <a:bodyPr wrap="square" lIns="0" tIns="0" rIns="0" bIns="0" rtlCol="0" anchor="ctr"/>
+          <a:lstStyle/>
+          <a:p>
+            <a:pPr indent="0" marL="0">
+              <a:lnSpc>
+                <a:spcPct val="95000"/>
+              </a:lnSpc>
+              <a:buNone/>
+            </a:pPr>
+            <a:r>
+              <a:rPr lang="en-US" sz="1000" b="1" dirty="0">
+                <a:solidFill>
+                  <a:schemeClr val="tx1"/>
+                </a:solidFill>
+              </a:rPr>
+              <a:t>Angel Growth</a:t>
+            </a:r>
+            <a:endParaRPr lang="en-US" sz="1000" dirty="0"/>
+          </a:p>
+          <a:p>
+            <a:pPr indent="0" marL="0">
+              <a:lnSpc>
+                <a:spcPct val="95000"/>
+              </a:lnSpc>
+              <a:buNone/>
+            </a:pPr>
+            <a:r>
+              <a:rPr lang="en-US" sz="900" b="1" dirty="0">
+                <a:solidFill>
+                  <a:schemeClr val="accent5"/>
+                </a:solidFill>
+              </a:rPr>
+              <a:t>New: + AI</a:t>
+            </a:r>
+            <a:endParaRPr lang="en-US" sz="1000" dirty="0"/>
+          </a:p>
+        </p:txBody>
+      </p:sp>
+      <p:sp>
+        <p:nvSpPr>
+          <p:cNvPr id="30" name="stage SCALE"/>
+          <p:cNvSpPr/>
+          <p:nvPr/>
+        </p:nvSpPr>
+        <p:spPr>
+          <a:xfrm>
+            <a:off x="7580376" y="1600200"/>
+            <a:ext cx="1106424" cy="274320"/>
+          </a:xfrm>
+          <a:prstGeom prst="roundRect">
+            <a:avLst>
+              <a:gd name="adj" fmla="val 50000"/>
+            </a:avLst>
+          </a:prstGeom>
+          <a:solidFill>
+            <a:schemeClr val="accent5"/>
+          </a:solidFill>
+          <a:ln/>
+        </p:spPr>
+      </p:sp>
+      <p:sp>
+        <p:nvSpPr>
+          <p:cNvPr id="31" name="Text 28"/>
+          <p:cNvSpPr txBox="1"/>
+          <p:nvPr/>
+        </p:nvSpPr>
+        <p:spPr>
+          <a:xfrm>
+            <a:off x="7580376" y="1600200"/>
+            <a:ext cx="1106424" cy="274320"/>
+          </a:xfrm>
+          <a:prstGeom prst="rect">
+            <a:avLst/>
+          </a:prstGeom>
+          <a:noFill/>
+          <a:ln/>
+        </p:spPr>
+        <p:txBody>
+          <a:bodyPr wrap="square" lIns="0" tIns="0" rIns="0" bIns="0" rtlCol="0" anchor="ctr"/>
+          <a:lstStyle/>
+          <a:p>
+            <a:pPr algn="ctr" indent="0" marL="0">
+              <a:buNone/>
+            </a:pPr>
+            <a:r>
+              <a:rPr lang="en-US" sz="900" b="1" spc="100" kern="0" dirty="0">
+                <a:solidFill>
+                  <a:schemeClr val="bg1"/>
+                </a:solidFill>
+              </a:rPr>
+              <a:t>SCALE</a:t>
+            </a:r>
+            <a:endParaRPr lang="en-US" sz="900" dirty="0"/>
+          </a:p>
+        </p:txBody>
+      </p:sp>
+      <p:sp>
+        <p:nvSpPr>
+          <p:cNvPr id="32" name="product Angel Teams"/>
+          <p:cNvSpPr/>
+          <p:nvPr/>
+        </p:nvSpPr>
+        <p:spPr>
+          <a:xfrm>
+            <a:off x="7580376" y="1947672"/>
+            <a:ext cx="1106424" cy="493776"/>
+          </a:xfrm>
+          <a:prstGeom prst="roundRect">
+            <a:avLst>
+              <a:gd name="adj" fmla="val 14815"/>
+            </a:avLst>
+          </a:prstGeom>
+          <a:solidFill>
+            <a:schemeClr val="bg2"/>
+          </a:solidFill>
+          <a:ln/>
+        </p:spPr>
+      </p:sp>
+      <p:sp>
+        <p:nvSpPr>
+          <p:cNvPr id="33" name="Text 30"/>
+          <p:cNvSpPr txBox="1"/>
+          <p:nvPr/>
+        </p:nvSpPr>
+        <p:spPr>
+          <a:xfrm>
+            <a:off x="7653528" y="1947672"/>
+            <a:ext cx="996696" cy="493776"/>
+          </a:xfrm>
+          <a:prstGeom prst="rect">
+            <a:avLst/>
+          </a:prstGeom>
+          <a:noFill/>
+          <a:ln/>
+        </p:spPr>
+        <p:txBody>
+          <a:bodyPr wrap="square" lIns="0" tIns="0" rIns="0" bIns="0" rtlCol="0" anchor="ctr"/>
+          <a:lstStyle/>
+          <a:p>
+            <a:pPr indent="0" marL="0">
+              <a:lnSpc>
+                <a:spcPct val="95000"/>
+              </a:lnSpc>
+              <a:buNone/>
+            </a:pPr>
+            <a:r>
+              <a:rPr lang="en-US" sz="1000" b="1" dirty="0">
+                <a:solidFill>
+                  <a:schemeClr val="tx1"/>
+                </a:solidFill>
+              </a:rPr>
+              <a:t>Angel Teams</a:t>
+            </a:r>
+            <a:endParaRPr lang="en-US" sz="1000" dirty="0"/>
+          </a:p>
+        </p:txBody>
+      </p:sp>
+      <p:sp>
+        <p:nvSpPr>
+          <p:cNvPr id="34" name="product Angel Departments"/>
+          <p:cNvSpPr/>
+          <p:nvPr/>
+        </p:nvSpPr>
+        <p:spPr>
+          <a:xfrm>
+            <a:off x="7580376" y="2514600"/>
+            <a:ext cx="1106424" cy="493776"/>
+          </a:xfrm>
+          <a:prstGeom prst="roundRect">
+            <a:avLst>
+              <a:gd name="adj" fmla="val 14815"/>
+            </a:avLst>
+          </a:prstGeom>
+          <a:solidFill>
+            <a:schemeClr val="bg2"/>
+          </a:solidFill>
+          <a:ln/>
+        </p:spPr>
+      </p:sp>
+      <p:sp>
+        <p:nvSpPr>
+          <p:cNvPr id="35" name="Text 32"/>
+          <p:cNvSpPr txBox="1"/>
+          <p:nvPr/>
+        </p:nvSpPr>
+        <p:spPr>
+          <a:xfrm>
+            <a:off x="7653528" y="2514600"/>
+            <a:ext cx="996696" cy="493776"/>
+          </a:xfrm>
+          <a:prstGeom prst="rect">
+            <a:avLst/>
+          </a:prstGeom>
+          <a:noFill/>
+          <a:ln/>
+        </p:spPr>
+        <p:txBody>
+          <a:bodyPr wrap="square" lIns="0" tIns="0" rIns="0" bIns="0" rtlCol="0" anchor="ctr"/>
+          <a:lstStyle/>
+          <a:p>
+            <a:pPr indent="0" marL="0">
+              <a:lnSpc>
+                <a:spcPct val="95000"/>
+              </a:lnSpc>
+              <a:buNone/>
+            </a:pPr>
+            <a:r>
+              <a:rPr lang="en-US" sz="1000" b="1" dirty="0">
+                <a:solidFill>
+                  <a:schemeClr val="tx1"/>
+                </a:solidFill>
+              </a:rPr>
+              <a:t>Angel Departments</a:t>
+            </a:r>
+            <a:endParaRPr lang="en-US" sz="1000" dirty="0"/>
+          </a:p>
+        </p:txBody>
+      </p:sp>
+      <p:sp>
+        <p:nvSpPr>
+          <p:cNvPr id="36" name="plus programs"/>
+          <p:cNvSpPr/>
+          <p:nvPr/>
+        </p:nvSpPr>
+        <p:spPr>
+          <a:xfrm>
+            <a:off x="2788920" y="3127248"/>
+            <a:ext cx="5897880" cy="484632"/>
+          </a:xfrm>
+          <a:prstGeom prst="roundRect">
+            <a:avLst>
+              <a:gd name="adj" fmla="val 15094"/>
+            </a:avLst>
+          </a:prstGeom>
+          <a:solidFill>
+            <a:schemeClr val="accent4"/>
+          </a:solidFill>
+          <a:ln/>
+        </p:spPr>
+      </p:sp>
+      <p:sp>
+        <p:nvSpPr>
+          <p:cNvPr id="37" name="Text 34"/>
+          <p:cNvSpPr txBox="1"/>
+          <p:nvPr/>
+        </p:nvSpPr>
+        <p:spPr>
+          <a:xfrm>
+            <a:off x="2971800" y="3127248"/>
+            <a:ext cx="5623560" cy="484632"/>
+          </a:xfrm>
+          <a:prstGeom prst="rect">
+            <a:avLst/>
+          </a:prstGeom>
+          <a:noFill/>
+          <a:ln/>
+        </p:spPr>
+        <p:txBody>
+          <a:bodyPr wrap="square" lIns="0" tIns="0" rIns="0" bIns="0" rtlCol="0" anchor="ctr"/>
+          <a:lstStyle/>
+          <a:p>
+            <a:pPr indent="0" marL="0">
+              <a:buNone/>
+            </a:pPr>
+            <a:r>
+              <a:rPr lang="en-US" sz="1000" b="1" spc="100" kern="0" dirty="0">
+                <a:solidFill>
+                  <a:schemeClr val="accent5"/>
+                </a:solidFill>
+              </a:rPr>
+              <a:t>PLUS   </a:t>
+            </a:r>
+            <a:pPr indent="0" marL="0">
+              <a:buNone/>
+            </a:pPr>
+            <a:r>
+              <a:rPr lang="en-US" sz="1100" b="1" dirty="0">
+                <a:solidFill>
+                  <a:schemeClr val="tx1"/>
+                </a:solidFill>
+              </a:rPr>
+              <a:t>OAX100 Marketing</a:t>
+            </a:r>
+            <a:pPr indent="0" marL="0">
+              <a:buNone/>
+            </a:pPr>
+            <a:r>
+              <a:rPr lang="en-US" sz="1100" dirty="0">
+                <a:solidFill>
+                  <a:schemeClr val="accent3"/>
+                </a:solidFill>
+              </a:rPr>
+              <a:t> (upcoming)</a:t>
+            </a:r>
+            <a:pPr indent="0" marL="0">
+              <a:buNone/>
+            </a:pPr>
+            <a:r>
+              <a:rPr lang="en-US" sz="1100" dirty="0">
+                <a:solidFill>
+                  <a:schemeClr val="accent3"/>
+                </a:solidFill>
+              </a:rPr>
+              <a:t>   ·   </a:t>
+            </a:r>
+            <a:pPr indent="0" marL="0">
+              <a:buNone/>
+            </a:pPr>
+            <a:r>
+              <a:rPr lang="en-US" sz="1100" b="1" dirty="0">
+                <a:solidFill>
+                  <a:schemeClr val="tx1"/>
+                </a:solidFill>
+              </a:rPr>
+              <a:t>Fractional Partners</a:t>
+            </a:r>
+            <a:pPr indent="0" marL="0">
+              <a:buNone/>
+            </a:pPr>
+            <a:r>
+              <a:rPr lang="en-US" sz="1100" dirty="0">
+                <a:solidFill>
+                  <a:schemeClr val="accent3"/>
+                </a:solidFill>
+              </a:rPr>
+              <a:t> (Marketing + AI)</a:t>
+            </a:r>
+            <a:endParaRPr lang="en-US" sz="1000" dirty="0"/>
+          </a:p>
+        </p:txBody>
+      </p:sp>
+      <p:sp>
+        <p:nvSpPr>
+          <p:cNvPr id="38" name="Text 35"/>
+          <p:cNvSpPr txBox="1"/>
+          <p:nvPr/>
+        </p:nvSpPr>
+        <p:spPr>
+          <a:xfrm>
+            <a:off x="457200" y="3794760"/>
+            <a:ext cx="2743200" cy="228600"/>
+          </a:xfrm>
+          <a:prstGeom prst="rect">
+            <a:avLst/>
+          </a:prstGeom>
+          <a:noFill/>
+          <a:ln/>
+        </p:spPr>
+        <p:txBody>
+          <a:bodyPr wrap="square" lIns="0" tIns="0" rIns="0" bIns="0" rtlCol="0" anchor="ctr"/>
+          <a:lstStyle/>
+          <a:p>
+            <a:pPr indent="0" marL="0">
+              <a:buNone/>
+            </a:pPr>
+            <a:r>
+              <a:rPr lang="en-US" sz="1000" b="1" spc="100" kern="0" dirty="0">
+                <a:solidFill>
+                  <a:schemeClr val="accent5"/>
+                </a:solidFill>
+              </a:rPr>
+              <a:t>NEXT QUARTER</a:t>
+            </a:r>
+            <a:endParaRPr lang="en-US" sz="1000" dirty="0"/>
+          </a:p>
+        </p:txBody>
+      </p:sp>
+      <p:sp>
+        <p:nvSpPr>
+          <p:cNvPr id="39" name="next step 1"/>
+          <p:cNvSpPr/>
+          <p:nvPr/>
+        </p:nvSpPr>
+        <p:spPr>
+          <a:xfrm>
+            <a:off x="457200" y="4069080"/>
+            <a:ext cx="4000500" cy="548640"/>
+          </a:xfrm>
+          <a:prstGeom prst="roundRect">
+            <a:avLst>
+              <a:gd name="adj" fmla="val 13333"/>
+            </a:avLst>
+          </a:prstGeom>
+          <a:solidFill>
+            <a:schemeClr val="accent4"/>
+          </a:solidFill>
+          <a:ln/>
+        </p:spPr>
+      </p:sp>
       <p:pic>
         <p:nvPicPr>
-          <p:cNvPr id="12" name="product tick 1" descr="product tick 1">    </p:cNvPr>
+          <p:cNvPr id="40" name="next arrow 1" descr="next">    </p:cNvPr>
           <p:cNvPicPr>
             <a:picLocks noChangeAspect="1"/>
           </p:cNvPicPr>
@@ -5227,8 +6188,8 @@
         </p:blipFill>
         <p:spPr>
           <a:xfrm>
-            <a:off x="3735324" y="2729484"/>
-            <a:ext cx="155448" cy="155448"/>
+            <a:off x="621792" y="4233672"/>
+            <a:ext cx="219456" cy="219456"/>
           </a:xfrm>
           <a:prstGeom prst="rect">
             <a:avLst/>
@@ -5237,23 +6198,23 @@
       </p:pic>
       <p:sp>
         <p:nvSpPr>
-          <p:cNvPr id="13" name="Text 9"/>
-          <p:cNvSpPr txBox="1"/>
-          <p:nvPr/>
-        </p:nvSpPr>
-        <p:spPr>
-          <a:xfrm>
-            <a:off x="3657600" y="2999232"/>
-            <a:ext cx="1371600" cy="457200"/>
-          </a:xfrm>
-          <a:prstGeom prst="rect">
-            <a:avLst/>
-          </a:prstGeom>
-          <a:noFill/>
-          <a:ln/>
-        </p:spPr>
-        <p:txBody>
-          <a:bodyPr wrap="square" lIns="0" tIns="0" rIns="0" bIns="0" rtlCol="0" anchor="t"/>
+          <p:cNvPr id="41" name="Text 37"/>
+          <p:cNvSpPr txBox="1"/>
+          <p:nvPr/>
+        </p:nvSpPr>
+        <p:spPr>
+          <a:xfrm>
+            <a:off x="960120" y="4069080"/>
+            <a:ext cx="3360420" cy="548640"/>
+          </a:xfrm>
+          <a:prstGeom prst="rect">
+            <a:avLst/>
+          </a:prstGeom>
+          <a:noFill/>
+          <a:ln/>
+        </p:spPr>
+        <p:txBody>
+          <a:bodyPr wrap="square" lIns="0" tIns="0" rIns="0" bIns="0" rtlCol="0" anchor="ctr"/>
           <a:lstStyle/>
           <a:p>
             <a:pPr indent="0" marL="0">
@@ -5265,7 +6226,7 @@
                   <a:schemeClr val="tx1"/>
                 </a:solidFill>
               </a:rPr>
-              <a:t>2027 Product Ladder</a:t>
+              <a:t>Lead every qualified call with the $500 Freedom Plan</a:t>
             </a:r>
             <a:endParaRPr lang="en-US" sz="1100" dirty="0"/>
           </a:p>
@@ -5273,49 +6234,29 @@
       </p:sp>
       <p:sp>
         <p:nvSpPr>
-          <p:cNvPr id="14" name="product 2"/>
+          <p:cNvPr id="42" name="next step 2"/>
           <p:cNvSpPr/>
           <p:nvPr/>
         </p:nvSpPr>
         <p:spPr>
           <a:xfrm>
-            <a:off x="5303520" y="2514600"/>
-            <a:ext cx="1600200" cy="1005840"/>
+            <a:off x="4686300" y="4069080"/>
+            <a:ext cx="4000500" cy="548640"/>
           </a:xfrm>
           <a:prstGeom prst="roundRect">
             <a:avLst>
-              <a:gd name="adj" fmla="val 7273"/>
+              <a:gd name="adj" fmla="val 13333"/>
             </a:avLst>
           </a:prstGeom>
           <a:solidFill>
-            <a:schemeClr val="bg2"/>
-          </a:solidFill>
-          <a:ln/>
-        </p:spPr>
-      </p:sp>
-      <p:sp>
-        <p:nvSpPr>
-          <p:cNvPr id="15" name="product tick 2 circle"/>
-          <p:cNvSpPr/>
-          <p:nvPr/>
-        </p:nvSpPr>
-        <p:spPr>
-          <a:xfrm>
-            <a:off x="5440680" y="2651760"/>
-            <a:ext cx="310896" cy="310896"/>
-          </a:xfrm>
-          <a:prstGeom prst="ellipse">
-            <a:avLst/>
-          </a:prstGeom>
-          <a:solidFill>
-            <a:schemeClr val="accent5"/>
+            <a:schemeClr val="accent4"/>
           </a:solidFill>
           <a:ln/>
         </p:spPr>
       </p:sp>
       <p:pic>
         <p:nvPicPr>
-          <p:cNvPr id="16" name="product tick 2" descr="product tick 2">    </p:cNvPr>
+          <p:cNvPr id="43" name="next arrow 2" descr="next">    </p:cNvPr>
           <p:cNvPicPr>
             <a:picLocks noChangeAspect="1"/>
           </p:cNvPicPr>
@@ -5329,308 +6270,6 @@
         </p:blipFill>
         <p:spPr>
           <a:xfrm>
-            <a:off x="5518404" y="2729484"/>
-            <a:ext cx="155448" cy="155448"/>
-          </a:xfrm>
-          <a:prstGeom prst="rect">
-            <a:avLst/>
-          </a:prstGeom>
-        </p:spPr>
-      </p:pic>
-      <p:sp>
-        <p:nvSpPr>
-          <p:cNvPr id="17" name="Text 12"/>
-          <p:cNvSpPr txBox="1"/>
-          <p:nvPr/>
-        </p:nvSpPr>
-        <p:spPr>
-          <a:xfrm>
-            <a:off x="5440680" y="2999232"/>
-            <a:ext cx="1371600" cy="457200"/>
-          </a:xfrm>
-          <a:prstGeom prst="rect">
-            <a:avLst/>
-          </a:prstGeom>
-          <a:noFill/>
-          <a:ln/>
-        </p:spPr>
-        <p:txBody>
-          <a:bodyPr wrap="square" lIns="0" tIns="0" rIns="0" bIns="0" rtlCol="0" anchor="t"/>
-          <a:lstStyle/>
-          <a:p>
-            <a:pPr indent="0" marL="0">
-              <a:buNone/>
-            </a:pPr>
-            <a:r>
-              <a:rPr lang="en-US" sz="1100" b="1" dirty="0">
-                <a:solidFill>
-                  <a:schemeClr val="tx1"/>
-                </a:solidFill>
-              </a:rPr>
-              <a:t>OAX100</a:t>
-            </a:r>
-            <a:endParaRPr lang="en-US" sz="1100" dirty="0"/>
-          </a:p>
-        </p:txBody>
-      </p:sp>
-      <p:sp>
-        <p:nvSpPr>
-          <p:cNvPr id="18" name="product 3"/>
-          <p:cNvSpPr/>
-          <p:nvPr/>
-        </p:nvSpPr>
-        <p:spPr>
-          <a:xfrm>
-            <a:off x="7086600" y="2514600"/>
-            <a:ext cx="1600200" cy="1005840"/>
-          </a:xfrm>
-          <a:prstGeom prst="roundRect">
-            <a:avLst>
-              <a:gd name="adj" fmla="val 7273"/>
-            </a:avLst>
-          </a:prstGeom>
-          <a:solidFill>
-            <a:schemeClr val="bg2"/>
-          </a:solidFill>
-          <a:ln/>
-        </p:spPr>
-      </p:sp>
-      <p:sp>
-        <p:nvSpPr>
-          <p:cNvPr id="19" name="product tick 3 circle"/>
-          <p:cNvSpPr/>
-          <p:nvPr/>
-        </p:nvSpPr>
-        <p:spPr>
-          <a:xfrm>
-            <a:off x="7223760" y="2651760"/>
-            <a:ext cx="310896" cy="310896"/>
-          </a:xfrm>
-          <a:prstGeom prst="ellipse">
-            <a:avLst/>
-          </a:prstGeom>
-          <a:solidFill>
-            <a:schemeClr val="accent5"/>
-          </a:solidFill>
-          <a:ln/>
-        </p:spPr>
-      </p:sp>
-      <p:pic>
-        <p:nvPicPr>
-          <p:cNvPr id="20" name="product tick 3" descr="product tick 3">    </p:cNvPr>
-          <p:cNvPicPr>
-            <a:picLocks noChangeAspect="1"/>
-          </p:cNvPicPr>
-          <p:nvPr/>
-        </p:nvPicPr>
-        <p:blipFill>
-          <a:blip r:embed="rId3"/>
-          <a:stretch>
-            <a:fillRect/>
-          </a:stretch>
-        </p:blipFill>
-        <p:spPr>
-          <a:xfrm>
-            <a:off x="7301484" y="2729484"/>
-            <a:ext cx="155448" cy="155448"/>
-          </a:xfrm>
-          <a:prstGeom prst="rect">
-            <a:avLst/>
-          </a:prstGeom>
-        </p:spPr>
-      </p:pic>
-      <p:sp>
-        <p:nvSpPr>
-          <p:cNvPr id="21" name="Text 15"/>
-          <p:cNvSpPr txBox="1"/>
-          <p:nvPr/>
-        </p:nvSpPr>
-        <p:spPr>
-          <a:xfrm>
-            <a:off x="7223760" y="2999232"/>
-            <a:ext cx="1371600" cy="457200"/>
-          </a:xfrm>
-          <a:prstGeom prst="rect">
-            <a:avLst/>
-          </a:prstGeom>
-          <a:noFill/>
-          <a:ln/>
-        </p:spPr>
-        <p:txBody>
-          <a:bodyPr wrap="square" lIns="0" tIns="0" rIns="0" bIns="0" rtlCol="0" anchor="t"/>
-          <a:lstStyle/>
-          <a:p>
-            <a:pPr indent="0" marL="0">
-              <a:buNone/>
-            </a:pPr>
-            <a:r>
-              <a:rPr lang="en-US" sz="1100" b="1" dirty="0">
-                <a:solidFill>
-                  <a:schemeClr val="tx1"/>
-                </a:solidFill>
-              </a:rPr>
-              <a:t>Fractional Marketing Partners</a:t>
-            </a:r>
-            <a:endParaRPr lang="en-US" sz="1100" dirty="0"/>
-          </a:p>
-        </p:txBody>
-      </p:sp>
-      <p:sp>
-        <p:nvSpPr>
-          <p:cNvPr id="22" name="Text 16"/>
-          <p:cNvSpPr txBox="1"/>
-          <p:nvPr/>
-        </p:nvSpPr>
-        <p:spPr>
-          <a:xfrm>
-            <a:off x="457200" y="3794760"/>
-            <a:ext cx="2743200" cy="228600"/>
-          </a:xfrm>
-          <a:prstGeom prst="rect">
-            <a:avLst/>
-          </a:prstGeom>
-          <a:noFill/>
-          <a:ln/>
-        </p:spPr>
-        <p:txBody>
-          <a:bodyPr wrap="square" lIns="0" tIns="0" rIns="0" bIns="0" rtlCol="0" anchor="ctr"/>
-          <a:lstStyle/>
-          <a:p>
-            <a:pPr indent="0" marL="0">
-              <a:buNone/>
-            </a:pPr>
-            <a:r>
-              <a:rPr lang="en-US" sz="1000" b="1" spc="100" kern="0" dirty="0">
-                <a:solidFill>
-                  <a:schemeClr val="accent5"/>
-                </a:solidFill>
-              </a:rPr>
-              <a:t>NEXT QUARTER</a:t>
-            </a:r>
-            <a:endParaRPr lang="en-US" sz="1000" dirty="0"/>
-          </a:p>
-        </p:txBody>
-      </p:sp>
-      <p:sp>
-        <p:nvSpPr>
-          <p:cNvPr id="23" name="next step 1"/>
-          <p:cNvSpPr/>
-          <p:nvPr/>
-        </p:nvSpPr>
-        <p:spPr>
-          <a:xfrm>
-            <a:off x="457200" y="4069080"/>
-            <a:ext cx="4000500" cy="548640"/>
-          </a:xfrm>
-          <a:prstGeom prst="roundRect">
-            <a:avLst>
-              <a:gd name="adj" fmla="val 13333"/>
-            </a:avLst>
-          </a:prstGeom>
-          <a:solidFill>
-            <a:schemeClr val="accent4"/>
-          </a:solidFill>
-          <a:ln/>
-        </p:spPr>
-      </p:sp>
-      <p:pic>
-        <p:nvPicPr>
-          <p:cNvPr id="24" name="next arrow 1" descr="next">    </p:cNvPr>
-          <p:cNvPicPr>
-            <a:picLocks noChangeAspect="1"/>
-          </p:cNvPicPr>
-          <p:nvPr/>
-        </p:nvPicPr>
-        <p:blipFill>
-          <a:blip r:embed="rId4"/>
-          <a:stretch>
-            <a:fillRect/>
-          </a:stretch>
-        </p:blipFill>
-        <p:spPr>
-          <a:xfrm>
-            <a:off x="621792" y="4233672"/>
-            <a:ext cx="219456" cy="219456"/>
-          </a:xfrm>
-          <a:prstGeom prst="rect">
-            <a:avLst/>
-          </a:prstGeom>
-        </p:spPr>
-      </p:pic>
-      <p:sp>
-        <p:nvSpPr>
-          <p:cNvPr id="25" name="Text 18"/>
-          <p:cNvSpPr txBox="1"/>
-          <p:nvPr/>
-        </p:nvSpPr>
-        <p:spPr>
-          <a:xfrm>
-            <a:off x="960120" y="4069080"/>
-            <a:ext cx="3360420" cy="548640"/>
-          </a:xfrm>
-          <a:prstGeom prst="rect">
-            <a:avLst/>
-          </a:prstGeom>
-          <a:noFill/>
-          <a:ln/>
-        </p:spPr>
-        <p:txBody>
-          <a:bodyPr wrap="square" lIns="0" tIns="0" rIns="0" bIns="0" rtlCol="0" anchor="ctr"/>
-          <a:lstStyle/>
-          <a:p>
-            <a:pPr indent="0" marL="0">
-              <a:buNone/>
-            </a:pPr>
-            <a:r>
-              <a:rPr lang="en-US" sz="1100" b="1" dirty="0">
-                <a:solidFill>
-                  <a:schemeClr val="tx1"/>
-                </a:solidFill>
-              </a:rPr>
-              <a:t>Lead every qualified call with the Freedom Plan</a:t>
-            </a:r>
-            <a:endParaRPr lang="en-US" sz="1100" dirty="0"/>
-          </a:p>
-        </p:txBody>
-      </p:sp>
-      <p:sp>
-        <p:nvSpPr>
-          <p:cNvPr id="26" name="next step 2"/>
-          <p:cNvSpPr/>
-          <p:nvPr/>
-        </p:nvSpPr>
-        <p:spPr>
-          <a:xfrm>
-            <a:off x="4686300" y="4069080"/>
-            <a:ext cx="4000500" cy="548640"/>
-          </a:xfrm>
-          <a:prstGeom prst="roundRect">
-            <a:avLst>
-              <a:gd name="adj" fmla="val 13333"/>
-            </a:avLst>
-          </a:prstGeom>
-          <a:solidFill>
-            <a:schemeClr val="accent4"/>
-          </a:solidFill>
-          <a:ln/>
-        </p:spPr>
-      </p:sp>
-      <p:pic>
-        <p:nvPicPr>
-          <p:cNvPr id="27" name="next arrow 2" descr="next">    </p:cNvPr>
-          <p:cNvPicPr>
-            <a:picLocks noChangeAspect="1"/>
-          </p:cNvPicPr>
-          <p:nvPr/>
-        </p:nvPicPr>
-        <p:blipFill>
-          <a:blip r:embed="rId5"/>
-          <a:stretch>
-            <a:fillRect/>
-          </a:stretch>
-        </p:blipFill>
-        <p:spPr>
-          <a:xfrm>
             <a:off x="4850892" y="4233672"/>
             <a:ext cx="219456" cy="219456"/>
           </a:xfrm>
@@ -5641,7 +6280,7 @@
       </p:pic>
       <p:sp>
         <p:nvSpPr>
-          <p:cNvPr id="28" name="Text 20"/>
+          <p:cNvPr id="44" name="Text 39"/>
           <p:cNvSpPr txBox="1"/>
           <p:nvPr/>
         </p:nvSpPr>

</xml_diff>

<commit_message>
Reword lost-lead reasons to shopping and comparing instead of price
Co-Authored-By: Claude Opus 5.5 <noreply@anthropic.com>
Claude-Session: https://claude.ai/code/session_01TQevHxB1x7vFaQYb7c58XF
</commit_message>
<xml_diff>
--- a/OA_Q2_Sales_Rock_Recap_Refined.pptx
+++ b/OA_Q2_Sales_Rock_Recap_Refined.pptx
@@ -114,13 +114,13 @@
   <p:extLst>
     <p:ext uri="{521415D9-36F7-43E2-AB2F-B90AF26B5E84}">
       <p14:sectionLst xmlns:p14="http://schemas.microsoft.com/office/powerpoint/2010/main">
-        <p14:section name="Overview" id="{70c46522-9495-e618-28cf-c8dac2f4bced}">
+        <p14:section name="Overview" id="{be72d57f-cf1b-c0ae-963d-482252847e55}">
           <p14:sldIdLst>
             <p14:sldId id="256"/>
             <p14:sldId id="257"/>
           </p14:sldIdLst>
         </p14:section>
-        <p14:section name="Rocks" id="{df6766dc-6615-ba26-e8d1-3084741bae69}">
+        <p14:section name="Rocks" id="{2aa97b4f-a32f-261d-174d-26858c2d00d3}">
           <p14:sldIdLst>
             <p14:sldId id="258"/>
             <p14:sldId id="259"/>
@@ -128,7 +128,7 @@
             <p14:sldId id="261"/>
           </p14:sldIdLst>
         </p14:section>
-        <p14:section name="Next quarter" id="{e168d3e7-d88e-b6b6-510e-35fa3c6698d3}">
+        <p14:section name="Next quarter" id="{bec216a2-1347-ba69-0aee-830be3f18f94}">
           <p14:sldIdLst>
             <p14:sldId id="262"/>
             <p14:sldId id="263"/>
@@ -978,7 +978,7 @@
           <a:p>
             <a:r>
               <a:rPr lang="en-US" dirty="0"/>
-              <a:t>We captured why lost leads did not go ahead, from post-call notes and reactivation replies, and grouped the feedback into themes. Three reasons stand out. Most lost deals are about timing and perceived price, not OA's quality. Each reason now has an answer we are building into offers and nurture.</a:t>
+              <a:t>We captured why lost leads did not go ahead, from post-call notes and reactivation replies, and grouped the feedback into themes. Three reasons stand out. Most lost deals are about timing and clients shopping and comparing, not OA's quality. Each reason now has an answer we are building into offers and nurture.</a:t>
             </a:r>
             <a:endParaRPr lang="en-US" dirty="0"/>
           </a:p>
@@ -1066,7 +1066,7 @@
           <a:p>
             <a:r>
               <a:rPr lang="en-US" dirty="0"/>
-              <a:t>Keep: reactivating the CRM and leading with flexible options both clearly worked. Change: open with the Freedom Plan as a low-commitment first step, sell outcomes before price, and nurture leads who are not ready instead of letting them go cold.</a:t>
+              <a:t>Keep: reactivating the CRM and leading with flexible options both clearly worked. Change: open with the Freedom Plan as a low-commitment first step, lead with outcomes and value, and nurture leads who are not ready instead of letting them go cold.</a:t>
             </a:r>
             <a:endParaRPr lang="en-US" dirty="0"/>
           </a:p>
@@ -2976,7 +2976,7 @@
                   <a:schemeClr val="accent3"/>
                 </a:solidFill>
               </a:rPr>
-              <a:t>3 reasons: price, not ready, still shopping</a:t>
+              <a:t>Not ready, shopping, comparing</a:t>
             </a:r>
             <a:endParaRPr lang="en-US" sz="1000" dirty="0"/>
           </a:p>
@@ -6556,7 +6556,7 @@
                   <a:schemeClr val="tx1"/>
                 </a:solidFill>
               </a:rPr>
-              <a:t>Price</a:t>
+              <a:t>Comparing options</a:t>
             </a:r>
             <a:endParaRPr lang="en-US" sz="1500" dirty="0"/>
           </a:p>
@@ -6592,7 +6592,7 @@
                   <a:schemeClr val="accent3"/>
                 </a:solidFill>
               </a:rPr>
-              <a:t>“It feels too expensive”</a:t>
+              <a:t>“We’re weighing it up”</a:t>
             </a:r>
             <a:endParaRPr lang="en-US" sz="1200" dirty="0"/>
           </a:p>
@@ -6686,7 +6686,7 @@
                   <a:schemeClr val="tx1"/>
                 </a:solidFill>
               </a:rPr>
-              <a:t>Sell outcomes before price</a:t>
+              <a:t>Lead with outcomes and value</a:t>
             </a:r>
             <a:endParaRPr lang="en-US" sz="1200" dirty="0"/>
           </a:p>
@@ -7056,7 +7056,7 @@
                   <a:schemeClr val="accent3"/>
                 </a:solidFill>
               </a:rPr>
-              <a:t>“We’re comparing options”</a:t>
+              <a:t>“We’re talking to others”</a:t>
             </a:r>
             <a:endParaRPr lang="en-US" sz="1200" dirty="0"/>
           </a:p>
@@ -7219,7 +7219,7 @@
                   <a:schemeClr val="bg1"/>
                 </a:solidFill>
               </a:rPr>
-              <a:t>Most lost deals are about timing and price, not OA's quality.</a:t>
+              <a:t>Most lost deals are about timing and comparison, not OA's quality.</a:t>
             </a:r>
             <a:endParaRPr lang="en-US" sz="1100" dirty="0"/>
           </a:p>
@@ -7685,7 +7685,7 @@
                   <a:schemeClr val="tx1"/>
                 </a:solidFill>
               </a:rPr>
-              <a:t>Sell outcomes before price</a:t>
+              <a:t>Lead with outcomes and value</a:t>
             </a:r>
             <a:endParaRPr lang="en-US" sz="1400" dirty="0"/>
           </a:p>

</xml_diff>

<commit_message>
Add next-quarter Rocks slides to Sales recap deck
Co-Authored-By: Claude Opus 5.5 <noreply@anthropic.com>
Claude-Session: https://claude.ai/code/session_01TQevHxB1x7vFaQYb7c58XF
</commit_message>
<xml_diff>
--- a/OA_Q2_Sales_Rock_Recap_Refined.pptx
+++ b/OA_Q2_Sales_Rock_Recap_Refined.pptx
@@ -13,9 +13,13 @@
     <p:sldId id="261" r:id="rId7"/>
     <p:sldId id="262" r:id="rId8"/>
     <p:sldId id="263" r:id="rId9"/>
+    <p:sldId id="264" r:id="rId10"/>
+    <p:sldId id="265" r:id="rId11"/>
+    <p:sldId id="266" r:id="rId12"/>
+    <p:sldId id="267" r:id="rId13"/>
   </p:sldIdLst>
   <p:notesMasterIdLst>
-    <p:notesMasterId r:id="rId10"/>
+    <p:notesMasterId r:id="rId14"/>
   </p:notesMasterIdLst>
   <p:sldSz cx="9144000" cy="5143500"/>
   <p:notesSz cx="5143500" cy="9144000"/>
@@ -114,13 +118,13 @@
   <p:extLst>
     <p:ext uri="{521415D9-36F7-43E2-AB2F-B90AF26B5E84}">
       <p14:sectionLst xmlns:p14="http://schemas.microsoft.com/office/powerpoint/2010/main">
-        <p14:section name="Overview" id="{be72d57f-cf1b-c0ae-963d-482252847e55}">
+        <p14:section name="Overview" id="{7f162cc9-d77b-1629-7499-a72e6b0701a1}">
           <p14:sldIdLst>
             <p14:sldId id="256"/>
             <p14:sldId id="257"/>
           </p14:sldIdLst>
         </p14:section>
-        <p14:section name="Rocks" id="{2aa97b4f-a32f-261d-174d-26858c2d00d3}">
+        <p14:section name="Rocks" id="{464dbded-4208-3daa-06c3-a6877a222226}">
           <p14:sldIdLst>
             <p14:sldId id="258"/>
             <p14:sldId id="259"/>
@@ -128,10 +132,18 @@
             <p14:sldId id="261"/>
           </p14:sldIdLst>
         </p14:section>
-        <p14:section name="Next quarter" id="{bec216a2-1347-ba69-0aee-830be3f18f94}">
+        <p14:section name="Next quarter" id="{b563e705-ed88-e8fe-0d2b-04b331588f82}">
           <p14:sldIdLst>
             <p14:sldId id="262"/>
             <p14:sldId id="263"/>
+          </p14:sldIdLst>
+        </p14:section>
+        <p14:section name="Q3 Rocks" id="{0cbb3c5e-8e62-8365-7dd5-a142ebfa2d46}">
+          <p14:sldIdLst>
+            <p14:sldId id="264"/>
+            <p14:sldId id="265"/>
+            <p14:sldId id="266"/>
+            <p14:sldId id="267"/>
           </p14:sldIdLst>
         </p14:section>
       </p14:sectionLst>
@@ -580,6 +592,270 @@
 </p:notes>
 </file>
 
+<file path=ppt/notesSlides/notesSlide10.xml><?xml version="1.0" encoding="utf-8"?>
+<p:notes xmlns:a="http://schemas.openxmlformats.org/drawingml/2006/main" xmlns:r="http://schemas.openxmlformats.org/officeDocument/2006/relationships" xmlns:p="http://schemas.openxmlformats.org/presentationml/2006/main">
+  <p:cSld>
+    <p:spTree>
+      <p:nvGrpSpPr>
+        <p:cNvPr id="1" name=""/>
+        <p:cNvGrpSpPr/>
+        <p:nvPr/>
+      </p:nvGrpSpPr>
+      <p:grpSpPr>
+        <a:xfrm>
+          <a:off x="0" y="0"/>
+          <a:ext cx="0" cy="0"/>
+          <a:chOff x="0" y="0"/>
+          <a:chExt cx="0" cy="0"/>
+        </a:xfrm>
+      </p:grpSpPr>
+      <p:sp>
+        <p:nvSpPr>
+          <p:cNvPr id="2" name="Slide Image Placeholder 1"/>
+          <p:cNvSpPr>
+            <a:spLocks noGrp="1" noRot="1" noChangeAspect="1"/>
+          </p:cNvSpPr>
+          <p:nvPr>
+            <p:ph type="sldImg"/>
+          </p:nvPr>
+        </p:nvSpPr>
+        <p:spPr/>
+      </p:sp>
+      <p:sp>
+        <p:nvSpPr>
+          <p:cNvPr id="3" name="Notes Placeholder 2"/>
+          <p:cNvSpPr>
+            <a:spLocks noGrp="1"/>
+          </p:cNvSpPr>
+          <p:nvPr>
+            <p:ph type="body" idx="1"/>
+          </p:nvPr>
+        </p:nvSpPr>
+        <p:spPr/>
+        <p:txBody>
+          <a:bodyPr/>
+          <a:lstStyle/>
+          <a:p>
+            <a:r>
+              <a:rPr lang="en-US" dirty="0"/>
+              <a:t>Our close rate is strong, so the lever is more qualified conversations. Keep the daily BDM habit, cut no-shows with reminders, and move the warm BDM leads to proposal. Targets to agree with Ms Linh.</a:t>
+            </a:r>
+            <a:endParaRPr lang="en-US" dirty="0"/>
+          </a:p>
+        </p:txBody>
+      </p:sp>
+      <p:sp>
+        <p:nvSpPr>
+          <p:cNvPr id="4" name="Slide Number Placeholder 3"/>
+          <p:cNvSpPr>
+            <a:spLocks noGrp="1"/>
+          </p:cNvSpPr>
+          <p:nvPr>
+            <p:ph type="sldNum" sz="quarter" idx="10"/>
+          </p:nvPr>
+        </p:nvSpPr>
+        <p:spPr/>
+        <p:txBody>
+          <a:bodyPr/>
+          <a:lstStyle/>
+          <a:p>
+            <a:fld id="{F7021451-1387-4CA6-816F-3879F97B5CBC}" type="slidenum">
+              <a:rPr lang="en-US"/>
+              <a:t>10</a:t>
+            </a:fld>
+            <a:endParaRPr lang="en-US"/>
+          </a:p>
+        </p:txBody>
+      </p:sp>
+    </p:spTree>
+    <p:extLst>
+      <p:ext uri="{BB962C8B-B14F-4D97-AF65-F5344CB8AC3E}">
+        <p14:creationId xmlns:p14="http://schemas.microsoft.com/office/powerpoint/2010/main" val="1024086991"/>
+      </p:ext>
+    </p:extLst>
+  </p:cSld>
+  <p:clrMapOvr>
+    <a:masterClrMapping/>
+  </p:clrMapOvr>
+</p:notes>
+</file>
+
+<file path=ppt/notesSlides/notesSlide11.xml><?xml version="1.0" encoding="utf-8"?>
+<p:notes xmlns:a="http://schemas.openxmlformats.org/drawingml/2006/main" xmlns:r="http://schemas.openxmlformats.org/officeDocument/2006/relationships" xmlns:p="http://schemas.openxmlformats.org/presentationml/2006/main">
+  <p:cSld>
+    <p:spTree>
+      <p:nvGrpSpPr>
+        <p:cNvPr id="1" name=""/>
+        <p:cNvGrpSpPr/>
+        <p:nvPr/>
+      </p:nvGrpSpPr>
+      <p:grpSpPr>
+        <a:xfrm>
+          <a:off x="0" y="0"/>
+          <a:ext cx="0" cy="0"/>
+          <a:chOff x="0" y="0"/>
+          <a:chExt cx="0" cy="0"/>
+        </a:xfrm>
+      </p:grpSpPr>
+      <p:sp>
+        <p:nvSpPr>
+          <p:cNvPr id="2" name="Slide Image Placeholder 1"/>
+          <p:cNvSpPr>
+            <a:spLocks noGrp="1" noRot="1" noChangeAspect="1"/>
+          </p:cNvSpPr>
+          <p:nvPr>
+            <p:ph type="sldImg"/>
+          </p:nvPr>
+        </p:nvSpPr>
+        <p:spPr/>
+      </p:sp>
+      <p:sp>
+        <p:nvSpPr>
+          <p:cNvPr id="3" name="Notes Placeholder 2"/>
+          <p:cNvSpPr>
+            <a:spLocks noGrp="1"/>
+          </p:cNvSpPr>
+          <p:nvPr>
+            <p:ph type="body" idx="1"/>
+          </p:nvPr>
+        </p:nvSpPr>
+        <p:spPr/>
+        <p:txBody>
+          <a:bodyPr/>
+          <a:lstStyle/>
+          <a:p>
+            <a:r>
+              <a:rPr lang="en-US" dirty="0"/>
+              <a:t>We built 10 ways to buy. Q3 is about selling across the whole ladder: the Freedom Plan as the front door, first clients for the Fractional Partners and OAX100, and growing existing clients through upgrades and a second Angel.</a:t>
+            </a:r>
+            <a:endParaRPr lang="en-US" dirty="0"/>
+          </a:p>
+        </p:txBody>
+      </p:sp>
+      <p:sp>
+        <p:nvSpPr>
+          <p:cNvPr id="4" name="Slide Number Placeholder 3"/>
+          <p:cNvSpPr>
+            <a:spLocks noGrp="1"/>
+          </p:cNvSpPr>
+          <p:nvPr>
+            <p:ph type="sldNum" sz="quarter" idx="10"/>
+          </p:nvPr>
+        </p:nvSpPr>
+        <p:spPr/>
+        <p:txBody>
+          <a:bodyPr/>
+          <a:lstStyle/>
+          <a:p>
+            <a:fld id="{F7021451-1387-4CA6-816F-3879F97B5CBC}" type="slidenum">
+              <a:rPr lang="en-US"/>
+              <a:t>11</a:t>
+            </a:fld>
+            <a:endParaRPr lang="en-US"/>
+          </a:p>
+        </p:txBody>
+      </p:sp>
+    </p:spTree>
+    <p:extLst>
+      <p:ext uri="{BB962C8B-B14F-4D97-AF65-F5344CB8AC3E}">
+        <p14:creationId xmlns:p14="http://schemas.microsoft.com/office/powerpoint/2010/main" val="1024086991"/>
+      </p:ext>
+    </p:extLst>
+  </p:cSld>
+  <p:clrMapOvr>
+    <a:masterClrMapping/>
+  </p:clrMapOvr>
+</p:notes>
+</file>
+
+<file path=ppt/notesSlides/notesSlide12.xml><?xml version="1.0" encoding="utf-8"?>
+<p:notes xmlns:a="http://schemas.openxmlformats.org/drawingml/2006/main" xmlns:r="http://schemas.openxmlformats.org/officeDocument/2006/relationships" xmlns:p="http://schemas.openxmlformats.org/presentationml/2006/main">
+  <p:cSld>
+    <p:spTree>
+      <p:nvGrpSpPr>
+        <p:cNvPr id="1" name=""/>
+        <p:cNvGrpSpPr/>
+        <p:nvPr/>
+      </p:nvGrpSpPr>
+      <p:grpSpPr>
+        <a:xfrm>
+          <a:off x="0" y="0"/>
+          <a:ext cx="0" cy="0"/>
+          <a:chOff x="0" y="0"/>
+          <a:chExt cx="0" cy="0"/>
+        </a:xfrm>
+      </p:grpSpPr>
+      <p:sp>
+        <p:nvSpPr>
+          <p:cNvPr id="2" name="Slide Image Placeholder 1"/>
+          <p:cNvSpPr>
+            <a:spLocks noGrp="1" noRot="1" noChangeAspect="1"/>
+          </p:cNvSpPr>
+          <p:nvPr>
+            <p:ph type="sldImg"/>
+          </p:nvPr>
+        </p:nvSpPr>
+        <p:spPr/>
+      </p:sp>
+      <p:sp>
+        <p:nvSpPr>
+          <p:cNvPr id="3" name="Notes Placeholder 2"/>
+          <p:cNvSpPr>
+            <a:spLocks noGrp="1"/>
+          </p:cNvSpPr>
+          <p:nvPr>
+            <p:ph type="body" idx="1"/>
+          </p:nvPr>
+        </p:nvSpPr>
+        <p:spPr/>
+        <p:txBody>
+          <a:bodyPr/>
+          <a:lstStyle/>
+          <a:p>
+            <a:r>
+              <a:rPr lang="en-US" dirty="0"/>
+              <a:t>We learned a lot from customers in Q2, but it lives in weekly notes. Q3 turns it into data: a live dashboard, a lost reason on every call, and a monthly report to Marketing, Recruitment and CAX.</a:t>
+            </a:r>
+            <a:endParaRPr lang="en-US" dirty="0"/>
+          </a:p>
+        </p:txBody>
+      </p:sp>
+      <p:sp>
+        <p:nvSpPr>
+          <p:cNvPr id="4" name="Slide Number Placeholder 3"/>
+          <p:cNvSpPr>
+            <a:spLocks noGrp="1"/>
+          </p:cNvSpPr>
+          <p:nvPr>
+            <p:ph type="sldNum" sz="quarter" idx="10"/>
+          </p:nvPr>
+        </p:nvSpPr>
+        <p:spPr/>
+        <p:txBody>
+          <a:bodyPr/>
+          <a:lstStyle/>
+          <a:p>
+            <a:fld id="{F7021451-1387-4CA6-816F-3879F97B5CBC}" type="slidenum">
+              <a:rPr lang="en-US"/>
+              <a:t>12</a:t>
+            </a:fld>
+            <a:endParaRPr lang="en-US"/>
+          </a:p>
+        </p:txBody>
+      </p:sp>
+    </p:spTree>
+    <p:extLst>
+      <p:ext uri="{BB962C8B-B14F-4D97-AF65-F5344CB8AC3E}">
+        <p14:creationId xmlns:p14="http://schemas.microsoft.com/office/powerpoint/2010/main" val="1024086991"/>
+      </p:ext>
+    </p:extLst>
+  </p:cSld>
+  <p:clrMapOvr>
+    <a:masterClrMapping/>
+  </p:clrMapOvr>
+</p:notes>
+</file>
+
 <file path=ppt/notesSlides/notesSlide2.xml><?xml version="1.0" encoding="utf-8"?>
 <p:notes xmlns:a="http://schemas.openxmlformats.org/drawingml/2006/main" xmlns:r="http://schemas.openxmlformats.org/officeDocument/2006/relationships" xmlns:p="http://schemas.openxmlformats.org/presentationml/2006/main">
   <p:cSld>
@@ -1178,6 +1454,94 @@
             <a:fld id="{F7021451-1387-4CA6-816F-3879F97B5CBC}" type="slidenum">
               <a:rPr lang="en-US"/>
               <a:t>8</a:t>
+            </a:fld>
+            <a:endParaRPr lang="en-US"/>
+          </a:p>
+        </p:txBody>
+      </p:sp>
+    </p:spTree>
+    <p:extLst>
+      <p:ext uri="{BB962C8B-B14F-4D97-AF65-F5344CB8AC3E}">
+        <p14:creationId xmlns:p14="http://schemas.microsoft.com/office/powerpoint/2010/main" val="1024086991"/>
+      </p:ext>
+    </p:extLst>
+  </p:cSld>
+  <p:clrMapOvr>
+    <a:masterClrMapping/>
+  </p:clrMapOvr>
+</p:notes>
+</file>
+
+<file path=ppt/notesSlides/notesSlide9.xml><?xml version="1.0" encoding="utf-8"?>
+<p:notes xmlns:a="http://schemas.openxmlformats.org/drawingml/2006/main" xmlns:r="http://schemas.openxmlformats.org/officeDocument/2006/relationships" xmlns:p="http://schemas.openxmlformats.org/presentationml/2006/main">
+  <p:cSld>
+    <p:spTree>
+      <p:nvGrpSpPr>
+        <p:cNvPr id="1" name=""/>
+        <p:cNvGrpSpPr/>
+        <p:nvPr/>
+      </p:nvGrpSpPr>
+      <p:grpSpPr>
+        <a:xfrm>
+          <a:off x="0" y="0"/>
+          <a:ext cx="0" cy="0"/>
+          <a:chOff x="0" y="0"/>
+          <a:chExt cx="0" cy="0"/>
+        </a:xfrm>
+      </p:grpSpPr>
+      <p:sp>
+        <p:nvSpPr>
+          <p:cNvPr id="2" name="Slide Image Placeholder 1"/>
+          <p:cNvSpPr>
+            <a:spLocks noGrp="1" noRot="1" noChangeAspect="1"/>
+          </p:cNvSpPr>
+          <p:nvPr>
+            <p:ph type="sldImg"/>
+          </p:nvPr>
+        </p:nvSpPr>
+        <p:spPr/>
+      </p:sp>
+      <p:sp>
+        <p:nvSpPr>
+          <p:cNvPr id="3" name="Notes Placeholder 2"/>
+          <p:cNvSpPr>
+            <a:spLocks noGrp="1"/>
+          </p:cNvSpPr>
+          <p:nvPr>
+            <p:ph type="body" idx="1"/>
+          </p:nvPr>
+        </p:nvSpPr>
+        <p:spPr/>
+        <p:txBody>
+          <a:bodyPr/>
+          <a:lstStyle/>
+          <a:p>
+            <a:r>
+              <a:rPr lang="en-US" dirty="0"/>
+              <a:t>Q2 proved what works. Q3 is about making it repeatable. Rock 1 fills the pipeline, Rock 2 makes sure every client finds the right product, and Rock 3 gives us the data to see it all in one place.</a:t>
+            </a:r>
+            <a:endParaRPr lang="en-US" dirty="0"/>
+          </a:p>
+        </p:txBody>
+      </p:sp>
+      <p:sp>
+        <p:nvSpPr>
+          <p:cNvPr id="4" name="Slide Number Placeholder 3"/>
+          <p:cNvSpPr>
+            <a:spLocks noGrp="1"/>
+          </p:cNvSpPr>
+          <p:nvPr>
+            <p:ph type="sldNum" sz="quarter" idx="10"/>
+          </p:nvPr>
+        </p:nvSpPr>
+        <p:spPr/>
+        <p:txBody>
+          <a:bodyPr/>
+          <a:lstStyle/>
+          <a:p>
+            <a:fld id="{F7021451-1387-4CA6-816F-3879F97B5CBC}" type="slidenum">
+              <a:rPr lang="en-US"/>
+              <a:t>9</a:t>
             </a:fld>
             <a:endParaRPr lang="en-US"/>
           </a:p>
@@ -2193,6 +2557,2625 @@
 </p:sld>
 </file>
 
+<file path=ppt/slides/slide10.xml><?xml version="1.0" encoding="utf-8"?>
+<p:sld xmlns:a="http://schemas.openxmlformats.org/drawingml/2006/main" xmlns:r="http://schemas.openxmlformats.org/officeDocument/2006/relationships" xmlns:p="http://schemas.openxmlformats.org/presentationml/2006/main">
+  <p:cSld name="Slide 10">
+    <p:spTree>
+      <p:nvGrpSpPr>
+        <p:cNvPr id="1" name=""/>
+        <p:cNvGrpSpPr/>
+        <p:nvPr/>
+      </p:nvGrpSpPr>
+      <p:grpSpPr>
+        <a:xfrm>
+          <a:off x="0" y="0"/>
+          <a:ext cx="0" cy="0"/>
+          <a:chOff x="0" y="0"/>
+          <a:chExt cx="0" cy="0"/>
+        </a:xfrm>
+      </p:grpSpPr>
+      <p:sp>
+        <p:nvSpPr>
+          <p:cNvPr id="2" name="Text 1"/>
+          <p:cNvSpPr/>
+          <p:nvPr>
+            <p:ph idx="101" type="body" hasCustomPrompt="1"/>
+          </p:nvPr>
+        </p:nvSpPr>
+        <p:spPr>
+          <a:xfrm>
+            <a:off x="457200" y="320040"/>
+            <a:ext cx="8229600" cy="274320"/>
+          </a:xfrm>
+          <a:prstGeom prst="rect">
+            <a:avLst/>
+          </a:prstGeom>
+          <a:noFill/>
+          <a:ln/>
+        </p:spPr>
+        <p:txBody>
+          <a:bodyPr wrap="square" lIns="0" tIns="0" rIns="0" bIns="0" rtlCol="0" anchor="ctr"/>
+          <a:lstStyle/>
+          <a:p>
+            <a:pPr indent="0" marL="0">
+              <a:buNone/>
+            </a:pPr>
+            <a:r>
+              <a:rPr lang="en-US" sz="1100" b="1" spc="200" kern="0" dirty="0">
+                <a:solidFill>
+                  <a:schemeClr val="accent5"/>
+                </a:solidFill>
+              </a:rPr>
+              <a:t>ROCK 01  ·  FILL THE PIPELINE</a:t>
+            </a:r>
+            <a:endParaRPr lang="en-US" sz="1100" dirty="0"/>
+          </a:p>
+        </p:txBody>
+      </p:sp>
+      <p:sp>
+        <p:nvSpPr>
+          <p:cNvPr id="3" name="Text 1"/>
+          <p:cNvSpPr/>
+          <p:nvPr>
+            <p:ph idx="102" type="title" hasCustomPrompt="1"/>
+          </p:nvPr>
+        </p:nvSpPr>
+        <p:spPr>
+          <a:xfrm>
+            <a:off x="457200" y="594360"/>
+            <a:ext cx="8229600" cy="548640"/>
+          </a:xfrm>
+          <a:prstGeom prst="rect">
+            <a:avLst/>
+          </a:prstGeom>
+          <a:noFill/>
+          <a:ln/>
+        </p:spPr>
+        <p:txBody>
+          <a:bodyPr wrap="square" lIns="0" tIns="0" rIns="0" bIns="0" rtlCol="0" anchor="ctr"/>
+          <a:lstStyle/>
+          <a:p>
+            <a:pPr algn="l" indent="0" marL="0">
+              <a:buNone/>
+            </a:pPr>
+            <a:r>
+              <a:rPr lang="en-US" sz="2600" b="1" dirty="0">
+                <a:solidFill>
+                  <a:schemeClr val="tx1"/>
+                </a:solidFill>
+              </a:rPr>
+              <a:t>More qualified calls, fewer no-shows</a:t>
+            </a:r>
+            <a:endParaRPr lang="en-US" sz="2600" dirty="0"/>
+          </a:p>
+        </p:txBody>
+      </p:sp>
+      <p:sp>
+        <p:nvSpPr>
+          <p:cNvPr id="5" name="why now"/>
+          <p:cNvSpPr/>
+          <p:nvPr/>
+        </p:nvSpPr>
+        <p:spPr>
+          <a:xfrm>
+            <a:off x="457200" y="1325880"/>
+            <a:ext cx="2743200" cy="2240280"/>
+          </a:xfrm>
+          <a:prstGeom prst="roundRect">
+            <a:avLst>
+              <a:gd name="adj" fmla="val 3265"/>
+            </a:avLst>
+          </a:prstGeom>
+          <a:solidFill>
+            <a:schemeClr val="accent5"/>
+          </a:solidFill>
+          <a:ln/>
+        </p:spPr>
+      </p:sp>
+      <p:sp>
+        <p:nvSpPr>
+          <p:cNvPr id="6" name="Text 3"/>
+          <p:cNvSpPr txBox="1"/>
+          <p:nvPr/>
+        </p:nvSpPr>
+        <p:spPr>
+          <a:xfrm>
+            <a:off x="685800" y="1463040"/>
+            <a:ext cx="2286000" cy="228600"/>
+          </a:xfrm>
+          <a:prstGeom prst="rect">
+            <a:avLst/>
+          </a:prstGeom>
+          <a:noFill/>
+          <a:ln/>
+        </p:spPr>
+        <p:txBody>
+          <a:bodyPr wrap="square" lIns="0" tIns="0" rIns="0" bIns="0" rtlCol="0" anchor="ctr"/>
+          <a:lstStyle/>
+          <a:p>
+            <a:pPr indent="0" marL="0">
+              <a:buNone/>
+            </a:pPr>
+            <a:r>
+              <a:rPr lang="en-US" sz="1000" b="1" spc="100" kern="0" dirty="0">
+                <a:solidFill>
+                  <a:schemeClr val="bg1"/>
+                </a:solidFill>
+              </a:rPr>
+              <a:t>WHY NOW</a:t>
+            </a:r>
+            <a:endParaRPr lang="en-US" sz="1000" dirty="0"/>
+          </a:p>
+        </p:txBody>
+      </p:sp>
+      <p:sp>
+        <p:nvSpPr>
+          <p:cNvPr id="7" name="Text 4"/>
+          <p:cNvSpPr txBox="1"/>
+          <p:nvPr/>
+        </p:nvSpPr>
+        <p:spPr>
+          <a:xfrm>
+            <a:off x="685800" y="1691640"/>
+            <a:ext cx="2377440" cy="777240"/>
+          </a:xfrm>
+          <a:prstGeom prst="rect">
+            <a:avLst/>
+          </a:prstGeom>
+          <a:noFill/>
+          <a:ln/>
+        </p:spPr>
+        <p:txBody>
+          <a:bodyPr wrap="square" lIns="0" tIns="0" rIns="0" bIns="0" rtlCol="0" anchor="ctr"/>
+          <a:lstStyle/>
+          <a:p>
+            <a:pPr indent="0" marL="0">
+              <a:buNone/>
+            </a:pPr>
+            <a:r>
+              <a:rPr lang="en-US" sz="3600" b="1" dirty="0">
+                <a:solidFill>
+                  <a:schemeClr val="bg1"/>
+                </a:solidFill>
+              </a:rPr>
+              <a:t>1 in 4</a:t>
+            </a:r>
+            <a:endParaRPr lang="en-US" sz="3600" dirty="0"/>
+          </a:p>
+        </p:txBody>
+      </p:sp>
+      <p:sp>
+        <p:nvSpPr>
+          <p:cNvPr id="8" name="Text 5"/>
+          <p:cNvSpPr txBox="1"/>
+          <p:nvPr/>
+        </p:nvSpPr>
+        <p:spPr>
+          <a:xfrm>
+            <a:off x="685800" y="2514600"/>
+            <a:ext cx="2377440" cy="960120"/>
+          </a:xfrm>
+          <a:prstGeom prst="rect">
+            <a:avLst/>
+          </a:prstGeom>
+          <a:noFill/>
+          <a:ln/>
+        </p:spPr>
+        <p:txBody>
+          <a:bodyPr wrap="square" lIns="0" tIns="0" rIns="0" bIns="0" rtlCol="0" anchor="t"/>
+          <a:lstStyle/>
+          <a:p>
+            <a:pPr indent="0" marL="0">
+              <a:buNone/>
+            </a:pPr>
+            <a:r>
+              <a:rPr lang="en-US" sz="1200" dirty="0">
+                <a:solidFill>
+                  <a:schemeClr val="bg1"/>
+                </a:solidFill>
+              </a:rPr>
+              <a:t>booked calls were no-shows or cancellations in Q2. Volume is the gap: people who show up, buy.</a:t>
+            </a:r>
+            <a:endParaRPr lang="en-US" sz="1200" dirty="0"/>
+          </a:p>
+        </p:txBody>
+      </p:sp>
+      <p:sp>
+        <p:nvSpPr>
+          <p:cNvPr id="9" name="Text 6"/>
+          <p:cNvSpPr txBox="1"/>
+          <p:nvPr/>
+        </p:nvSpPr>
+        <p:spPr>
+          <a:xfrm>
+            <a:off x="3474720" y="1325880"/>
+            <a:ext cx="3657600" cy="228600"/>
+          </a:xfrm>
+          <a:prstGeom prst="rect">
+            <a:avLst/>
+          </a:prstGeom>
+          <a:noFill/>
+          <a:ln/>
+        </p:spPr>
+        <p:txBody>
+          <a:bodyPr wrap="square" lIns="0" tIns="0" rIns="0" bIns="0" rtlCol="0" anchor="ctr"/>
+          <a:lstStyle/>
+          <a:p>
+            <a:pPr indent="0" marL="0">
+              <a:buNone/>
+            </a:pPr>
+            <a:r>
+              <a:rPr lang="en-US" sz="1000" b="1" spc="100" kern="0" dirty="0">
+                <a:solidFill>
+                  <a:schemeClr val="accent5"/>
+                </a:solidFill>
+              </a:rPr>
+              <a:t>WHAT WE'LL DO</a:t>
+            </a:r>
+            <a:endParaRPr lang="en-US" sz="1000" dirty="0"/>
+          </a:p>
+        </p:txBody>
+      </p:sp>
+      <p:sp>
+        <p:nvSpPr>
+          <p:cNvPr id="10" name="step 1"/>
+          <p:cNvSpPr/>
+          <p:nvPr/>
+        </p:nvSpPr>
+        <p:spPr>
+          <a:xfrm>
+            <a:off x="3474720" y="1700784"/>
+            <a:ext cx="384048" cy="384048"/>
+          </a:xfrm>
+          <a:prstGeom prst="ellipse">
+            <a:avLst/>
+          </a:prstGeom>
+          <a:solidFill>
+            <a:schemeClr val="accent1"/>
+          </a:solidFill>
+          <a:ln/>
+        </p:spPr>
+      </p:sp>
+      <p:sp>
+        <p:nvSpPr>
+          <p:cNvPr id="11" name="Text 8"/>
+          <p:cNvSpPr txBox="1"/>
+          <p:nvPr/>
+        </p:nvSpPr>
+        <p:spPr>
+          <a:xfrm>
+            <a:off x="3474720" y="1700784"/>
+            <a:ext cx="384048" cy="384048"/>
+          </a:xfrm>
+          <a:prstGeom prst="rect">
+            <a:avLst/>
+          </a:prstGeom>
+          <a:noFill/>
+          <a:ln/>
+        </p:spPr>
+        <p:txBody>
+          <a:bodyPr wrap="square" lIns="0" tIns="0" rIns="0" bIns="0" rtlCol="0" anchor="ctr"/>
+          <a:lstStyle/>
+          <a:p>
+            <a:pPr algn="ctr" indent="0" marL="0">
+              <a:buNone/>
+            </a:pPr>
+            <a:r>
+              <a:rPr lang="en-US" sz="1300" b="1" dirty="0">
+                <a:solidFill>
+                  <a:schemeClr val="bg1"/>
+                </a:solidFill>
+              </a:rPr>
+              <a:t>1</a:t>
+            </a:r>
+            <a:endParaRPr lang="en-US" sz="1300" dirty="0"/>
+          </a:p>
+        </p:txBody>
+      </p:sp>
+      <p:sp>
+        <p:nvSpPr>
+          <p:cNvPr id="12" name="Text 9"/>
+          <p:cNvSpPr txBox="1"/>
+          <p:nvPr/>
+        </p:nvSpPr>
+        <p:spPr>
+          <a:xfrm>
+            <a:off x="4023360" y="1627632"/>
+            <a:ext cx="4663440" cy="530352"/>
+          </a:xfrm>
+          <a:prstGeom prst="rect">
+            <a:avLst/>
+          </a:prstGeom>
+          <a:noFill/>
+          <a:ln/>
+        </p:spPr>
+        <p:txBody>
+          <a:bodyPr wrap="square" lIns="0" tIns="0" rIns="0" bIns="0" rtlCol="0" anchor="ctr"/>
+          <a:lstStyle/>
+          <a:p>
+            <a:pPr indent="0" marL="0">
+              <a:buNone/>
+            </a:pPr>
+            <a:r>
+              <a:rPr lang="en-US" sz="1300" b="1" dirty="0">
+                <a:solidFill>
+                  <a:schemeClr val="tx1"/>
+                </a:solidFill>
+              </a:rPr>
+              <a:t>Keep the daily BDM rhythm: 20 leads, 20 emails</a:t>
+            </a:r>
+            <a:endParaRPr lang="en-US" sz="1300" dirty="0"/>
+          </a:p>
+        </p:txBody>
+      </p:sp>
+      <p:sp>
+        <p:nvSpPr>
+          <p:cNvPr id="13" name="step 2"/>
+          <p:cNvSpPr/>
+          <p:nvPr/>
+        </p:nvSpPr>
+        <p:spPr>
+          <a:xfrm>
+            <a:off x="3474720" y="2359152"/>
+            <a:ext cx="384048" cy="384048"/>
+          </a:xfrm>
+          <a:prstGeom prst="ellipse">
+            <a:avLst/>
+          </a:prstGeom>
+          <a:solidFill>
+            <a:schemeClr val="accent1"/>
+          </a:solidFill>
+          <a:ln/>
+        </p:spPr>
+      </p:sp>
+      <p:sp>
+        <p:nvSpPr>
+          <p:cNvPr id="14" name="Text 11"/>
+          <p:cNvSpPr txBox="1"/>
+          <p:nvPr/>
+        </p:nvSpPr>
+        <p:spPr>
+          <a:xfrm>
+            <a:off x="3474720" y="2359152"/>
+            <a:ext cx="384048" cy="384048"/>
+          </a:xfrm>
+          <a:prstGeom prst="rect">
+            <a:avLst/>
+          </a:prstGeom>
+          <a:noFill/>
+          <a:ln/>
+        </p:spPr>
+        <p:txBody>
+          <a:bodyPr wrap="square" lIns="0" tIns="0" rIns="0" bIns="0" rtlCol="0" anchor="ctr"/>
+          <a:lstStyle/>
+          <a:p>
+            <a:pPr algn="ctr" indent="0" marL="0">
+              <a:buNone/>
+            </a:pPr>
+            <a:r>
+              <a:rPr lang="en-US" sz="1300" b="1" dirty="0">
+                <a:solidFill>
+                  <a:schemeClr val="bg1"/>
+                </a:solidFill>
+              </a:rPr>
+              <a:t>2</a:t>
+            </a:r>
+            <a:endParaRPr lang="en-US" sz="1300" dirty="0"/>
+          </a:p>
+        </p:txBody>
+      </p:sp>
+      <p:sp>
+        <p:nvSpPr>
+          <p:cNvPr id="15" name="Text 12"/>
+          <p:cNvSpPr txBox="1"/>
+          <p:nvPr/>
+        </p:nvSpPr>
+        <p:spPr>
+          <a:xfrm>
+            <a:off x="4023360" y="2286000"/>
+            <a:ext cx="4663440" cy="530352"/>
+          </a:xfrm>
+          <a:prstGeom prst="rect">
+            <a:avLst/>
+          </a:prstGeom>
+          <a:noFill/>
+          <a:ln/>
+        </p:spPr>
+        <p:txBody>
+          <a:bodyPr wrap="square" lIns="0" tIns="0" rIns="0" bIns="0" rtlCol="0" anchor="ctr"/>
+          <a:lstStyle/>
+          <a:p>
+            <a:pPr indent="0" marL="0">
+              <a:buNone/>
+            </a:pPr>
+            <a:r>
+              <a:rPr lang="en-US" sz="1300" b="1" dirty="0">
+                <a:solidFill>
+                  <a:schemeClr val="tx1"/>
+                </a:solidFill>
+              </a:rPr>
+              <a:t>Send email + SMS reminders before every Freedom Audit</a:t>
+            </a:r>
+            <a:endParaRPr lang="en-US" sz="1300" dirty="0"/>
+          </a:p>
+        </p:txBody>
+      </p:sp>
+      <p:sp>
+        <p:nvSpPr>
+          <p:cNvPr id="16" name="step 3"/>
+          <p:cNvSpPr/>
+          <p:nvPr/>
+        </p:nvSpPr>
+        <p:spPr>
+          <a:xfrm>
+            <a:off x="3474720" y="3017520"/>
+            <a:ext cx="384048" cy="384048"/>
+          </a:xfrm>
+          <a:prstGeom prst="ellipse">
+            <a:avLst/>
+          </a:prstGeom>
+          <a:solidFill>
+            <a:schemeClr val="accent1"/>
+          </a:solidFill>
+          <a:ln/>
+        </p:spPr>
+      </p:sp>
+      <p:sp>
+        <p:nvSpPr>
+          <p:cNvPr id="17" name="Text 14"/>
+          <p:cNvSpPr txBox="1"/>
+          <p:nvPr/>
+        </p:nvSpPr>
+        <p:spPr>
+          <a:xfrm>
+            <a:off x="3474720" y="3017520"/>
+            <a:ext cx="384048" cy="384048"/>
+          </a:xfrm>
+          <a:prstGeom prst="rect">
+            <a:avLst/>
+          </a:prstGeom>
+          <a:noFill/>
+          <a:ln/>
+        </p:spPr>
+        <p:txBody>
+          <a:bodyPr wrap="square" lIns="0" tIns="0" rIns="0" bIns="0" rtlCol="0" anchor="ctr"/>
+          <a:lstStyle/>
+          <a:p>
+            <a:pPr algn="ctr" indent="0" marL="0">
+              <a:buNone/>
+            </a:pPr>
+            <a:r>
+              <a:rPr lang="en-US" sz="1300" b="1" dirty="0">
+                <a:solidFill>
+                  <a:schemeClr val="bg1"/>
+                </a:solidFill>
+              </a:rPr>
+              <a:t>3</a:t>
+            </a:r>
+            <a:endParaRPr lang="en-US" sz="1300" dirty="0"/>
+          </a:p>
+        </p:txBody>
+      </p:sp>
+      <p:sp>
+        <p:nvSpPr>
+          <p:cNvPr id="18" name="Text 15"/>
+          <p:cNvSpPr txBox="1"/>
+          <p:nvPr/>
+        </p:nvSpPr>
+        <p:spPr>
+          <a:xfrm>
+            <a:off x="4023360" y="2944368"/>
+            <a:ext cx="4663440" cy="530352"/>
+          </a:xfrm>
+          <a:prstGeom prst="rect">
+            <a:avLst/>
+          </a:prstGeom>
+          <a:noFill/>
+          <a:ln/>
+        </p:spPr>
+        <p:txBody>
+          <a:bodyPr wrap="square" lIns="0" tIns="0" rIns="0" bIns="0" rtlCol="0" anchor="ctr"/>
+          <a:lstStyle/>
+          <a:p>
+            <a:pPr indent="0" marL="0">
+              <a:buNone/>
+            </a:pPr>
+            <a:r>
+              <a:rPr lang="en-US" sz="1300" b="1" dirty="0">
+                <a:solidFill>
+                  <a:schemeClr val="tx1"/>
+                </a:solidFill>
+              </a:rPr>
+              <a:t>Move warm leads (Brian, Mona, Arianne) to proposal</a:t>
+            </a:r>
+            <a:endParaRPr lang="en-US" sz="1300" dirty="0"/>
+          </a:p>
+        </p:txBody>
+      </p:sp>
+      <p:sp>
+        <p:nvSpPr>
+          <p:cNvPr id="19" name="Text 16"/>
+          <p:cNvSpPr txBox="1"/>
+          <p:nvPr/>
+        </p:nvSpPr>
+        <p:spPr>
+          <a:xfrm>
+            <a:off x="457200" y="3703320"/>
+            <a:ext cx="3657600" cy="228600"/>
+          </a:xfrm>
+          <a:prstGeom prst="rect">
+            <a:avLst/>
+          </a:prstGeom>
+          <a:noFill/>
+          <a:ln/>
+        </p:spPr>
+        <p:txBody>
+          <a:bodyPr wrap="square" lIns="0" tIns="0" rIns="0" bIns="0" rtlCol="0" anchor="ctr"/>
+          <a:lstStyle/>
+          <a:p>
+            <a:pPr indent="0" marL="0">
+              <a:buNone/>
+            </a:pPr>
+            <a:r>
+              <a:rPr lang="en-US" sz="1000" b="1" spc="100" kern="0" dirty="0">
+                <a:solidFill>
+                  <a:schemeClr val="accent5"/>
+                </a:solidFill>
+              </a:rPr>
+              <a:t>HOW WE'LL MEASURE</a:t>
+            </a:r>
+            <a:endParaRPr lang="en-US" sz="1000" dirty="0"/>
+          </a:p>
+        </p:txBody>
+      </p:sp>
+      <p:sp>
+        <p:nvSpPr>
+          <p:cNvPr id="20" name="measure 1"/>
+          <p:cNvSpPr/>
+          <p:nvPr/>
+        </p:nvSpPr>
+        <p:spPr>
+          <a:xfrm>
+            <a:off x="457200" y="3977640"/>
+            <a:ext cx="2590800" cy="658368"/>
+          </a:xfrm>
+          <a:prstGeom prst="roundRect">
+            <a:avLst>
+              <a:gd name="adj" fmla="val 11111"/>
+            </a:avLst>
+          </a:prstGeom>
+          <a:solidFill>
+            <a:schemeClr val="accent4"/>
+          </a:solidFill>
+          <a:ln/>
+        </p:spPr>
+      </p:sp>
+      <p:sp>
+        <p:nvSpPr>
+          <p:cNvPr id="21" name="Text 18"/>
+          <p:cNvSpPr txBox="1"/>
+          <p:nvPr/>
+        </p:nvSpPr>
+        <p:spPr>
+          <a:xfrm>
+            <a:off x="621792" y="3977640"/>
+            <a:ext cx="2316480" cy="658368"/>
+          </a:xfrm>
+          <a:prstGeom prst="rect">
+            <a:avLst/>
+          </a:prstGeom>
+          <a:noFill/>
+          <a:ln/>
+        </p:spPr>
+        <p:txBody>
+          <a:bodyPr wrap="square" lIns="0" tIns="0" rIns="0" bIns="0" rtlCol="0" anchor="ctr"/>
+          <a:lstStyle/>
+          <a:p>
+            <a:pPr indent="0" marL="0">
+              <a:buNone/>
+            </a:pPr>
+            <a:r>
+              <a:rPr lang="en-US" sz="1100" b="1" dirty="0">
+                <a:solidFill>
+                  <a:schemeClr val="tx1"/>
+                </a:solidFill>
+              </a:rPr>
+              <a:t>Freedom Audits per month</a:t>
+            </a:r>
+            <a:endParaRPr lang="en-US" sz="1100" dirty="0"/>
+          </a:p>
+          <a:p>
+            <a:pPr indent="0" marL="0">
+              <a:buNone/>
+            </a:pPr>
+            <a:r>
+              <a:rPr lang="en-US" sz="1000" b="1" dirty="0">
+                <a:solidFill>
+                  <a:schemeClr val="accent5"/>
+                </a:solidFill>
+              </a:rPr>
+              <a:t>Now: </a:t>
+            </a:r>
+            <a:pPr indent="0" marL="0">
+              <a:buNone/>
+            </a:pPr>
+            <a:r>
+              <a:rPr lang="en-US" sz="1000" dirty="0">
+                <a:solidFill>
+                  <a:schemeClr val="accent3"/>
+                </a:solidFill>
+              </a:rPr>
+              <a:t>29 calls in Sept</a:t>
+            </a:r>
+            <a:endParaRPr lang="en-US" sz="1100" dirty="0"/>
+          </a:p>
+        </p:txBody>
+      </p:sp>
+      <p:sp>
+        <p:nvSpPr>
+          <p:cNvPr id="22" name="measure 2"/>
+          <p:cNvSpPr/>
+          <p:nvPr/>
+        </p:nvSpPr>
+        <p:spPr>
+          <a:xfrm>
+            <a:off x="3276600" y="3977640"/>
+            <a:ext cx="2590800" cy="658368"/>
+          </a:xfrm>
+          <a:prstGeom prst="roundRect">
+            <a:avLst>
+              <a:gd name="adj" fmla="val 11111"/>
+            </a:avLst>
+          </a:prstGeom>
+          <a:solidFill>
+            <a:schemeClr val="accent4"/>
+          </a:solidFill>
+          <a:ln/>
+        </p:spPr>
+      </p:sp>
+      <p:sp>
+        <p:nvSpPr>
+          <p:cNvPr id="23" name="Text 20"/>
+          <p:cNvSpPr txBox="1"/>
+          <p:nvPr/>
+        </p:nvSpPr>
+        <p:spPr>
+          <a:xfrm>
+            <a:off x="3441192" y="3977640"/>
+            <a:ext cx="2316480" cy="658368"/>
+          </a:xfrm>
+          <a:prstGeom prst="rect">
+            <a:avLst/>
+          </a:prstGeom>
+          <a:noFill/>
+          <a:ln/>
+        </p:spPr>
+        <p:txBody>
+          <a:bodyPr wrap="square" lIns="0" tIns="0" rIns="0" bIns="0" rtlCol="0" anchor="ctr"/>
+          <a:lstStyle/>
+          <a:p>
+            <a:pPr indent="0" marL="0">
+              <a:buNone/>
+            </a:pPr>
+            <a:r>
+              <a:rPr lang="en-US" sz="1100" b="1" dirty="0">
+                <a:solidFill>
+                  <a:schemeClr val="tx1"/>
+                </a:solidFill>
+              </a:rPr>
+              <a:t>No-show rate (aim: halve it)</a:t>
+            </a:r>
+            <a:endParaRPr lang="en-US" sz="1100" dirty="0"/>
+          </a:p>
+          <a:p>
+            <a:pPr indent="0" marL="0">
+              <a:buNone/>
+            </a:pPr>
+            <a:r>
+              <a:rPr lang="en-US" sz="1000" b="1" dirty="0">
+                <a:solidFill>
+                  <a:schemeClr val="accent5"/>
+                </a:solidFill>
+              </a:rPr>
+              <a:t>Now: </a:t>
+            </a:r>
+            <a:pPr indent="0" marL="0">
+              <a:buNone/>
+            </a:pPr>
+            <a:r>
+              <a:rPr lang="en-US" sz="1000" dirty="0">
+                <a:solidFill>
+                  <a:schemeClr val="accent3"/>
+                </a:solidFill>
+              </a:rPr>
+              <a:t>about 1 in 4 calls</a:t>
+            </a:r>
+            <a:endParaRPr lang="en-US" sz="1100" dirty="0"/>
+          </a:p>
+        </p:txBody>
+      </p:sp>
+      <p:sp>
+        <p:nvSpPr>
+          <p:cNvPr id="24" name="measure 3"/>
+          <p:cNvSpPr/>
+          <p:nvPr/>
+        </p:nvSpPr>
+        <p:spPr>
+          <a:xfrm>
+            <a:off x="6096000" y="3977640"/>
+            <a:ext cx="2590800" cy="658368"/>
+          </a:xfrm>
+          <a:prstGeom prst="roundRect">
+            <a:avLst>
+              <a:gd name="adj" fmla="val 11111"/>
+            </a:avLst>
+          </a:prstGeom>
+          <a:solidFill>
+            <a:schemeClr val="accent4"/>
+          </a:solidFill>
+          <a:ln/>
+        </p:spPr>
+      </p:sp>
+      <p:sp>
+        <p:nvSpPr>
+          <p:cNvPr id="25" name="Text 22"/>
+          <p:cNvSpPr txBox="1"/>
+          <p:nvPr/>
+        </p:nvSpPr>
+        <p:spPr>
+          <a:xfrm>
+            <a:off x="6260592" y="3977640"/>
+            <a:ext cx="2316480" cy="658368"/>
+          </a:xfrm>
+          <a:prstGeom prst="rect">
+            <a:avLst/>
+          </a:prstGeom>
+          <a:noFill/>
+          <a:ln/>
+        </p:spPr>
+        <p:txBody>
+          <a:bodyPr wrap="square" lIns="0" tIns="0" rIns="0" bIns="0" rtlCol="0" anchor="ctr"/>
+          <a:lstStyle/>
+          <a:p>
+            <a:pPr indent="0" marL="0">
+              <a:buNone/>
+            </a:pPr>
+            <a:r>
+              <a:rPr lang="en-US" sz="1100" b="1" dirty="0">
+                <a:solidFill>
+                  <a:schemeClr val="tx1"/>
+                </a:solidFill>
+              </a:rPr>
+              <a:t>Wins from reactivated leads</a:t>
+            </a:r>
+            <a:endParaRPr lang="en-US" sz="1100" dirty="0"/>
+          </a:p>
+          <a:p>
+            <a:pPr indent="0" marL="0">
+              <a:buNone/>
+            </a:pPr>
+            <a:r>
+              <a:rPr lang="en-US" sz="1000" b="1" dirty="0">
+                <a:solidFill>
+                  <a:schemeClr val="accent5"/>
+                </a:solidFill>
+              </a:rPr>
+              <a:t>Now: </a:t>
+            </a:r>
+            <a:pPr indent="0" marL="0">
+              <a:buNone/>
+            </a:pPr>
+            <a:r>
+              <a:rPr lang="en-US" sz="1000" dirty="0">
+                <a:solidFill>
+                  <a:schemeClr val="accent3"/>
+                </a:solidFill>
+              </a:rPr>
+              <a:t>2 in Q2</a:t>
+            </a:r>
+            <a:endParaRPr lang="en-US" sz="1100" dirty="0"/>
+          </a:p>
+        </p:txBody>
+      </p:sp>
+      <p:sp>
+        <p:nvSpPr>
+          <p:cNvPr id="25" name="Slide Number Placeholder 0"/>
+          <p:cNvSpPr>
+            <a:spLocks noGrp="1"/>
+          </p:cNvSpPr>
+          <p:nvPr>
+            <p:ph type="sldNum" sz="quarter" idx="4294967295"/>
+          </p:nvPr>
+        </p:nvSpPr>
+        <p:spPr>
+          <a:xfrm>
+            <a:off x="8321040" y="4754880"/>
+            <a:ext cx="365760" cy="228600"/>
+          </a:xfrm>
+          <a:prstGeom prst="rect">
+            <a:avLst/>
+          </a:prstGeom>
+          <a:extLst>
+            <a:ext uri="{C572A759-6A51-4108-AA02-DFA0A04FC94B}">
+              <ma14:wrappingTextBoxFlag xmlns:ma14="http://schemas.microsoft.com/office/mac/drawingml/2011/main" val="0"/>
+            </a:ext>
+          </a:extLst>
+        </p:spPr>
+        <p:txBody>
+          <a:bodyPr/>
+          <a:lstStyle>
+            <a:lvl1pPr>
+              <a:defRPr sz="900">
+                <a:solidFill>
+                  <a:schemeClr val="accent3"/>
+                </a:solidFill>
+              </a:defRPr>
+            </a:lvl1pPr>
+          </a:lstStyle>
+          <a:p>
+            <a:pPr algn="r"/>
+            <a:fld id="{F7021451-1387-4CA6-816F-3879F97B5CBC}" type="slidenum">
+              <a:rPr b="0" lang="en-US"/>
+              <a:t>10</a:t>
+            </a:fld>
+            <a:endParaRPr lang="en-US"/>
+          </a:p>
+        </p:txBody>
+      </p:sp>
+    </p:spTree>
+  </p:cSld>
+  <p:clrMapOvr>
+    <a:masterClrMapping/>
+  </p:clrMapOvr>
+</p:sld>
+</file>
+
+<file path=ppt/slides/slide11.xml><?xml version="1.0" encoding="utf-8"?>
+<p:sld xmlns:a="http://schemas.openxmlformats.org/drawingml/2006/main" xmlns:r="http://schemas.openxmlformats.org/officeDocument/2006/relationships" xmlns:p="http://schemas.openxmlformats.org/presentationml/2006/main">
+  <p:cSld name="Slide 11">
+    <p:spTree>
+      <p:nvGrpSpPr>
+        <p:cNvPr id="1" name=""/>
+        <p:cNvGrpSpPr/>
+        <p:nvPr/>
+      </p:nvGrpSpPr>
+      <p:grpSpPr>
+        <a:xfrm>
+          <a:off x="0" y="0"/>
+          <a:ext cx="0" cy="0"/>
+          <a:chOff x="0" y="0"/>
+          <a:chExt cx="0" cy="0"/>
+        </a:xfrm>
+      </p:grpSpPr>
+      <p:sp>
+        <p:nvSpPr>
+          <p:cNvPr id="2" name="Text 1"/>
+          <p:cNvSpPr/>
+          <p:nvPr>
+            <p:ph idx="101" type="body" hasCustomPrompt="1"/>
+          </p:nvPr>
+        </p:nvSpPr>
+        <p:spPr>
+          <a:xfrm>
+            <a:off x="457200" y="320040"/>
+            <a:ext cx="8229600" cy="274320"/>
+          </a:xfrm>
+          <a:prstGeom prst="rect">
+            <a:avLst/>
+          </a:prstGeom>
+          <a:noFill/>
+          <a:ln/>
+        </p:spPr>
+        <p:txBody>
+          <a:bodyPr wrap="square" lIns="0" tIns="0" rIns="0" bIns="0" rtlCol="0" anchor="ctr"/>
+          <a:lstStyle/>
+          <a:p>
+            <a:pPr indent="0" marL="0">
+              <a:buNone/>
+            </a:pPr>
+            <a:r>
+              <a:rPr lang="en-US" sz="1100" b="1" spc="200" kern="0" dirty="0">
+                <a:solidFill>
+                  <a:schemeClr val="accent5"/>
+                </a:solidFill>
+              </a:rPr>
+              <a:t>ROCK 02  ·  SELL THE FULL LADDER</a:t>
+            </a:r>
+            <a:endParaRPr lang="en-US" sz="1100" dirty="0"/>
+          </a:p>
+        </p:txBody>
+      </p:sp>
+      <p:sp>
+        <p:nvSpPr>
+          <p:cNvPr id="3" name="Text 1"/>
+          <p:cNvSpPr/>
+          <p:nvPr>
+            <p:ph idx="102" type="title" hasCustomPrompt="1"/>
+          </p:nvPr>
+        </p:nvSpPr>
+        <p:spPr>
+          <a:xfrm>
+            <a:off x="457200" y="594360"/>
+            <a:ext cx="8229600" cy="548640"/>
+          </a:xfrm>
+          <a:prstGeom prst="rect">
+            <a:avLst/>
+          </a:prstGeom>
+          <a:noFill/>
+          <a:ln/>
+        </p:spPr>
+        <p:txBody>
+          <a:bodyPr wrap="square" lIns="0" tIns="0" rIns="0" bIns="0" rtlCol="0" anchor="ctr"/>
+          <a:lstStyle/>
+          <a:p>
+            <a:pPr algn="l" indent="0" marL="0">
+              <a:buNone/>
+            </a:pPr>
+            <a:r>
+              <a:rPr lang="en-US" sz="2600" b="1" dirty="0">
+                <a:solidFill>
+                  <a:schemeClr val="tx1"/>
+                </a:solidFill>
+              </a:rPr>
+              <a:t>Every client finds the right next step</a:t>
+            </a:r>
+            <a:endParaRPr lang="en-US" sz="2600" dirty="0"/>
+          </a:p>
+        </p:txBody>
+      </p:sp>
+      <p:sp>
+        <p:nvSpPr>
+          <p:cNvPr id="5" name="why now"/>
+          <p:cNvSpPr/>
+          <p:nvPr/>
+        </p:nvSpPr>
+        <p:spPr>
+          <a:xfrm>
+            <a:off x="457200" y="1325880"/>
+            <a:ext cx="2743200" cy="2240280"/>
+          </a:xfrm>
+          <a:prstGeom prst="roundRect">
+            <a:avLst>
+              <a:gd name="adj" fmla="val 3265"/>
+            </a:avLst>
+          </a:prstGeom>
+          <a:solidFill>
+            <a:schemeClr val="accent5"/>
+          </a:solidFill>
+          <a:ln/>
+        </p:spPr>
+      </p:sp>
+      <p:sp>
+        <p:nvSpPr>
+          <p:cNvPr id="6" name="Text 3"/>
+          <p:cNvSpPr txBox="1"/>
+          <p:nvPr/>
+        </p:nvSpPr>
+        <p:spPr>
+          <a:xfrm>
+            <a:off x="685800" y="1463040"/>
+            <a:ext cx="2286000" cy="228600"/>
+          </a:xfrm>
+          <a:prstGeom prst="rect">
+            <a:avLst/>
+          </a:prstGeom>
+          <a:noFill/>
+          <a:ln/>
+        </p:spPr>
+        <p:txBody>
+          <a:bodyPr wrap="square" lIns="0" tIns="0" rIns="0" bIns="0" rtlCol="0" anchor="ctr"/>
+          <a:lstStyle/>
+          <a:p>
+            <a:pPr indent="0" marL="0">
+              <a:buNone/>
+            </a:pPr>
+            <a:r>
+              <a:rPr lang="en-US" sz="1000" b="1" spc="100" kern="0" dirty="0">
+                <a:solidFill>
+                  <a:schemeClr val="bg1"/>
+                </a:solidFill>
+              </a:rPr>
+              <a:t>WHY NOW</a:t>
+            </a:r>
+            <a:endParaRPr lang="en-US" sz="1000" dirty="0"/>
+          </a:p>
+        </p:txBody>
+      </p:sp>
+      <p:sp>
+        <p:nvSpPr>
+          <p:cNvPr id="7" name="Text 4"/>
+          <p:cNvSpPr txBox="1"/>
+          <p:nvPr/>
+        </p:nvSpPr>
+        <p:spPr>
+          <a:xfrm>
+            <a:off x="685800" y="1691640"/>
+            <a:ext cx="2377440" cy="777240"/>
+          </a:xfrm>
+          <a:prstGeom prst="rect">
+            <a:avLst/>
+          </a:prstGeom>
+          <a:noFill/>
+          <a:ln/>
+        </p:spPr>
+        <p:txBody>
+          <a:bodyPr wrap="square" lIns="0" tIns="0" rIns="0" bIns="0" rtlCol="0" anchor="ctr"/>
+          <a:lstStyle/>
+          <a:p>
+            <a:pPr indent="0" marL="0">
+              <a:buNone/>
+            </a:pPr>
+            <a:r>
+              <a:rPr lang="en-US" sz="4800" b="1" dirty="0">
+                <a:solidFill>
+                  <a:schemeClr val="bg1"/>
+                </a:solidFill>
+              </a:rPr>
+              <a:t>5</a:t>
+            </a:r>
+            <a:endParaRPr lang="en-US" sz="4800" dirty="0"/>
+          </a:p>
+        </p:txBody>
+      </p:sp>
+      <p:sp>
+        <p:nvSpPr>
+          <p:cNvPr id="8" name="Text 5"/>
+          <p:cNvSpPr txBox="1"/>
+          <p:nvPr/>
+        </p:nvSpPr>
+        <p:spPr>
+          <a:xfrm>
+            <a:off x="685800" y="2514600"/>
+            <a:ext cx="2377440" cy="960120"/>
+          </a:xfrm>
+          <a:prstGeom prst="rect">
+            <a:avLst/>
+          </a:prstGeom>
+          <a:noFill/>
+          <a:ln/>
+        </p:spPr>
+        <p:txBody>
+          <a:bodyPr wrap="square" lIns="0" tIns="0" rIns="0" bIns="0" rtlCol="0" anchor="t"/>
+          <a:lstStyle/>
+          <a:p>
+            <a:pPr indent="0" marL="0">
+              <a:buNone/>
+            </a:pPr>
+            <a:r>
+              <a:rPr lang="en-US" sz="1200" dirty="0">
+                <a:solidFill>
+                  <a:schemeClr val="bg1"/>
+                </a:solidFill>
+              </a:rPr>
+              <a:t>Angel Essentials clients in the first month of the pilot. The ladder works, now every product needs its first clients.</a:t>
+            </a:r>
+            <a:endParaRPr lang="en-US" sz="1200" dirty="0"/>
+          </a:p>
+        </p:txBody>
+      </p:sp>
+      <p:sp>
+        <p:nvSpPr>
+          <p:cNvPr id="9" name="Text 6"/>
+          <p:cNvSpPr txBox="1"/>
+          <p:nvPr/>
+        </p:nvSpPr>
+        <p:spPr>
+          <a:xfrm>
+            <a:off x="3474720" y="1325880"/>
+            <a:ext cx="3657600" cy="228600"/>
+          </a:xfrm>
+          <a:prstGeom prst="rect">
+            <a:avLst/>
+          </a:prstGeom>
+          <a:noFill/>
+          <a:ln/>
+        </p:spPr>
+        <p:txBody>
+          <a:bodyPr wrap="square" lIns="0" tIns="0" rIns="0" bIns="0" rtlCol="0" anchor="ctr"/>
+          <a:lstStyle/>
+          <a:p>
+            <a:pPr indent="0" marL="0">
+              <a:buNone/>
+            </a:pPr>
+            <a:r>
+              <a:rPr lang="en-US" sz="1000" b="1" spc="100" kern="0" dirty="0">
+                <a:solidFill>
+                  <a:schemeClr val="accent5"/>
+                </a:solidFill>
+              </a:rPr>
+              <a:t>WHAT WE'LL DO</a:t>
+            </a:r>
+            <a:endParaRPr lang="en-US" sz="1000" dirty="0"/>
+          </a:p>
+        </p:txBody>
+      </p:sp>
+      <p:sp>
+        <p:nvSpPr>
+          <p:cNvPr id="10" name="step 1"/>
+          <p:cNvSpPr/>
+          <p:nvPr/>
+        </p:nvSpPr>
+        <p:spPr>
+          <a:xfrm>
+            <a:off x="3474720" y="1700784"/>
+            <a:ext cx="384048" cy="384048"/>
+          </a:xfrm>
+          <a:prstGeom prst="ellipse">
+            <a:avLst/>
+          </a:prstGeom>
+          <a:solidFill>
+            <a:schemeClr val="accent1"/>
+          </a:solidFill>
+          <a:ln/>
+        </p:spPr>
+      </p:sp>
+      <p:sp>
+        <p:nvSpPr>
+          <p:cNvPr id="11" name="Text 8"/>
+          <p:cNvSpPr txBox="1"/>
+          <p:nvPr/>
+        </p:nvSpPr>
+        <p:spPr>
+          <a:xfrm>
+            <a:off x="3474720" y="1700784"/>
+            <a:ext cx="384048" cy="384048"/>
+          </a:xfrm>
+          <a:prstGeom prst="rect">
+            <a:avLst/>
+          </a:prstGeom>
+          <a:noFill/>
+          <a:ln/>
+        </p:spPr>
+        <p:txBody>
+          <a:bodyPr wrap="square" lIns="0" tIns="0" rIns="0" bIns="0" rtlCol="0" anchor="ctr"/>
+          <a:lstStyle/>
+          <a:p>
+            <a:pPr algn="ctr" indent="0" marL="0">
+              <a:buNone/>
+            </a:pPr>
+            <a:r>
+              <a:rPr lang="en-US" sz="1300" b="1" dirty="0">
+                <a:solidFill>
+                  <a:schemeClr val="bg1"/>
+                </a:solidFill>
+              </a:rPr>
+              <a:t>1</a:t>
+            </a:r>
+            <a:endParaRPr lang="en-US" sz="1300" dirty="0"/>
+          </a:p>
+        </p:txBody>
+      </p:sp>
+      <p:sp>
+        <p:nvSpPr>
+          <p:cNvPr id="12" name="Text 9"/>
+          <p:cNvSpPr txBox="1"/>
+          <p:nvPr/>
+        </p:nvSpPr>
+        <p:spPr>
+          <a:xfrm>
+            <a:off x="4023360" y="1627632"/>
+            <a:ext cx="4663440" cy="530352"/>
+          </a:xfrm>
+          <a:prstGeom prst="rect">
+            <a:avLst/>
+          </a:prstGeom>
+          <a:noFill/>
+          <a:ln/>
+        </p:spPr>
+        <p:txBody>
+          <a:bodyPr wrap="square" lIns="0" tIns="0" rIns="0" bIns="0" rtlCol="0" anchor="ctr"/>
+          <a:lstStyle/>
+          <a:p>
+            <a:pPr indent="0" marL="0">
+              <a:buNone/>
+            </a:pPr>
+            <a:r>
+              <a:rPr lang="en-US" sz="1300" b="1" dirty="0">
+                <a:solidFill>
+                  <a:schemeClr val="tx1"/>
+                </a:solidFill>
+              </a:rPr>
+              <a:t>Lead every qualified call with the $500 Freedom Plan</a:t>
+            </a:r>
+            <a:endParaRPr lang="en-US" sz="1300" dirty="0"/>
+          </a:p>
+        </p:txBody>
+      </p:sp>
+      <p:sp>
+        <p:nvSpPr>
+          <p:cNvPr id="13" name="step 2"/>
+          <p:cNvSpPr/>
+          <p:nvPr/>
+        </p:nvSpPr>
+        <p:spPr>
+          <a:xfrm>
+            <a:off x="3474720" y="2359152"/>
+            <a:ext cx="384048" cy="384048"/>
+          </a:xfrm>
+          <a:prstGeom prst="ellipse">
+            <a:avLst/>
+          </a:prstGeom>
+          <a:solidFill>
+            <a:schemeClr val="accent1"/>
+          </a:solidFill>
+          <a:ln/>
+        </p:spPr>
+      </p:sp>
+      <p:sp>
+        <p:nvSpPr>
+          <p:cNvPr id="14" name="Text 11"/>
+          <p:cNvSpPr txBox="1"/>
+          <p:nvPr/>
+        </p:nvSpPr>
+        <p:spPr>
+          <a:xfrm>
+            <a:off x="3474720" y="2359152"/>
+            <a:ext cx="384048" cy="384048"/>
+          </a:xfrm>
+          <a:prstGeom prst="rect">
+            <a:avLst/>
+          </a:prstGeom>
+          <a:noFill/>
+          <a:ln/>
+        </p:spPr>
+        <p:txBody>
+          <a:bodyPr wrap="square" lIns="0" tIns="0" rIns="0" bIns="0" rtlCol="0" anchor="ctr"/>
+          <a:lstStyle/>
+          <a:p>
+            <a:pPr algn="ctr" indent="0" marL="0">
+              <a:buNone/>
+            </a:pPr>
+            <a:r>
+              <a:rPr lang="en-US" sz="1300" b="1" dirty="0">
+                <a:solidFill>
+                  <a:schemeClr val="bg1"/>
+                </a:solidFill>
+              </a:rPr>
+              <a:t>2</a:t>
+            </a:r>
+            <a:endParaRPr lang="en-US" sz="1300" dirty="0"/>
+          </a:p>
+        </p:txBody>
+      </p:sp>
+      <p:sp>
+        <p:nvSpPr>
+          <p:cNvPr id="15" name="Text 12"/>
+          <p:cNvSpPr txBox="1"/>
+          <p:nvPr/>
+        </p:nvSpPr>
+        <p:spPr>
+          <a:xfrm>
+            <a:off x="4023360" y="2286000"/>
+            <a:ext cx="4663440" cy="530352"/>
+          </a:xfrm>
+          <a:prstGeom prst="rect">
+            <a:avLst/>
+          </a:prstGeom>
+          <a:noFill/>
+          <a:ln/>
+        </p:spPr>
+        <p:txBody>
+          <a:bodyPr wrap="square" lIns="0" tIns="0" rIns="0" bIns="0" rtlCol="0" anchor="ctr"/>
+          <a:lstStyle/>
+          <a:p>
+            <a:pPr indent="0" marL="0">
+              <a:buNone/>
+            </a:pPr>
+            <a:r>
+              <a:rPr lang="en-US" sz="1300" b="1" dirty="0">
+                <a:solidFill>
+                  <a:schemeClr val="tx1"/>
+                </a:solidFill>
+              </a:rPr>
+              <a:t>Close the first Fractional Partner clients and launch OAX100</a:t>
+            </a:r>
+            <a:endParaRPr lang="en-US" sz="1300" dirty="0"/>
+          </a:p>
+        </p:txBody>
+      </p:sp>
+      <p:sp>
+        <p:nvSpPr>
+          <p:cNvPr id="16" name="step 3"/>
+          <p:cNvSpPr/>
+          <p:nvPr/>
+        </p:nvSpPr>
+        <p:spPr>
+          <a:xfrm>
+            <a:off x="3474720" y="3017520"/>
+            <a:ext cx="384048" cy="384048"/>
+          </a:xfrm>
+          <a:prstGeom prst="ellipse">
+            <a:avLst/>
+          </a:prstGeom>
+          <a:solidFill>
+            <a:schemeClr val="accent1"/>
+          </a:solidFill>
+          <a:ln/>
+        </p:spPr>
+      </p:sp>
+      <p:sp>
+        <p:nvSpPr>
+          <p:cNvPr id="17" name="Text 14"/>
+          <p:cNvSpPr txBox="1"/>
+          <p:nvPr/>
+        </p:nvSpPr>
+        <p:spPr>
+          <a:xfrm>
+            <a:off x="3474720" y="3017520"/>
+            <a:ext cx="384048" cy="384048"/>
+          </a:xfrm>
+          <a:prstGeom prst="rect">
+            <a:avLst/>
+          </a:prstGeom>
+          <a:noFill/>
+          <a:ln/>
+        </p:spPr>
+        <p:txBody>
+          <a:bodyPr wrap="square" lIns="0" tIns="0" rIns="0" bIns="0" rtlCol="0" anchor="ctr"/>
+          <a:lstStyle/>
+          <a:p>
+            <a:pPr algn="ctr" indent="0" marL="0">
+              <a:buNone/>
+            </a:pPr>
+            <a:r>
+              <a:rPr lang="en-US" sz="1300" b="1" dirty="0">
+                <a:solidFill>
+                  <a:schemeClr val="bg1"/>
+                </a:solidFill>
+              </a:rPr>
+              <a:t>3</a:t>
+            </a:r>
+            <a:endParaRPr lang="en-US" sz="1300" dirty="0"/>
+          </a:p>
+        </p:txBody>
+      </p:sp>
+      <p:sp>
+        <p:nvSpPr>
+          <p:cNvPr id="18" name="Text 15"/>
+          <p:cNvSpPr txBox="1"/>
+          <p:nvPr/>
+        </p:nvSpPr>
+        <p:spPr>
+          <a:xfrm>
+            <a:off x="4023360" y="2944368"/>
+            <a:ext cx="4663440" cy="530352"/>
+          </a:xfrm>
+          <a:prstGeom prst="rect">
+            <a:avLst/>
+          </a:prstGeom>
+          <a:noFill/>
+          <a:ln/>
+        </p:spPr>
+        <p:txBody>
+          <a:bodyPr wrap="square" lIns="0" tIns="0" rIns="0" bIns="0" rtlCol="0" anchor="ctr"/>
+          <a:lstStyle/>
+          <a:p>
+            <a:pPr indent="0" marL="0">
+              <a:buNone/>
+            </a:pPr>
+            <a:r>
+              <a:rPr lang="en-US" sz="1300" b="1" dirty="0">
+                <a:solidFill>
+                  <a:schemeClr val="tx1"/>
+                </a:solidFill>
+              </a:rPr>
+              <a:t>Review the Essentials pilot and grow Angel #2 and upgrades</a:t>
+            </a:r>
+            <a:endParaRPr lang="en-US" sz="1300" dirty="0"/>
+          </a:p>
+        </p:txBody>
+      </p:sp>
+      <p:sp>
+        <p:nvSpPr>
+          <p:cNvPr id="19" name="Text 16"/>
+          <p:cNvSpPr txBox="1"/>
+          <p:nvPr/>
+        </p:nvSpPr>
+        <p:spPr>
+          <a:xfrm>
+            <a:off x="457200" y="3703320"/>
+            <a:ext cx="3657600" cy="228600"/>
+          </a:xfrm>
+          <a:prstGeom prst="rect">
+            <a:avLst/>
+          </a:prstGeom>
+          <a:noFill/>
+          <a:ln/>
+        </p:spPr>
+        <p:txBody>
+          <a:bodyPr wrap="square" lIns="0" tIns="0" rIns="0" bIns="0" rtlCol="0" anchor="ctr"/>
+          <a:lstStyle/>
+          <a:p>
+            <a:pPr indent="0" marL="0">
+              <a:buNone/>
+            </a:pPr>
+            <a:r>
+              <a:rPr lang="en-US" sz="1000" b="1" spc="100" kern="0" dirty="0">
+                <a:solidFill>
+                  <a:schemeClr val="accent5"/>
+                </a:solidFill>
+              </a:rPr>
+              <a:t>HOW WE'LL MEASURE</a:t>
+            </a:r>
+            <a:endParaRPr lang="en-US" sz="1000" dirty="0"/>
+          </a:p>
+        </p:txBody>
+      </p:sp>
+      <p:sp>
+        <p:nvSpPr>
+          <p:cNvPr id="20" name="measure 1"/>
+          <p:cNvSpPr/>
+          <p:nvPr/>
+        </p:nvSpPr>
+        <p:spPr>
+          <a:xfrm>
+            <a:off x="457200" y="3977640"/>
+            <a:ext cx="2590800" cy="658368"/>
+          </a:xfrm>
+          <a:prstGeom prst="roundRect">
+            <a:avLst>
+              <a:gd name="adj" fmla="val 11111"/>
+            </a:avLst>
+          </a:prstGeom>
+          <a:solidFill>
+            <a:schemeClr val="accent4"/>
+          </a:solidFill>
+          <a:ln/>
+        </p:spPr>
+      </p:sp>
+      <p:sp>
+        <p:nvSpPr>
+          <p:cNvPr id="21" name="Text 18"/>
+          <p:cNvSpPr txBox="1"/>
+          <p:nvPr/>
+        </p:nvSpPr>
+        <p:spPr>
+          <a:xfrm>
+            <a:off x="621792" y="3977640"/>
+            <a:ext cx="2316480" cy="658368"/>
+          </a:xfrm>
+          <a:prstGeom prst="rect">
+            <a:avLst/>
+          </a:prstGeom>
+          <a:noFill/>
+          <a:ln/>
+        </p:spPr>
+        <p:txBody>
+          <a:bodyPr wrap="square" lIns="0" tIns="0" rIns="0" bIns="0" rtlCol="0" anchor="ctr"/>
+          <a:lstStyle/>
+          <a:p>
+            <a:pPr indent="0" marL="0">
+              <a:buNone/>
+            </a:pPr>
+            <a:r>
+              <a:rPr lang="en-US" sz="1100" b="1" dirty="0">
+                <a:solidFill>
+                  <a:schemeClr val="tx1"/>
+                </a:solidFill>
+              </a:rPr>
+              <a:t>Sales by product, every month</a:t>
+            </a:r>
+            <a:endParaRPr lang="en-US" sz="1100" dirty="0"/>
+          </a:p>
+          <a:p>
+            <a:pPr indent="0" marL="0">
+              <a:buNone/>
+            </a:pPr>
+            <a:r>
+              <a:rPr lang="en-US" sz="1000" b="1" dirty="0">
+                <a:solidFill>
+                  <a:schemeClr val="accent5"/>
+                </a:solidFill>
+              </a:rPr>
+              <a:t>Now: </a:t>
+            </a:r>
+            <a:pPr indent="0" marL="0">
+              <a:buNone/>
+            </a:pPr>
+            <a:r>
+              <a:rPr lang="en-US" sz="1000" dirty="0">
+                <a:solidFill>
+                  <a:schemeClr val="accent3"/>
+                </a:solidFill>
+              </a:rPr>
+              <a:t>not tracked yet</a:t>
+            </a:r>
+            <a:endParaRPr lang="en-US" sz="1100" dirty="0"/>
+          </a:p>
+        </p:txBody>
+      </p:sp>
+      <p:sp>
+        <p:nvSpPr>
+          <p:cNvPr id="22" name="measure 2"/>
+          <p:cNvSpPr/>
+          <p:nvPr/>
+        </p:nvSpPr>
+        <p:spPr>
+          <a:xfrm>
+            <a:off x="3276600" y="3977640"/>
+            <a:ext cx="2590800" cy="658368"/>
+          </a:xfrm>
+          <a:prstGeom prst="roundRect">
+            <a:avLst>
+              <a:gd name="adj" fmla="val 11111"/>
+            </a:avLst>
+          </a:prstGeom>
+          <a:solidFill>
+            <a:schemeClr val="accent4"/>
+          </a:solidFill>
+          <a:ln/>
+        </p:spPr>
+      </p:sp>
+      <p:sp>
+        <p:nvSpPr>
+          <p:cNvPr id="23" name="Text 20"/>
+          <p:cNvSpPr txBox="1"/>
+          <p:nvPr/>
+        </p:nvSpPr>
+        <p:spPr>
+          <a:xfrm>
+            <a:off x="3441192" y="3977640"/>
+            <a:ext cx="2316480" cy="658368"/>
+          </a:xfrm>
+          <a:prstGeom prst="rect">
+            <a:avLst/>
+          </a:prstGeom>
+          <a:noFill/>
+          <a:ln/>
+        </p:spPr>
+        <p:txBody>
+          <a:bodyPr wrap="square" lIns="0" tIns="0" rIns="0" bIns="0" rtlCol="0" anchor="ctr"/>
+          <a:lstStyle/>
+          <a:p>
+            <a:pPr indent="0" marL="0">
+              <a:buNone/>
+            </a:pPr>
+            <a:r>
+              <a:rPr lang="en-US" sz="1100" b="1" dirty="0">
+                <a:solidFill>
+                  <a:schemeClr val="tx1"/>
+                </a:solidFill>
+              </a:rPr>
+              <a:t>First Fractional + OAX100 sales</a:t>
+            </a:r>
+            <a:endParaRPr lang="en-US" sz="1100" dirty="0"/>
+          </a:p>
+          <a:p>
+            <a:pPr indent="0" marL="0">
+              <a:buNone/>
+            </a:pPr>
+            <a:r>
+              <a:rPr lang="en-US" sz="1000" b="1" dirty="0">
+                <a:solidFill>
+                  <a:schemeClr val="accent5"/>
+                </a:solidFill>
+              </a:rPr>
+              <a:t>Now: </a:t>
+            </a:r>
+            <a:pPr indent="0" marL="0">
+              <a:buNone/>
+            </a:pPr>
+            <a:r>
+              <a:rPr lang="en-US" sz="1000" dirty="0">
+                <a:solidFill>
+                  <a:schemeClr val="accent3"/>
+                </a:solidFill>
+              </a:rPr>
+              <a:t>1 proposal out</a:t>
+            </a:r>
+            <a:endParaRPr lang="en-US" sz="1100" dirty="0"/>
+          </a:p>
+        </p:txBody>
+      </p:sp>
+      <p:sp>
+        <p:nvSpPr>
+          <p:cNvPr id="24" name="measure 3"/>
+          <p:cNvSpPr/>
+          <p:nvPr/>
+        </p:nvSpPr>
+        <p:spPr>
+          <a:xfrm>
+            <a:off x="6096000" y="3977640"/>
+            <a:ext cx="2590800" cy="658368"/>
+          </a:xfrm>
+          <a:prstGeom prst="roundRect">
+            <a:avLst>
+              <a:gd name="adj" fmla="val 11111"/>
+            </a:avLst>
+          </a:prstGeom>
+          <a:solidFill>
+            <a:schemeClr val="accent4"/>
+          </a:solidFill>
+          <a:ln/>
+        </p:spPr>
+      </p:sp>
+      <p:sp>
+        <p:nvSpPr>
+          <p:cNvPr id="25" name="Text 22"/>
+          <p:cNvSpPr txBox="1"/>
+          <p:nvPr/>
+        </p:nvSpPr>
+        <p:spPr>
+          <a:xfrm>
+            <a:off x="6260592" y="3977640"/>
+            <a:ext cx="2316480" cy="658368"/>
+          </a:xfrm>
+          <a:prstGeom prst="rect">
+            <a:avLst/>
+          </a:prstGeom>
+          <a:noFill/>
+          <a:ln/>
+        </p:spPr>
+        <p:txBody>
+          <a:bodyPr wrap="square" lIns="0" tIns="0" rIns="0" bIns="0" rtlCol="0" anchor="ctr"/>
+          <a:lstStyle/>
+          <a:p>
+            <a:pPr indent="0" marL="0">
+              <a:buNone/>
+            </a:pPr>
+            <a:r>
+              <a:rPr lang="en-US" sz="1100" b="1" dirty="0">
+                <a:solidFill>
+                  <a:schemeClr val="tx1"/>
+                </a:solidFill>
+              </a:rPr>
+              <a:t>Upgrades and Angel #2</a:t>
+            </a:r>
+            <a:endParaRPr lang="en-US" sz="1100" dirty="0"/>
+          </a:p>
+          <a:p>
+            <a:pPr indent="0" marL="0">
+              <a:buNone/>
+            </a:pPr>
+            <a:r>
+              <a:rPr lang="en-US" sz="1000" b="1" dirty="0">
+                <a:solidFill>
+                  <a:schemeClr val="accent5"/>
+                </a:solidFill>
+              </a:rPr>
+              <a:t>Now: </a:t>
+            </a:r>
+            <a:pPr indent="0" marL="0">
+              <a:buNone/>
+            </a:pPr>
+            <a:r>
+              <a:rPr lang="en-US" sz="1000" dirty="0">
+                <a:solidFill>
+                  <a:schemeClr val="accent3"/>
+                </a:solidFill>
+              </a:rPr>
+              <a:t>1 upgrade in talks</a:t>
+            </a:r>
+            <a:endParaRPr lang="en-US" sz="1100" dirty="0"/>
+          </a:p>
+        </p:txBody>
+      </p:sp>
+      <p:sp>
+        <p:nvSpPr>
+          <p:cNvPr id="25" name="Slide Number Placeholder 0"/>
+          <p:cNvSpPr>
+            <a:spLocks noGrp="1"/>
+          </p:cNvSpPr>
+          <p:nvPr>
+            <p:ph type="sldNum" sz="quarter" idx="4294967295"/>
+          </p:nvPr>
+        </p:nvSpPr>
+        <p:spPr>
+          <a:xfrm>
+            <a:off x="8321040" y="4754880"/>
+            <a:ext cx="365760" cy="228600"/>
+          </a:xfrm>
+          <a:prstGeom prst="rect">
+            <a:avLst/>
+          </a:prstGeom>
+          <a:extLst>
+            <a:ext uri="{C572A759-6A51-4108-AA02-DFA0A04FC94B}">
+              <ma14:wrappingTextBoxFlag xmlns:ma14="http://schemas.microsoft.com/office/mac/drawingml/2011/main" val="0"/>
+            </a:ext>
+          </a:extLst>
+        </p:spPr>
+        <p:txBody>
+          <a:bodyPr/>
+          <a:lstStyle>
+            <a:lvl1pPr>
+              <a:defRPr sz="900">
+                <a:solidFill>
+                  <a:schemeClr val="accent3"/>
+                </a:solidFill>
+              </a:defRPr>
+            </a:lvl1pPr>
+          </a:lstStyle>
+          <a:p>
+            <a:pPr algn="r"/>
+            <a:fld id="{F7021451-1387-4CA6-816F-3879F97B5CBC}" type="slidenum">
+              <a:rPr b="0" lang="en-US"/>
+              <a:t>11</a:t>
+            </a:fld>
+            <a:endParaRPr lang="en-US"/>
+          </a:p>
+        </p:txBody>
+      </p:sp>
+    </p:spTree>
+  </p:cSld>
+  <p:clrMapOvr>
+    <a:masterClrMapping/>
+  </p:clrMapOvr>
+</p:sld>
+</file>
+
+<file path=ppt/slides/slide12.xml><?xml version="1.0" encoding="utf-8"?>
+<p:sld xmlns:a="http://schemas.openxmlformats.org/drawingml/2006/main" xmlns:r="http://schemas.openxmlformats.org/officeDocument/2006/relationships" xmlns:p="http://schemas.openxmlformats.org/presentationml/2006/main">
+  <p:cSld name="Slide 12">
+    <p:spTree>
+      <p:nvGrpSpPr>
+        <p:cNvPr id="1" name=""/>
+        <p:cNvGrpSpPr/>
+        <p:nvPr/>
+      </p:nvGrpSpPr>
+      <p:grpSpPr>
+        <a:xfrm>
+          <a:off x="0" y="0"/>
+          <a:ext cx="0" cy="0"/>
+          <a:chOff x="0" y="0"/>
+          <a:chExt cx="0" cy="0"/>
+        </a:xfrm>
+      </p:grpSpPr>
+      <p:sp>
+        <p:nvSpPr>
+          <p:cNvPr id="2" name="Text 1"/>
+          <p:cNvSpPr/>
+          <p:nvPr>
+            <p:ph idx="101" type="body" hasCustomPrompt="1"/>
+          </p:nvPr>
+        </p:nvSpPr>
+        <p:spPr>
+          <a:xfrm>
+            <a:off x="457200" y="320040"/>
+            <a:ext cx="8229600" cy="274320"/>
+          </a:xfrm>
+          <a:prstGeom prst="rect">
+            <a:avLst/>
+          </a:prstGeom>
+          <a:noFill/>
+          <a:ln/>
+        </p:spPr>
+        <p:txBody>
+          <a:bodyPr wrap="square" lIns="0" tIns="0" rIns="0" bIns="0" rtlCol="0" anchor="ctr"/>
+          <a:lstStyle/>
+          <a:p>
+            <a:pPr indent="0" marL="0">
+              <a:buNone/>
+            </a:pPr>
+            <a:r>
+              <a:rPr lang="en-US" sz="1100" b="1" spc="200" kern="0" dirty="0">
+                <a:solidFill>
+                  <a:schemeClr val="accent5"/>
+                </a:solidFill>
+              </a:rPr>
+              <a:t>ROCK 03  ·  SEE THE NUMBERS</a:t>
+            </a:r>
+            <a:endParaRPr lang="en-US" sz="1100" dirty="0"/>
+          </a:p>
+        </p:txBody>
+      </p:sp>
+      <p:sp>
+        <p:nvSpPr>
+          <p:cNvPr id="3" name="Text 1"/>
+          <p:cNvSpPr/>
+          <p:nvPr>
+            <p:ph idx="102" type="title" hasCustomPrompt="1"/>
+          </p:nvPr>
+        </p:nvSpPr>
+        <p:spPr>
+          <a:xfrm>
+            <a:off x="457200" y="594360"/>
+            <a:ext cx="8229600" cy="548640"/>
+          </a:xfrm>
+          <a:prstGeom prst="rect">
+            <a:avLst/>
+          </a:prstGeom>
+          <a:noFill/>
+          <a:ln/>
+        </p:spPr>
+        <p:txBody>
+          <a:bodyPr wrap="square" lIns="0" tIns="0" rIns="0" bIns="0" rtlCol="0" anchor="ctr"/>
+          <a:lstStyle/>
+          <a:p>
+            <a:pPr algn="l" indent="0" marL="0">
+              <a:buNone/>
+            </a:pPr>
+            <a:r>
+              <a:rPr lang="en-US" sz="2600" b="1" dirty="0">
+                <a:solidFill>
+                  <a:schemeClr val="tx1"/>
+                </a:solidFill>
+              </a:rPr>
+              <a:t>Sales data everyone can see and use</a:t>
+            </a:r>
+            <a:endParaRPr lang="en-US" sz="2600" dirty="0"/>
+          </a:p>
+        </p:txBody>
+      </p:sp>
+      <p:sp>
+        <p:nvSpPr>
+          <p:cNvPr id="5" name="why now"/>
+          <p:cNvSpPr/>
+          <p:nvPr/>
+        </p:nvSpPr>
+        <p:spPr>
+          <a:xfrm>
+            <a:off x="457200" y="1325880"/>
+            <a:ext cx="2743200" cy="2240280"/>
+          </a:xfrm>
+          <a:prstGeom prst="roundRect">
+            <a:avLst>
+              <a:gd name="adj" fmla="val 3265"/>
+            </a:avLst>
+          </a:prstGeom>
+          <a:solidFill>
+            <a:schemeClr val="accent5"/>
+          </a:solidFill>
+          <a:ln/>
+        </p:spPr>
+      </p:sp>
+      <p:sp>
+        <p:nvSpPr>
+          <p:cNvPr id="6" name="Text 3"/>
+          <p:cNvSpPr txBox="1"/>
+          <p:nvPr/>
+        </p:nvSpPr>
+        <p:spPr>
+          <a:xfrm>
+            <a:off x="685800" y="1463040"/>
+            <a:ext cx="2286000" cy="228600"/>
+          </a:xfrm>
+          <a:prstGeom prst="rect">
+            <a:avLst/>
+          </a:prstGeom>
+          <a:noFill/>
+          <a:ln/>
+        </p:spPr>
+        <p:txBody>
+          <a:bodyPr wrap="square" lIns="0" tIns="0" rIns="0" bIns="0" rtlCol="0" anchor="ctr"/>
+          <a:lstStyle/>
+          <a:p>
+            <a:pPr indent="0" marL="0">
+              <a:buNone/>
+            </a:pPr>
+            <a:r>
+              <a:rPr lang="en-US" sz="1000" b="1" spc="100" kern="0" dirty="0">
+                <a:solidFill>
+                  <a:schemeClr val="bg1"/>
+                </a:solidFill>
+              </a:rPr>
+              <a:t>WHY NOW</a:t>
+            </a:r>
+            <a:endParaRPr lang="en-US" sz="1000" dirty="0"/>
+          </a:p>
+        </p:txBody>
+      </p:sp>
+      <p:sp>
+        <p:nvSpPr>
+          <p:cNvPr id="7" name="Text 4"/>
+          <p:cNvSpPr txBox="1"/>
+          <p:nvPr/>
+        </p:nvSpPr>
+        <p:spPr>
+          <a:xfrm>
+            <a:off x="685800" y="1691640"/>
+            <a:ext cx="2377440" cy="777240"/>
+          </a:xfrm>
+          <a:prstGeom prst="rect">
+            <a:avLst/>
+          </a:prstGeom>
+          <a:noFill/>
+          <a:ln/>
+        </p:spPr>
+        <p:txBody>
+          <a:bodyPr wrap="square" lIns="0" tIns="0" rIns="0" bIns="0" rtlCol="0" anchor="ctr"/>
+          <a:lstStyle/>
+          <a:p>
+            <a:pPr indent="0" marL="0">
+              <a:buNone/>
+            </a:pPr>
+            <a:r>
+              <a:rPr lang="en-US" sz="3600" b="1" dirty="0">
+                <a:solidFill>
+                  <a:schemeClr val="bg1"/>
+                </a:solidFill>
+              </a:rPr>
+              <a:t>0 of 60</a:t>
+            </a:r>
+            <a:endParaRPr lang="en-US" sz="3600" dirty="0"/>
+          </a:p>
+        </p:txBody>
+      </p:sp>
+      <p:sp>
+        <p:nvSpPr>
+          <p:cNvPr id="8" name="Text 5"/>
+          <p:cNvSpPr txBox="1"/>
+          <p:nvPr/>
+        </p:nvSpPr>
+        <p:spPr>
+          <a:xfrm>
+            <a:off x="685800" y="2514600"/>
+            <a:ext cx="2377440" cy="960120"/>
+          </a:xfrm>
+          <a:prstGeom prst="rect">
+            <a:avLst/>
+          </a:prstGeom>
+          <a:noFill/>
+          <a:ln/>
+        </p:spPr>
+        <p:txBody>
+          <a:bodyPr wrap="square" lIns="0" tIns="0" rIns="0" bIns="0" rtlCol="0" anchor="t"/>
+          <a:lstStyle/>
+          <a:p>
+            <a:pPr indent="0" marL="0">
+              <a:buNone/>
+            </a:pPr>
+            <a:r>
+              <a:rPr lang="en-US" sz="1200" dirty="0">
+                <a:solidFill>
+                  <a:schemeClr val="bg1"/>
+                </a:solidFill>
+              </a:rPr>
+              <a:t>Q2 calls had a lost reason recorded in the CRM. Our insight lives in notes, not data.</a:t>
+            </a:r>
+            <a:endParaRPr lang="en-US" sz="1200" dirty="0"/>
+          </a:p>
+        </p:txBody>
+      </p:sp>
+      <p:sp>
+        <p:nvSpPr>
+          <p:cNvPr id="9" name="Text 6"/>
+          <p:cNvSpPr txBox="1"/>
+          <p:nvPr/>
+        </p:nvSpPr>
+        <p:spPr>
+          <a:xfrm>
+            <a:off x="3474720" y="1325880"/>
+            <a:ext cx="3657600" cy="228600"/>
+          </a:xfrm>
+          <a:prstGeom prst="rect">
+            <a:avLst/>
+          </a:prstGeom>
+          <a:noFill/>
+          <a:ln/>
+        </p:spPr>
+        <p:txBody>
+          <a:bodyPr wrap="square" lIns="0" tIns="0" rIns="0" bIns="0" rtlCol="0" anchor="ctr"/>
+          <a:lstStyle/>
+          <a:p>
+            <a:pPr indent="0" marL="0">
+              <a:buNone/>
+            </a:pPr>
+            <a:r>
+              <a:rPr lang="en-US" sz="1000" b="1" spc="100" kern="0" dirty="0">
+                <a:solidFill>
+                  <a:schemeClr val="accent5"/>
+                </a:solidFill>
+              </a:rPr>
+              <a:t>WHAT WE'LL DO</a:t>
+            </a:r>
+            <a:endParaRPr lang="en-US" sz="1000" dirty="0"/>
+          </a:p>
+        </p:txBody>
+      </p:sp>
+      <p:sp>
+        <p:nvSpPr>
+          <p:cNvPr id="10" name="step 1"/>
+          <p:cNvSpPr/>
+          <p:nvPr/>
+        </p:nvSpPr>
+        <p:spPr>
+          <a:xfrm>
+            <a:off x="3474720" y="1700784"/>
+            <a:ext cx="384048" cy="384048"/>
+          </a:xfrm>
+          <a:prstGeom prst="ellipse">
+            <a:avLst/>
+          </a:prstGeom>
+          <a:solidFill>
+            <a:schemeClr val="accent1"/>
+          </a:solidFill>
+          <a:ln/>
+        </p:spPr>
+      </p:sp>
+      <p:sp>
+        <p:nvSpPr>
+          <p:cNvPr id="11" name="Text 8"/>
+          <p:cNvSpPr txBox="1"/>
+          <p:nvPr/>
+        </p:nvSpPr>
+        <p:spPr>
+          <a:xfrm>
+            <a:off x="3474720" y="1700784"/>
+            <a:ext cx="384048" cy="384048"/>
+          </a:xfrm>
+          <a:prstGeom prst="rect">
+            <a:avLst/>
+          </a:prstGeom>
+          <a:noFill/>
+          <a:ln/>
+        </p:spPr>
+        <p:txBody>
+          <a:bodyPr wrap="square" lIns="0" tIns="0" rIns="0" bIns="0" rtlCol="0" anchor="ctr"/>
+          <a:lstStyle/>
+          <a:p>
+            <a:pPr algn="ctr" indent="0" marL="0">
+              <a:buNone/>
+            </a:pPr>
+            <a:r>
+              <a:rPr lang="en-US" sz="1300" b="1" dirty="0">
+                <a:solidFill>
+                  <a:schemeClr val="bg1"/>
+                </a:solidFill>
+              </a:rPr>
+              <a:t>1</a:t>
+            </a:r>
+            <a:endParaRPr lang="en-US" sz="1300" dirty="0"/>
+          </a:p>
+        </p:txBody>
+      </p:sp>
+      <p:sp>
+        <p:nvSpPr>
+          <p:cNvPr id="12" name="Text 9"/>
+          <p:cNvSpPr txBox="1"/>
+          <p:nvPr/>
+        </p:nvSpPr>
+        <p:spPr>
+          <a:xfrm>
+            <a:off x="4023360" y="1627632"/>
+            <a:ext cx="4663440" cy="530352"/>
+          </a:xfrm>
+          <a:prstGeom prst="rect">
+            <a:avLst/>
+          </a:prstGeom>
+          <a:noFill/>
+          <a:ln/>
+        </p:spPr>
+        <p:txBody>
+          <a:bodyPr wrap="square" lIns="0" tIns="0" rIns="0" bIns="0" rtlCol="0" anchor="ctr"/>
+          <a:lstStyle/>
+          <a:p>
+            <a:pPr indent="0" marL="0">
+              <a:buNone/>
+            </a:pPr>
+            <a:r>
+              <a:rPr lang="en-US" sz="1300" b="1" dirty="0">
+                <a:solidFill>
+                  <a:schemeClr val="tx1"/>
+                </a:solidFill>
+              </a:rPr>
+              <a:t>Finish the Sales dashboard (Claude + Notion + GHL)</a:t>
+            </a:r>
+            <a:endParaRPr lang="en-US" sz="1300" dirty="0"/>
+          </a:p>
+        </p:txBody>
+      </p:sp>
+      <p:sp>
+        <p:nvSpPr>
+          <p:cNvPr id="13" name="step 2"/>
+          <p:cNvSpPr/>
+          <p:nvPr/>
+        </p:nvSpPr>
+        <p:spPr>
+          <a:xfrm>
+            <a:off x="3474720" y="2359152"/>
+            <a:ext cx="384048" cy="384048"/>
+          </a:xfrm>
+          <a:prstGeom prst="ellipse">
+            <a:avLst/>
+          </a:prstGeom>
+          <a:solidFill>
+            <a:schemeClr val="accent1"/>
+          </a:solidFill>
+          <a:ln/>
+        </p:spPr>
+      </p:sp>
+      <p:sp>
+        <p:nvSpPr>
+          <p:cNvPr id="14" name="Text 11"/>
+          <p:cNvSpPr txBox="1"/>
+          <p:nvPr/>
+        </p:nvSpPr>
+        <p:spPr>
+          <a:xfrm>
+            <a:off x="3474720" y="2359152"/>
+            <a:ext cx="384048" cy="384048"/>
+          </a:xfrm>
+          <a:prstGeom prst="rect">
+            <a:avLst/>
+          </a:prstGeom>
+          <a:noFill/>
+          <a:ln/>
+        </p:spPr>
+        <p:txBody>
+          <a:bodyPr wrap="square" lIns="0" tIns="0" rIns="0" bIns="0" rtlCol="0" anchor="ctr"/>
+          <a:lstStyle/>
+          <a:p>
+            <a:pPr algn="ctr" indent="0" marL="0">
+              <a:buNone/>
+            </a:pPr>
+            <a:r>
+              <a:rPr lang="en-US" sz="1300" b="1" dirty="0">
+                <a:solidFill>
+                  <a:schemeClr val="bg1"/>
+                </a:solidFill>
+              </a:rPr>
+              <a:t>2</a:t>
+            </a:r>
+            <a:endParaRPr lang="en-US" sz="1300" dirty="0"/>
+          </a:p>
+        </p:txBody>
+      </p:sp>
+      <p:sp>
+        <p:nvSpPr>
+          <p:cNvPr id="15" name="Text 12"/>
+          <p:cNvSpPr txBox="1"/>
+          <p:nvPr/>
+        </p:nvSpPr>
+        <p:spPr>
+          <a:xfrm>
+            <a:off x="4023360" y="2286000"/>
+            <a:ext cx="4663440" cy="530352"/>
+          </a:xfrm>
+          <a:prstGeom prst="rect">
+            <a:avLst/>
+          </a:prstGeom>
+          <a:noFill/>
+          <a:ln/>
+        </p:spPr>
+        <p:txBody>
+          <a:bodyPr wrap="square" lIns="0" tIns="0" rIns="0" bIns="0" rtlCol="0" anchor="ctr"/>
+          <a:lstStyle/>
+          <a:p>
+            <a:pPr indent="0" marL="0">
+              <a:buNone/>
+            </a:pPr>
+            <a:r>
+              <a:rPr lang="en-US" sz="1300" b="1" dirty="0">
+                <a:solidFill>
+                  <a:schemeClr val="tx1"/>
+                </a:solidFill>
+              </a:rPr>
+              <a:t>Record the lost reason and source on every call</a:t>
+            </a:r>
+            <a:endParaRPr lang="en-US" sz="1300" dirty="0"/>
+          </a:p>
+        </p:txBody>
+      </p:sp>
+      <p:sp>
+        <p:nvSpPr>
+          <p:cNvPr id="16" name="step 3"/>
+          <p:cNvSpPr/>
+          <p:nvPr/>
+        </p:nvSpPr>
+        <p:spPr>
+          <a:xfrm>
+            <a:off x="3474720" y="3017520"/>
+            <a:ext cx="384048" cy="384048"/>
+          </a:xfrm>
+          <a:prstGeom prst="ellipse">
+            <a:avLst/>
+          </a:prstGeom>
+          <a:solidFill>
+            <a:schemeClr val="accent1"/>
+          </a:solidFill>
+          <a:ln/>
+        </p:spPr>
+      </p:sp>
+      <p:sp>
+        <p:nvSpPr>
+          <p:cNvPr id="17" name="Text 14"/>
+          <p:cNvSpPr txBox="1"/>
+          <p:nvPr/>
+        </p:nvSpPr>
+        <p:spPr>
+          <a:xfrm>
+            <a:off x="3474720" y="3017520"/>
+            <a:ext cx="384048" cy="384048"/>
+          </a:xfrm>
+          <a:prstGeom prst="rect">
+            <a:avLst/>
+          </a:prstGeom>
+          <a:noFill/>
+          <a:ln/>
+        </p:spPr>
+        <p:txBody>
+          <a:bodyPr wrap="square" lIns="0" tIns="0" rIns="0" bIns="0" rtlCol="0" anchor="ctr"/>
+          <a:lstStyle/>
+          <a:p>
+            <a:pPr algn="ctr" indent="0" marL="0">
+              <a:buNone/>
+            </a:pPr>
+            <a:r>
+              <a:rPr lang="en-US" sz="1300" b="1" dirty="0">
+                <a:solidFill>
+                  <a:schemeClr val="bg1"/>
+                </a:solidFill>
+              </a:rPr>
+              <a:t>3</a:t>
+            </a:r>
+            <a:endParaRPr lang="en-US" sz="1300" dirty="0"/>
+          </a:p>
+        </p:txBody>
+      </p:sp>
+      <p:sp>
+        <p:nvSpPr>
+          <p:cNvPr id="18" name="Text 15"/>
+          <p:cNvSpPr txBox="1"/>
+          <p:nvPr/>
+        </p:nvSpPr>
+        <p:spPr>
+          <a:xfrm>
+            <a:off x="4023360" y="2944368"/>
+            <a:ext cx="4663440" cy="530352"/>
+          </a:xfrm>
+          <a:prstGeom prst="rect">
+            <a:avLst/>
+          </a:prstGeom>
+          <a:noFill/>
+          <a:ln/>
+        </p:spPr>
+        <p:txBody>
+          <a:bodyPr wrap="square" lIns="0" tIns="0" rIns="0" bIns="0" rtlCol="0" anchor="ctr"/>
+          <a:lstStyle/>
+          <a:p>
+            <a:pPr indent="0" marL="0">
+              <a:buNone/>
+            </a:pPr>
+            <a:r>
+              <a:rPr lang="en-US" sz="1300" b="1" dirty="0">
+                <a:solidFill>
+                  <a:schemeClr val="tx1"/>
+                </a:solidFill>
+              </a:rPr>
+              <a:t>Share a monthly Sales Intelligence report + win/loss review</a:t>
+            </a:r>
+            <a:endParaRPr lang="en-US" sz="1300" dirty="0"/>
+          </a:p>
+        </p:txBody>
+      </p:sp>
+      <p:sp>
+        <p:nvSpPr>
+          <p:cNvPr id="19" name="Text 16"/>
+          <p:cNvSpPr txBox="1"/>
+          <p:nvPr/>
+        </p:nvSpPr>
+        <p:spPr>
+          <a:xfrm>
+            <a:off x="457200" y="3703320"/>
+            <a:ext cx="3657600" cy="228600"/>
+          </a:xfrm>
+          <a:prstGeom prst="rect">
+            <a:avLst/>
+          </a:prstGeom>
+          <a:noFill/>
+          <a:ln/>
+        </p:spPr>
+        <p:txBody>
+          <a:bodyPr wrap="square" lIns="0" tIns="0" rIns="0" bIns="0" rtlCol="0" anchor="ctr"/>
+          <a:lstStyle/>
+          <a:p>
+            <a:pPr indent="0" marL="0">
+              <a:buNone/>
+            </a:pPr>
+            <a:r>
+              <a:rPr lang="en-US" sz="1000" b="1" spc="100" kern="0" dirty="0">
+                <a:solidFill>
+                  <a:schemeClr val="accent5"/>
+                </a:solidFill>
+              </a:rPr>
+              <a:t>HOW WE'LL MEASURE</a:t>
+            </a:r>
+            <a:endParaRPr lang="en-US" sz="1000" dirty="0"/>
+          </a:p>
+        </p:txBody>
+      </p:sp>
+      <p:sp>
+        <p:nvSpPr>
+          <p:cNvPr id="20" name="measure 1"/>
+          <p:cNvSpPr/>
+          <p:nvPr/>
+        </p:nvSpPr>
+        <p:spPr>
+          <a:xfrm>
+            <a:off x="457200" y="3977640"/>
+            <a:ext cx="2590800" cy="658368"/>
+          </a:xfrm>
+          <a:prstGeom prst="roundRect">
+            <a:avLst>
+              <a:gd name="adj" fmla="val 11111"/>
+            </a:avLst>
+          </a:prstGeom>
+          <a:solidFill>
+            <a:schemeClr val="accent4"/>
+          </a:solidFill>
+          <a:ln/>
+        </p:spPr>
+      </p:sp>
+      <p:sp>
+        <p:nvSpPr>
+          <p:cNvPr id="21" name="Text 18"/>
+          <p:cNvSpPr txBox="1"/>
+          <p:nvPr/>
+        </p:nvSpPr>
+        <p:spPr>
+          <a:xfrm>
+            <a:off x="621792" y="3977640"/>
+            <a:ext cx="2316480" cy="658368"/>
+          </a:xfrm>
+          <a:prstGeom prst="rect">
+            <a:avLst/>
+          </a:prstGeom>
+          <a:noFill/>
+          <a:ln/>
+        </p:spPr>
+        <p:txBody>
+          <a:bodyPr wrap="square" lIns="0" tIns="0" rIns="0" bIns="0" rtlCol="0" anchor="ctr"/>
+          <a:lstStyle/>
+          <a:p>
+            <a:pPr indent="0" marL="0">
+              <a:buNone/>
+            </a:pPr>
+            <a:r>
+              <a:rPr lang="en-US" sz="1100" b="1" dirty="0">
+                <a:solidFill>
+                  <a:schemeClr val="tx1"/>
+                </a:solidFill>
+              </a:rPr>
+              <a:t>Lost reason recorded</a:t>
+            </a:r>
+            <a:endParaRPr lang="en-US" sz="1100" dirty="0"/>
+          </a:p>
+          <a:p>
+            <a:pPr indent="0" marL="0">
+              <a:buNone/>
+            </a:pPr>
+            <a:r>
+              <a:rPr lang="en-US" sz="1000" b="1" dirty="0">
+                <a:solidFill>
+                  <a:schemeClr val="accent5"/>
+                </a:solidFill>
+              </a:rPr>
+              <a:t>Now: </a:t>
+            </a:r>
+            <a:pPr indent="0" marL="0">
+              <a:buNone/>
+            </a:pPr>
+            <a:r>
+              <a:rPr lang="en-US" sz="1000" dirty="0">
+                <a:solidFill>
+                  <a:schemeClr val="accent3"/>
+                </a:solidFill>
+              </a:rPr>
+              <a:t>0% → aim 100%</a:t>
+            </a:r>
+            <a:endParaRPr lang="en-US" sz="1100" dirty="0"/>
+          </a:p>
+        </p:txBody>
+      </p:sp>
+      <p:sp>
+        <p:nvSpPr>
+          <p:cNvPr id="22" name="measure 2"/>
+          <p:cNvSpPr/>
+          <p:nvPr/>
+        </p:nvSpPr>
+        <p:spPr>
+          <a:xfrm>
+            <a:off x="3276600" y="3977640"/>
+            <a:ext cx="2590800" cy="658368"/>
+          </a:xfrm>
+          <a:prstGeom prst="roundRect">
+            <a:avLst>
+              <a:gd name="adj" fmla="val 11111"/>
+            </a:avLst>
+          </a:prstGeom>
+          <a:solidFill>
+            <a:schemeClr val="accent4"/>
+          </a:solidFill>
+          <a:ln/>
+        </p:spPr>
+      </p:sp>
+      <p:sp>
+        <p:nvSpPr>
+          <p:cNvPr id="23" name="Text 20"/>
+          <p:cNvSpPr txBox="1"/>
+          <p:nvPr/>
+        </p:nvSpPr>
+        <p:spPr>
+          <a:xfrm>
+            <a:off x="3441192" y="3977640"/>
+            <a:ext cx="2316480" cy="658368"/>
+          </a:xfrm>
+          <a:prstGeom prst="rect">
+            <a:avLst/>
+          </a:prstGeom>
+          <a:noFill/>
+          <a:ln/>
+        </p:spPr>
+        <p:txBody>
+          <a:bodyPr wrap="square" lIns="0" tIns="0" rIns="0" bIns="0" rtlCol="0" anchor="ctr"/>
+          <a:lstStyle/>
+          <a:p>
+            <a:pPr indent="0" marL="0">
+              <a:buNone/>
+            </a:pPr>
+            <a:r>
+              <a:rPr lang="en-US" sz="1100" b="1" dirty="0">
+                <a:solidFill>
+                  <a:schemeClr val="tx1"/>
+                </a:solidFill>
+              </a:rPr>
+              <a:t>Monthly report shared</a:t>
+            </a:r>
+            <a:endParaRPr lang="en-US" sz="1100" dirty="0"/>
+          </a:p>
+          <a:p>
+            <a:pPr indent="0" marL="0">
+              <a:buNone/>
+            </a:pPr>
+            <a:r>
+              <a:rPr lang="en-US" sz="1000" b="1" dirty="0">
+                <a:solidFill>
+                  <a:schemeClr val="accent5"/>
+                </a:solidFill>
+              </a:rPr>
+              <a:t>Now: </a:t>
+            </a:r>
+            <a:pPr indent="0" marL="0">
+              <a:buNone/>
+            </a:pPr>
+            <a:r>
+              <a:rPr lang="en-US" sz="1000" dirty="0">
+                <a:solidFill>
+                  <a:schemeClr val="accent3"/>
+                </a:solidFill>
+              </a:rPr>
+              <a:t>none → 3 of 3 months</a:t>
+            </a:r>
+            <a:endParaRPr lang="en-US" sz="1100" dirty="0"/>
+          </a:p>
+        </p:txBody>
+      </p:sp>
+      <p:sp>
+        <p:nvSpPr>
+          <p:cNvPr id="24" name="measure 3"/>
+          <p:cNvSpPr/>
+          <p:nvPr/>
+        </p:nvSpPr>
+        <p:spPr>
+          <a:xfrm>
+            <a:off x="6096000" y="3977640"/>
+            <a:ext cx="2590800" cy="658368"/>
+          </a:xfrm>
+          <a:prstGeom prst="roundRect">
+            <a:avLst>
+              <a:gd name="adj" fmla="val 11111"/>
+            </a:avLst>
+          </a:prstGeom>
+          <a:solidFill>
+            <a:schemeClr val="accent4"/>
+          </a:solidFill>
+          <a:ln/>
+        </p:spPr>
+      </p:sp>
+      <p:sp>
+        <p:nvSpPr>
+          <p:cNvPr id="25" name="Text 22"/>
+          <p:cNvSpPr txBox="1"/>
+          <p:nvPr/>
+        </p:nvSpPr>
+        <p:spPr>
+          <a:xfrm>
+            <a:off x="6260592" y="3977640"/>
+            <a:ext cx="2316480" cy="658368"/>
+          </a:xfrm>
+          <a:prstGeom prst="rect">
+            <a:avLst/>
+          </a:prstGeom>
+          <a:noFill/>
+          <a:ln/>
+        </p:spPr>
+        <p:txBody>
+          <a:bodyPr wrap="square" lIns="0" tIns="0" rIns="0" bIns="0" rtlCol="0" anchor="ctr"/>
+          <a:lstStyle/>
+          <a:p>
+            <a:pPr indent="0" marL="0">
+              <a:buNone/>
+            </a:pPr>
+            <a:r>
+              <a:rPr lang="en-US" sz="1100" b="1" dirty="0">
+                <a:solidFill>
+                  <a:schemeClr val="tx1"/>
+                </a:solidFill>
+              </a:rPr>
+              <a:t>Sales dashboard live</a:t>
+            </a:r>
+            <a:endParaRPr lang="en-US" sz="1100" dirty="0"/>
+          </a:p>
+          <a:p>
+            <a:pPr indent="0" marL="0">
+              <a:buNone/>
+            </a:pPr>
+            <a:r>
+              <a:rPr lang="en-US" sz="1000" b="1" dirty="0">
+                <a:solidFill>
+                  <a:schemeClr val="accent5"/>
+                </a:solidFill>
+              </a:rPr>
+              <a:t>Now: </a:t>
+            </a:r>
+            <a:pPr indent="0" marL="0">
+              <a:buNone/>
+            </a:pPr>
+            <a:r>
+              <a:rPr lang="en-US" sz="1000" dirty="0">
+                <a:solidFill>
+                  <a:schemeClr val="accent3"/>
+                </a:solidFill>
+              </a:rPr>
+              <a:t>in progress</a:t>
+            </a:r>
+            <a:endParaRPr lang="en-US" sz="1100" dirty="0"/>
+          </a:p>
+        </p:txBody>
+      </p:sp>
+      <p:sp>
+        <p:nvSpPr>
+          <p:cNvPr id="25" name="Slide Number Placeholder 0"/>
+          <p:cNvSpPr>
+            <a:spLocks noGrp="1"/>
+          </p:cNvSpPr>
+          <p:nvPr>
+            <p:ph type="sldNum" sz="quarter" idx="4294967295"/>
+          </p:nvPr>
+        </p:nvSpPr>
+        <p:spPr>
+          <a:xfrm>
+            <a:off x="8321040" y="4754880"/>
+            <a:ext cx="365760" cy="228600"/>
+          </a:xfrm>
+          <a:prstGeom prst="rect">
+            <a:avLst/>
+          </a:prstGeom>
+          <a:extLst>
+            <a:ext uri="{C572A759-6A51-4108-AA02-DFA0A04FC94B}">
+              <ma14:wrappingTextBoxFlag xmlns:ma14="http://schemas.microsoft.com/office/mac/drawingml/2011/main" val="0"/>
+            </a:ext>
+          </a:extLst>
+        </p:spPr>
+        <p:txBody>
+          <a:bodyPr/>
+          <a:lstStyle>
+            <a:lvl1pPr>
+              <a:defRPr sz="900">
+                <a:solidFill>
+                  <a:schemeClr val="accent3"/>
+                </a:solidFill>
+              </a:defRPr>
+            </a:lvl1pPr>
+          </a:lstStyle>
+          <a:p>
+            <a:pPr algn="r"/>
+            <a:fld id="{F7021451-1387-4CA6-816F-3879F97B5CBC}" type="slidenum">
+              <a:rPr b="0" lang="en-US"/>
+              <a:t>12</a:t>
+            </a:fld>
+            <a:endParaRPr lang="en-US"/>
+          </a:p>
+        </p:txBody>
+      </p:sp>
+    </p:spTree>
+  </p:cSld>
+  <p:clrMapOvr>
+    <a:masterClrMapping/>
+  </p:clrMapOvr>
+</p:sld>
+</file>
+
 <file path=ppt/slides/slide2.xml><?xml version="1.0" encoding="utf-8"?>
 <p:sld xmlns:a="http://schemas.openxmlformats.org/drawingml/2006/main" xmlns:r="http://schemas.openxmlformats.org/officeDocument/2006/relationships" xmlns:p="http://schemas.openxmlformats.org/presentationml/2006/main">
   <p:cSld name="Slide 2">
@@ -2556,7 +5539,7 @@
                   <a:schemeClr val="accent1"/>
                 </a:solidFill>
               </a:rPr>
-              <a:t>1</a:t>
+              <a:t>2</a:t>
             </a:r>
             <a:endParaRPr lang="en-US" sz="4400" dirty="0"/>
           </a:p>
@@ -2592,7 +5575,7 @@
                   <a:schemeClr val="tx1"/>
                 </a:solidFill>
               </a:rPr>
-              <a:t>Lost client won back</a:t>
+              <a:t>Lost clients won back</a:t>
             </a:r>
             <a:endParaRPr lang="en-US" sz="1200" dirty="0"/>
           </a:p>
@@ -2628,7 +5611,7 @@
                   <a:schemeClr val="accent3"/>
                 </a:solidFill>
               </a:rPr>
-              <a:t>Andrew Owen, via lead reactivation</a:t>
+              <a:t>Anoushka Gungadin and Andrew Owen</a:t>
             </a:r>
             <a:endParaRPr lang="en-US" sz="1000" dirty="0"/>
           </a:p>
@@ -3509,7 +6492,7 @@
                   <a:schemeClr val="tx1"/>
                 </a:solidFill>
               </a:rPr>
-              <a:t>Daily habit now. 1 lost client won back, warm leads in pipeline</a:t>
+              <a:t>Daily habit now. 2 lost clients won back, warm leads in pipeline</a:t>
             </a:r>
             <a:endParaRPr lang="en-US" sz="1100" dirty="0"/>
           </a:p>
@@ -4483,7 +7466,7 @@
                   <a:schemeClr val="bg1"/>
                 </a:solidFill>
               </a:rPr>
-              <a:t>1</a:t>
+              <a:t>2</a:t>
             </a:r>
             <a:endParaRPr lang="en-US" sz="5400" dirty="0"/>
           </a:p>
@@ -4519,7 +7502,7 @@
                   <a:schemeClr val="bg1"/>
                 </a:solidFill>
               </a:rPr>
-              <a:t>lost client won back (Andrew Owen)</a:t>
+              <a:t>lost clients won back (Anoushka Gungadin, Andrew Owen)</a:t>
             </a:r>
             <a:endParaRPr lang="en-US" sz="1200" dirty="0"/>
           </a:p>
@@ -8216,7 +11199,7 @@
                   <a:schemeClr val="accent3"/>
                 </a:solidFill>
               </a:rPr>
-              <a:t>1 in Q2 (Andrew Owen)</a:t>
+              <a:t>2 in Q2 (Anoushka, Andrew)</a:t>
             </a:r>
             <a:endParaRPr lang="en-US" sz="1100" dirty="0"/>
           </a:p>
@@ -8629,6 +11612,851 @@
             <a:fld id="{F7021451-1387-4CA6-816F-3879F97B5CBC}" type="slidenum">
               <a:rPr b="0" lang="en-US"/>
               <a:t>8</a:t>
+            </a:fld>
+            <a:endParaRPr lang="en-US"/>
+          </a:p>
+        </p:txBody>
+      </p:sp>
+    </p:spTree>
+  </p:cSld>
+  <p:clrMapOvr>
+    <a:masterClrMapping/>
+  </p:clrMapOvr>
+</p:sld>
+</file>
+
+<file path=ppt/slides/slide9.xml><?xml version="1.0" encoding="utf-8"?>
+<p:sld xmlns:a="http://schemas.openxmlformats.org/drawingml/2006/main" xmlns:r="http://schemas.openxmlformats.org/officeDocument/2006/relationships" xmlns:p="http://schemas.openxmlformats.org/presentationml/2006/main">
+  <p:cSld name="Slide 9">
+    <p:spTree>
+      <p:nvGrpSpPr>
+        <p:cNvPr id="1" name=""/>
+        <p:cNvGrpSpPr/>
+        <p:nvPr/>
+      </p:nvGrpSpPr>
+      <p:grpSpPr>
+        <a:xfrm>
+          <a:off x="0" y="0"/>
+          <a:ext cx="0" cy="0"/>
+          <a:chOff x="0" y="0"/>
+          <a:chExt cx="0" cy="0"/>
+        </a:xfrm>
+      </p:grpSpPr>
+      <p:sp>
+        <p:nvSpPr>
+          <p:cNvPr id="2" name="Text 1"/>
+          <p:cNvSpPr/>
+          <p:nvPr>
+            <p:ph idx="101" type="body" hasCustomPrompt="1"/>
+          </p:nvPr>
+        </p:nvSpPr>
+        <p:spPr>
+          <a:xfrm>
+            <a:off x="457200" y="320040"/>
+            <a:ext cx="8229600" cy="274320"/>
+          </a:xfrm>
+          <a:prstGeom prst="rect">
+            <a:avLst/>
+          </a:prstGeom>
+          <a:noFill/>
+          <a:ln/>
+        </p:spPr>
+        <p:txBody>
+          <a:bodyPr wrap="square" lIns="0" tIns="0" rIns="0" bIns="0" rtlCol="0" anchor="ctr"/>
+          <a:lstStyle/>
+          <a:p>
+            <a:pPr indent="0" marL="0">
+              <a:buNone/>
+            </a:pPr>
+            <a:r>
+              <a:rPr lang="en-US" sz="1100" b="1" spc="200" kern="0" dirty="0">
+                <a:solidFill>
+                  <a:schemeClr val="accent5"/>
+                </a:solidFill>
+              </a:rPr>
+              <a:t>Q3 ROCKS  ·  OCTOBER–DECEMBER</a:t>
+            </a:r>
+            <a:endParaRPr lang="en-US" sz="1100" dirty="0"/>
+          </a:p>
+        </p:txBody>
+      </p:sp>
+      <p:sp>
+        <p:nvSpPr>
+          <p:cNvPr id="3" name="Text 1"/>
+          <p:cNvSpPr/>
+          <p:nvPr>
+            <p:ph idx="102" type="title" hasCustomPrompt="1"/>
+          </p:nvPr>
+        </p:nvSpPr>
+        <p:spPr>
+          <a:xfrm>
+            <a:off x="457200" y="594360"/>
+            <a:ext cx="8229600" cy="548640"/>
+          </a:xfrm>
+          <a:prstGeom prst="rect">
+            <a:avLst/>
+          </a:prstGeom>
+          <a:noFill/>
+          <a:ln/>
+        </p:spPr>
+        <p:txBody>
+          <a:bodyPr wrap="square" lIns="0" tIns="0" rIns="0" bIns="0" rtlCol="0" anchor="ctr"/>
+          <a:lstStyle/>
+          <a:p>
+            <a:pPr algn="l" indent="0" marL="0">
+              <a:buNone/>
+            </a:pPr>
+            <a:r>
+              <a:rPr lang="en-US" sz="2600" b="1" dirty="0">
+                <a:solidFill>
+                  <a:schemeClr val="tx1"/>
+                </a:solidFill>
+              </a:rPr>
+              <a:t>Our 3 Rocks for next quarter</a:t>
+            </a:r>
+            <a:endParaRPr lang="en-US" sz="2600" dirty="0"/>
+          </a:p>
+        </p:txBody>
+      </p:sp>
+      <p:sp>
+        <p:nvSpPr>
+          <p:cNvPr id="5" name="rock card 01"/>
+          <p:cNvSpPr/>
+          <p:nvPr/>
+        </p:nvSpPr>
+        <p:spPr>
+          <a:xfrm>
+            <a:off x="457200" y="1371600"/>
+            <a:ext cx="2590800" cy="2377440"/>
+          </a:xfrm>
+          <a:prstGeom prst="roundRect">
+            <a:avLst>
+              <a:gd name="adj" fmla="val 3077"/>
+            </a:avLst>
+          </a:prstGeom>
+          <a:solidFill>
+            <a:schemeClr val="bg2"/>
+          </a:solidFill>
+          <a:ln/>
+        </p:spPr>
+      </p:sp>
+      <p:sp>
+        <p:nvSpPr>
+          <p:cNvPr id="6" name="rock icon 01 circle"/>
+          <p:cNvSpPr/>
+          <p:nvPr/>
+        </p:nvSpPr>
+        <p:spPr>
+          <a:xfrm>
+            <a:off x="685800" y="1600200"/>
+            <a:ext cx="502920" cy="502920"/>
+          </a:xfrm>
+          <a:prstGeom prst="ellipse">
+            <a:avLst/>
+          </a:prstGeom>
+          <a:solidFill>
+            <a:schemeClr val="accent1"/>
+          </a:solidFill>
+          <a:ln/>
+        </p:spPr>
+      </p:sp>
+      <p:pic>
+        <p:nvPicPr>
+          <p:cNvPr id="7" name="rock icon 01" descr="rock icon 01">    </p:cNvPr>
+          <p:cNvPicPr>
+            <a:picLocks noChangeAspect="1"/>
+          </p:cNvPicPr>
+          <p:nvPr/>
+        </p:nvPicPr>
+        <p:blipFill>
+          <a:blip r:embed="rId1"/>
+          <a:stretch>
+            <a:fillRect/>
+          </a:stretch>
+        </p:blipFill>
+        <p:spPr>
+          <a:xfrm>
+            <a:off x="811530" y="1725930"/>
+            <a:ext cx="251460" cy="251460"/>
+          </a:xfrm>
+          <a:prstGeom prst="rect">
+            <a:avLst/>
+          </a:prstGeom>
+        </p:spPr>
+      </p:pic>
+      <p:sp>
+        <p:nvSpPr>
+          <p:cNvPr id="8" name="Text 4"/>
+          <p:cNvSpPr txBox="1"/>
+          <p:nvPr/>
+        </p:nvSpPr>
+        <p:spPr>
+          <a:xfrm>
+            <a:off x="1325880" y="1645920"/>
+            <a:ext cx="1584960" cy="411480"/>
+          </a:xfrm>
+          <a:prstGeom prst="rect">
+            <a:avLst/>
+          </a:prstGeom>
+          <a:noFill/>
+          <a:ln/>
+        </p:spPr>
+        <p:txBody>
+          <a:bodyPr wrap="square" lIns="0" tIns="0" rIns="0" bIns="0" rtlCol="0" anchor="ctr"/>
+          <a:lstStyle/>
+          <a:p>
+            <a:pPr indent="0" marL="0">
+              <a:buNone/>
+            </a:pPr>
+            <a:r>
+              <a:rPr lang="en-US" sz="1100" b="1" spc="200" kern="0" dirty="0">
+                <a:solidFill>
+                  <a:schemeClr val="accent5"/>
+                </a:solidFill>
+              </a:rPr>
+              <a:t>ROCK 01</a:t>
+            </a:r>
+            <a:endParaRPr lang="en-US" sz="1100" dirty="0"/>
+          </a:p>
+        </p:txBody>
+      </p:sp>
+      <p:sp>
+        <p:nvSpPr>
+          <p:cNvPr id="9" name="Text 5"/>
+          <p:cNvSpPr txBox="1"/>
+          <p:nvPr/>
+        </p:nvSpPr>
+        <p:spPr>
+          <a:xfrm>
+            <a:off x="685800" y="2240280"/>
+            <a:ext cx="2179320" cy="457200"/>
+          </a:xfrm>
+          <a:prstGeom prst="rect">
+            <a:avLst/>
+          </a:prstGeom>
+          <a:noFill/>
+          <a:ln/>
+        </p:spPr>
+        <p:txBody>
+          <a:bodyPr wrap="square" lIns="0" tIns="0" rIns="0" bIns="0" rtlCol="0" anchor="t"/>
+          <a:lstStyle/>
+          <a:p>
+            <a:pPr indent="0" marL="0">
+              <a:buNone/>
+            </a:pPr>
+            <a:r>
+              <a:rPr lang="en-US" sz="1800" b="1" dirty="0">
+                <a:solidFill>
+                  <a:schemeClr val="tx1"/>
+                </a:solidFill>
+              </a:rPr>
+              <a:t>Fill the pipeline</a:t>
+            </a:r>
+            <a:endParaRPr lang="en-US" sz="1800" dirty="0"/>
+          </a:p>
+        </p:txBody>
+      </p:sp>
+      <p:sp>
+        <p:nvSpPr>
+          <p:cNvPr id="10" name="Text 6"/>
+          <p:cNvSpPr txBox="1"/>
+          <p:nvPr/>
+        </p:nvSpPr>
+        <p:spPr>
+          <a:xfrm>
+            <a:off x="685800" y="2743200"/>
+            <a:ext cx="2179320" cy="548640"/>
+          </a:xfrm>
+          <a:prstGeom prst="rect">
+            <a:avLst/>
+          </a:prstGeom>
+          <a:noFill/>
+          <a:ln/>
+        </p:spPr>
+        <p:txBody>
+          <a:bodyPr wrap="square" lIns="0" tIns="0" rIns="0" bIns="0" rtlCol="0" anchor="t"/>
+          <a:lstStyle/>
+          <a:p>
+            <a:pPr indent="0" marL="0">
+              <a:buNone/>
+            </a:pPr>
+            <a:r>
+              <a:rPr lang="en-US" sz="1200" dirty="0">
+                <a:solidFill>
+                  <a:schemeClr val="accent3"/>
+                </a:solidFill>
+              </a:rPr>
+              <a:t>More qualified Freedom Audits, fewer no-shows</a:t>
+            </a:r>
+            <a:endParaRPr lang="en-US" sz="1200" dirty="0"/>
+          </a:p>
+        </p:txBody>
+      </p:sp>
+      <p:sp>
+        <p:nvSpPr>
+          <p:cNvPr id="11" name="Text 7"/>
+          <p:cNvSpPr txBox="1"/>
+          <p:nvPr/>
+        </p:nvSpPr>
+        <p:spPr>
+          <a:xfrm>
+            <a:off x="685800" y="3337560"/>
+            <a:ext cx="2179320" cy="274320"/>
+          </a:xfrm>
+          <a:prstGeom prst="rect">
+            <a:avLst/>
+          </a:prstGeom>
+          <a:noFill/>
+          <a:ln/>
+        </p:spPr>
+        <p:txBody>
+          <a:bodyPr wrap="square" lIns="0" tIns="0" rIns="0" bIns="0" rtlCol="0" anchor="ctr"/>
+          <a:lstStyle/>
+          <a:p>
+            <a:pPr indent="0" marL="0">
+              <a:buNone/>
+            </a:pPr>
+            <a:r>
+              <a:rPr lang="en-US" sz="1000" b="1" dirty="0">
+                <a:solidFill>
+                  <a:schemeClr val="accent5"/>
+                </a:solidFill>
+              </a:rPr>
+              <a:t>Builds on Rock 1</a:t>
+            </a:r>
+            <a:endParaRPr lang="en-US" sz="1000" dirty="0"/>
+          </a:p>
+        </p:txBody>
+      </p:sp>
+      <p:sp>
+        <p:nvSpPr>
+          <p:cNvPr id="12" name="rock card 02"/>
+          <p:cNvSpPr/>
+          <p:nvPr/>
+        </p:nvSpPr>
+        <p:spPr>
+          <a:xfrm>
+            <a:off x="3276600" y="1371600"/>
+            <a:ext cx="2590800" cy="2377440"/>
+          </a:xfrm>
+          <a:prstGeom prst="roundRect">
+            <a:avLst>
+              <a:gd name="adj" fmla="val 3077"/>
+            </a:avLst>
+          </a:prstGeom>
+          <a:solidFill>
+            <a:schemeClr val="bg2"/>
+          </a:solidFill>
+          <a:ln/>
+        </p:spPr>
+      </p:sp>
+      <p:sp>
+        <p:nvSpPr>
+          <p:cNvPr id="13" name="rock icon 02 circle"/>
+          <p:cNvSpPr/>
+          <p:nvPr/>
+        </p:nvSpPr>
+        <p:spPr>
+          <a:xfrm>
+            <a:off x="3505200" y="1600200"/>
+            <a:ext cx="502920" cy="502920"/>
+          </a:xfrm>
+          <a:prstGeom prst="ellipse">
+            <a:avLst/>
+          </a:prstGeom>
+          <a:solidFill>
+            <a:schemeClr val="accent1"/>
+          </a:solidFill>
+          <a:ln/>
+        </p:spPr>
+      </p:sp>
+      <p:pic>
+        <p:nvPicPr>
+          <p:cNvPr id="14" name="rock icon 02" descr="rock icon 02">    </p:cNvPr>
+          <p:cNvPicPr>
+            <a:picLocks noChangeAspect="1"/>
+          </p:cNvPicPr>
+          <p:nvPr/>
+        </p:nvPicPr>
+        <p:blipFill>
+          <a:blip r:embed="rId2"/>
+          <a:stretch>
+            <a:fillRect/>
+          </a:stretch>
+        </p:blipFill>
+        <p:spPr>
+          <a:xfrm>
+            <a:off x="3630930" y="1725930"/>
+            <a:ext cx="251460" cy="251460"/>
+          </a:xfrm>
+          <a:prstGeom prst="rect">
+            <a:avLst/>
+          </a:prstGeom>
+        </p:spPr>
+      </p:pic>
+      <p:sp>
+        <p:nvSpPr>
+          <p:cNvPr id="15" name="Text 10"/>
+          <p:cNvSpPr txBox="1"/>
+          <p:nvPr/>
+        </p:nvSpPr>
+        <p:spPr>
+          <a:xfrm>
+            <a:off x="4145280" y="1645920"/>
+            <a:ext cx="1584960" cy="411480"/>
+          </a:xfrm>
+          <a:prstGeom prst="rect">
+            <a:avLst/>
+          </a:prstGeom>
+          <a:noFill/>
+          <a:ln/>
+        </p:spPr>
+        <p:txBody>
+          <a:bodyPr wrap="square" lIns="0" tIns="0" rIns="0" bIns="0" rtlCol="0" anchor="ctr"/>
+          <a:lstStyle/>
+          <a:p>
+            <a:pPr indent="0" marL="0">
+              <a:buNone/>
+            </a:pPr>
+            <a:r>
+              <a:rPr lang="en-US" sz="1100" b="1" spc="200" kern="0" dirty="0">
+                <a:solidFill>
+                  <a:schemeClr val="accent5"/>
+                </a:solidFill>
+              </a:rPr>
+              <a:t>ROCK 02</a:t>
+            </a:r>
+            <a:endParaRPr lang="en-US" sz="1100" dirty="0"/>
+          </a:p>
+        </p:txBody>
+      </p:sp>
+      <p:sp>
+        <p:nvSpPr>
+          <p:cNvPr id="16" name="Text 11"/>
+          <p:cNvSpPr txBox="1"/>
+          <p:nvPr/>
+        </p:nvSpPr>
+        <p:spPr>
+          <a:xfrm>
+            <a:off x="3505200" y="2240280"/>
+            <a:ext cx="2179320" cy="457200"/>
+          </a:xfrm>
+          <a:prstGeom prst="rect">
+            <a:avLst/>
+          </a:prstGeom>
+          <a:noFill/>
+          <a:ln/>
+        </p:spPr>
+        <p:txBody>
+          <a:bodyPr wrap="square" lIns="0" tIns="0" rIns="0" bIns="0" rtlCol="0" anchor="t"/>
+          <a:lstStyle/>
+          <a:p>
+            <a:pPr indent="0" marL="0">
+              <a:buNone/>
+            </a:pPr>
+            <a:r>
+              <a:rPr lang="en-US" sz="1800" b="1" dirty="0">
+                <a:solidFill>
+                  <a:schemeClr val="tx1"/>
+                </a:solidFill>
+              </a:rPr>
+              <a:t>Sell the full ladder</a:t>
+            </a:r>
+            <a:endParaRPr lang="en-US" sz="1800" dirty="0"/>
+          </a:p>
+        </p:txBody>
+      </p:sp>
+      <p:sp>
+        <p:nvSpPr>
+          <p:cNvPr id="17" name="Text 12"/>
+          <p:cNvSpPr txBox="1"/>
+          <p:nvPr/>
+        </p:nvSpPr>
+        <p:spPr>
+          <a:xfrm>
+            <a:off x="3505200" y="2743200"/>
+            <a:ext cx="2179320" cy="548640"/>
+          </a:xfrm>
+          <a:prstGeom prst="rect">
+            <a:avLst/>
+          </a:prstGeom>
+          <a:noFill/>
+          <a:ln/>
+        </p:spPr>
+        <p:txBody>
+          <a:bodyPr wrap="square" lIns="0" tIns="0" rIns="0" bIns="0" rtlCol="0" anchor="t"/>
+          <a:lstStyle/>
+          <a:p>
+            <a:pPr indent="0" marL="0">
+              <a:buNone/>
+            </a:pPr>
+            <a:r>
+              <a:rPr lang="en-US" sz="1200" dirty="0">
+                <a:solidFill>
+                  <a:schemeClr val="accent3"/>
+                </a:solidFill>
+              </a:rPr>
+              <a:t>Every client finds the right next step</a:t>
+            </a:r>
+            <a:endParaRPr lang="en-US" sz="1200" dirty="0"/>
+          </a:p>
+        </p:txBody>
+      </p:sp>
+      <p:sp>
+        <p:nvSpPr>
+          <p:cNvPr id="18" name="Text 13"/>
+          <p:cNvSpPr txBox="1"/>
+          <p:nvPr/>
+        </p:nvSpPr>
+        <p:spPr>
+          <a:xfrm>
+            <a:off x="3505200" y="3337560"/>
+            <a:ext cx="2179320" cy="274320"/>
+          </a:xfrm>
+          <a:prstGeom prst="rect">
+            <a:avLst/>
+          </a:prstGeom>
+          <a:noFill/>
+          <a:ln/>
+        </p:spPr>
+        <p:txBody>
+          <a:bodyPr wrap="square" lIns="0" tIns="0" rIns="0" bIns="0" rtlCol="0" anchor="ctr"/>
+          <a:lstStyle/>
+          <a:p>
+            <a:pPr indent="0" marL="0">
+              <a:buNone/>
+            </a:pPr>
+            <a:r>
+              <a:rPr lang="en-US" sz="1000" b="1" dirty="0">
+                <a:solidFill>
+                  <a:schemeClr val="accent5"/>
+                </a:solidFill>
+              </a:rPr>
+              <a:t>Builds on Rock 2</a:t>
+            </a:r>
+            <a:endParaRPr lang="en-US" sz="1000" dirty="0"/>
+          </a:p>
+        </p:txBody>
+      </p:sp>
+      <p:sp>
+        <p:nvSpPr>
+          <p:cNvPr id="19" name="rock card 03"/>
+          <p:cNvSpPr/>
+          <p:nvPr/>
+        </p:nvSpPr>
+        <p:spPr>
+          <a:xfrm>
+            <a:off x="6096000" y="1371600"/>
+            <a:ext cx="2590800" cy="2377440"/>
+          </a:xfrm>
+          <a:prstGeom prst="roundRect">
+            <a:avLst>
+              <a:gd name="adj" fmla="val 3077"/>
+            </a:avLst>
+          </a:prstGeom>
+          <a:solidFill>
+            <a:schemeClr val="bg2"/>
+          </a:solidFill>
+          <a:ln/>
+        </p:spPr>
+      </p:sp>
+      <p:sp>
+        <p:nvSpPr>
+          <p:cNvPr id="20" name="rock icon 03 circle"/>
+          <p:cNvSpPr/>
+          <p:nvPr/>
+        </p:nvSpPr>
+        <p:spPr>
+          <a:xfrm>
+            <a:off x="6324600" y="1600200"/>
+            <a:ext cx="502920" cy="502920"/>
+          </a:xfrm>
+          <a:prstGeom prst="ellipse">
+            <a:avLst/>
+          </a:prstGeom>
+          <a:solidFill>
+            <a:schemeClr val="accent1"/>
+          </a:solidFill>
+          <a:ln/>
+        </p:spPr>
+      </p:sp>
+      <p:pic>
+        <p:nvPicPr>
+          <p:cNvPr id="21" name="rock icon 03" descr="rock icon 03">    </p:cNvPr>
+          <p:cNvPicPr>
+            <a:picLocks noChangeAspect="1"/>
+          </p:cNvPicPr>
+          <p:nvPr/>
+        </p:nvPicPr>
+        <p:blipFill>
+          <a:blip r:embed="rId3"/>
+          <a:stretch>
+            <a:fillRect/>
+          </a:stretch>
+        </p:blipFill>
+        <p:spPr>
+          <a:xfrm>
+            <a:off x="6450330" y="1725930"/>
+            <a:ext cx="251460" cy="251460"/>
+          </a:xfrm>
+          <a:prstGeom prst="rect">
+            <a:avLst/>
+          </a:prstGeom>
+        </p:spPr>
+      </p:pic>
+      <p:sp>
+        <p:nvSpPr>
+          <p:cNvPr id="22" name="Text 16"/>
+          <p:cNvSpPr txBox="1"/>
+          <p:nvPr/>
+        </p:nvSpPr>
+        <p:spPr>
+          <a:xfrm>
+            <a:off x="6964680" y="1645920"/>
+            <a:ext cx="1584960" cy="411480"/>
+          </a:xfrm>
+          <a:prstGeom prst="rect">
+            <a:avLst/>
+          </a:prstGeom>
+          <a:noFill/>
+          <a:ln/>
+        </p:spPr>
+        <p:txBody>
+          <a:bodyPr wrap="square" lIns="0" tIns="0" rIns="0" bIns="0" rtlCol="0" anchor="ctr"/>
+          <a:lstStyle/>
+          <a:p>
+            <a:pPr indent="0" marL="0">
+              <a:buNone/>
+            </a:pPr>
+            <a:r>
+              <a:rPr lang="en-US" sz="1100" b="1" spc="200" kern="0" dirty="0">
+                <a:solidFill>
+                  <a:schemeClr val="accent5"/>
+                </a:solidFill>
+              </a:rPr>
+              <a:t>ROCK 03</a:t>
+            </a:r>
+            <a:endParaRPr lang="en-US" sz="1100" dirty="0"/>
+          </a:p>
+        </p:txBody>
+      </p:sp>
+      <p:sp>
+        <p:nvSpPr>
+          <p:cNvPr id="23" name="Text 17"/>
+          <p:cNvSpPr txBox="1"/>
+          <p:nvPr/>
+        </p:nvSpPr>
+        <p:spPr>
+          <a:xfrm>
+            <a:off x="6324600" y="2240280"/>
+            <a:ext cx="2179320" cy="457200"/>
+          </a:xfrm>
+          <a:prstGeom prst="rect">
+            <a:avLst/>
+          </a:prstGeom>
+          <a:noFill/>
+          <a:ln/>
+        </p:spPr>
+        <p:txBody>
+          <a:bodyPr wrap="square" lIns="0" tIns="0" rIns="0" bIns="0" rtlCol="0" anchor="t"/>
+          <a:lstStyle/>
+          <a:p>
+            <a:pPr indent="0" marL="0">
+              <a:buNone/>
+            </a:pPr>
+            <a:r>
+              <a:rPr lang="en-US" sz="1800" b="1" dirty="0">
+                <a:solidFill>
+                  <a:schemeClr val="tx1"/>
+                </a:solidFill>
+              </a:rPr>
+              <a:t>See the numbers</a:t>
+            </a:r>
+            <a:endParaRPr lang="en-US" sz="1800" dirty="0"/>
+          </a:p>
+        </p:txBody>
+      </p:sp>
+      <p:sp>
+        <p:nvSpPr>
+          <p:cNvPr id="24" name="Text 18"/>
+          <p:cNvSpPr txBox="1"/>
+          <p:nvPr/>
+        </p:nvSpPr>
+        <p:spPr>
+          <a:xfrm>
+            <a:off x="6324600" y="2743200"/>
+            <a:ext cx="2179320" cy="548640"/>
+          </a:xfrm>
+          <a:prstGeom prst="rect">
+            <a:avLst/>
+          </a:prstGeom>
+          <a:noFill/>
+          <a:ln/>
+        </p:spPr>
+        <p:txBody>
+          <a:bodyPr wrap="square" lIns="0" tIns="0" rIns="0" bIns="0" rtlCol="0" anchor="t"/>
+          <a:lstStyle/>
+          <a:p>
+            <a:pPr indent="0" marL="0">
+              <a:buNone/>
+            </a:pPr>
+            <a:r>
+              <a:rPr lang="en-US" sz="1200" dirty="0">
+                <a:solidFill>
+                  <a:schemeClr val="accent3"/>
+                </a:solidFill>
+              </a:rPr>
+              <a:t>Sales data everyone can see and use</a:t>
+            </a:r>
+            <a:endParaRPr lang="en-US" sz="1200" dirty="0"/>
+          </a:p>
+        </p:txBody>
+      </p:sp>
+      <p:sp>
+        <p:nvSpPr>
+          <p:cNvPr id="25" name="Text 19"/>
+          <p:cNvSpPr txBox="1"/>
+          <p:nvPr/>
+        </p:nvSpPr>
+        <p:spPr>
+          <a:xfrm>
+            <a:off x="6324600" y="3337560"/>
+            <a:ext cx="2179320" cy="274320"/>
+          </a:xfrm>
+          <a:prstGeom prst="rect">
+            <a:avLst/>
+          </a:prstGeom>
+          <a:noFill/>
+          <a:ln/>
+        </p:spPr>
+        <p:txBody>
+          <a:bodyPr wrap="square" lIns="0" tIns="0" rIns="0" bIns="0" rtlCol="0" anchor="ctr"/>
+          <a:lstStyle/>
+          <a:p>
+            <a:pPr indent="0" marL="0">
+              <a:buNone/>
+            </a:pPr>
+            <a:r>
+              <a:rPr lang="en-US" sz="1000" b="1" dirty="0">
+                <a:solidFill>
+                  <a:schemeClr val="accent5"/>
+                </a:solidFill>
+              </a:rPr>
+              <a:t>Builds on Rock 3</a:t>
+            </a:r>
+            <a:endParaRPr lang="en-US" sz="1000" dirty="0"/>
+          </a:p>
+        </p:txBody>
+      </p:sp>
+      <p:sp>
+        <p:nvSpPr>
+          <p:cNvPr id="26" name="takeaway"/>
+          <p:cNvSpPr/>
+          <p:nvPr/>
+        </p:nvSpPr>
+        <p:spPr>
+          <a:xfrm>
+            <a:off x="457200" y="3977640"/>
+            <a:ext cx="8229600" cy="594360"/>
+          </a:xfrm>
+          <a:prstGeom prst="roundRect">
+            <a:avLst>
+              <a:gd name="adj" fmla="val 12308"/>
+            </a:avLst>
+          </a:prstGeom>
+          <a:solidFill>
+            <a:schemeClr val="accent5"/>
+          </a:solidFill>
+          <a:ln/>
+        </p:spPr>
+      </p:sp>
+      <p:sp>
+        <p:nvSpPr>
+          <p:cNvPr id="27" name="Text 21"/>
+          <p:cNvSpPr txBox="1"/>
+          <p:nvPr/>
+        </p:nvSpPr>
+        <p:spPr>
+          <a:xfrm>
+            <a:off x="731520" y="3977640"/>
+            <a:ext cx="7680960" cy="594360"/>
+          </a:xfrm>
+          <a:prstGeom prst="rect">
+            <a:avLst/>
+          </a:prstGeom>
+          <a:noFill/>
+          <a:ln/>
+        </p:spPr>
+        <p:txBody>
+          <a:bodyPr wrap="square" lIns="0" tIns="0" rIns="0" bIns="0" rtlCol="0" anchor="ctr"/>
+          <a:lstStyle/>
+          <a:p>
+            <a:pPr indent="0" marL="0">
+              <a:buNone/>
+            </a:pPr>
+            <a:r>
+              <a:rPr lang="en-US" sz="1100" b="1" spc="100" kern="0" dirty="0">
+                <a:solidFill>
+                  <a:schemeClr val="bg1"/>
+                </a:solidFill>
+              </a:rPr>
+              <a:t>THEME   </a:t>
+            </a:r>
+            <a:pPr indent="0" marL="0">
+              <a:buNone/>
+            </a:pPr>
+            <a:r>
+              <a:rPr lang="en-US" sz="1400" b="1" dirty="0">
+                <a:solidFill>
+                  <a:schemeClr val="bg1"/>
+                </a:solidFill>
+              </a:rPr>
+              <a:t>From Q2 wins to a repeatable sales rhythm.</a:t>
+            </a:r>
+            <a:endParaRPr lang="en-US" sz="1100" dirty="0"/>
+          </a:p>
+        </p:txBody>
+      </p:sp>
+      <p:sp>
+        <p:nvSpPr>
+          <p:cNvPr id="25" name="Slide Number Placeholder 0"/>
+          <p:cNvSpPr>
+            <a:spLocks noGrp="1"/>
+          </p:cNvSpPr>
+          <p:nvPr>
+            <p:ph type="sldNum" sz="quarter" idx="4294967295"/>
+          </p:nvPr>
+        </p:nvSpPr>
+        <p:spPr>
+          <a:xfrm>
+            <a:off x="8321040" y="4754880"/>
+            <a:ext cx="365760" cy="228600"/>
+          </a:xfrm>
+          <a:prstGeom prst="rect">
+            <a:avLst/>
+          </a:prstGeom>
+          <a:extLst>
+            <a:ext uri="{C572A759-6A51-4108-AA02-DFA0A04FC94B}">
+              <ma14:wrappingTextBoxFlag xmlns:ma14="http://schemas.microsoft.com/office/mac/drawingml/2011/main" val="0"/>
+            </a:ext>
+          </a:extLst>
+        </p:spPr>
+        <p:txBody>
+          <a:bodyPr/>
+          <a:lstStyle>
+            <a:lvl1pPr>
+              <a:defRPr sz="900">
+                <a:solidFill>
+                  <a:schemeClr val="accent3"/>
+                </a:solidFill>
+              </a:defRPr>
+            </a:lvl1pPr>
+          </a:lstStyle>
+          <a:p>
+            <a:pPr algn="r"/>
+            <a:fld id="{F7021451-1387-4CA6-816F-3879F97B5CBC}" type="slidenum">
+              <a:rPr b="0" lang="en-US"/>
+              <a:t>9</a:t>
             </a:fld>
             <a:endParaRPr lang="en-US"/>
           </a:p>

</xml_diff>